<commit_message>
Judge the tenor choice against realised noise on the risk-led slide
</commit_message>
<xml_diff>
--- a/JGB_2s10s_Steepener_Risk.pptx
+++ b/JGB_2s10s_Steepener_Risk.pptx
@@ -5095,48 +5095,6 @@
       </p:sp>
       <p:sp>
         <p:nvSpPr>
-          <p:cNvPr id="3" name="TextBox 2"/>
-          <p:cNvSpPr txBox="1"/>
-          <p:nvPr/>
-        </p:nvSpPr>
-        <p:spPr>
-          <a:xfrm>
-            <a:off x="8412480" y="347472"/>
-            <a:ext cx="3310128" cy="219456"/>
-          </a:xfrm>
-          <a:prstGeom prst="rect">
-            <a:avLst/>
-          </a:prstGeom>
-          <a:noFill/>
-        </p:spPr>
-        <p:txBody>
-          <a:bodyPr wrap="none" lIns="0" rIns="0" tIns="0" bIns="0" anchor="t">
-            <a:spAutoFit/>
-          </a:bodyPr>
-          <a:lstStyle/>
-          <a:p>
-            <a:pPr algn="r">
-              <a:lnSpc>
-                <a:spcPct val="100000"/>
-              </a:lnSpc>
-              <a:spcAft>
-                <a:spcPts val="0"/>
-              </a:spcAft>
-            </a:pPr>
-            <a:r>
-              <a:rPr sz="950" b="0" i="1">
-                <a:solidFill>
-                  <a:srgbClr val="767576"/>
-                </a:solidFill>
-                <a:latin typeface="Arial"/>
-              </a:rPr>
-              <a:t>Trade 2 of 3 · rates · 30% of the risk budget</a:t>
-            </a:r>
-          </a:p>
-        </p:txBody>
-      </p:sp>
-      <p:sp>
-        <p:nvSpPr>
           <p:cNvPr id="4" name="TextBox 3"/>
           <p:cNvSpPr txBox="1"/>
           <p:nvPr/>
@@ -5862,7 +5820,7 @@
                 </a:solidFill>
                 <a:latin typeface="Arial"/>
               </a:rPr>
-              <a:t>Exhibit 5. The same curve pays 30bp on 2s10s and 21bp on 2s30s, and only 2s30s needs a new record to do it</a:t>
+              <a:t>Exhibit 5. The whole 2s30s trade fits inside one quarter of its own noise. The 2s10s trade does not</a:t>
             </a:r>
           </a:p>
         </p:txBody>
@@ -5904,7 +5862,7 @@
                 </a:solidFill>
                 <a:latin typeface="Arial"/>
               </a:rPr>
-              <a:t>Move on our projected curve, bp of steepening from today</a:t>
+              <a:t>Trade plan vs one quarter of realised volatility, bp from today</a:t>
             </a:r>
           </a:p>
         </p:txBody>
@@ -6084,648 +6042,16 @@
           </a:fontRef>
         </p:style>
       </p:cxnSp>
-      <p:sp>
-        <p:nvSpPr>
-          <p:cNvPr id="28" name="Rectangle 27"/>
-          <p:cNvSpPr/>
-          <p:nvPr/>
-        </p:nvSpPr>
-        <p:spPr>
-          <a:xfrm>
-            <a:off x="5065775" y="2011680"/>
-            <a:ext cx="1577339" cy="201168"/>
-          </a:xfrm>
-          <a:prstGeom prst="rect">
-            <a:avLst/>
-          </a:prstGeom>
-          <a:solidFill>
-            <a:srgbClr val="F4B4BB"/>
-          </a:solidFill>
-          <a:ln>
-            <a:noFill/>
-          </a:ln>
-          <a:effectLst/>
-        </p:spPr>
-        <p:style>
-          <a:lnRef idx="1">
-            <a:schemeClr val="accent1"/>
-          </a:lnRef>
-          <a:fillRef idx="3">
-            <a:schemeClr val="accent1"/>
-          </a:fillRef>
-          <a:effectRef idx="2">
-            <a:schemeClr val="accent1"/>
-          </a:effectRef>
-          <a:fontRef idx="minor">
-            <a:schemeClr val="lt1"/>
-          </a:fontRef>
-        </p:style>
-        <p:txBody>
-          <a:bodyPr rtlCol="0" anchor="ctr"/>
-          <a:lstStyle/>
-          <a:p/>
-        </p:txBody>
-      </p:sp>
-      <p:sp>
-        <p:nvSpPr>
-          <p:cNvPr id="29" name="Rectangle 28"/>
-          <p:cNvSpPr/>
-          <p:nvPr/>
-        </p:nvSpPr>
-        <p:spPr>
-          <a:xfrm>
-            <a:off x="5065775" y="2011680"/>
-            <a:ext cx="210312" cy="201168"/>
-          </a:xfrm>
-          <a:prstGeom prst="rect">
-            <a:avLst/>
-          </a:prstGeom>
-          <a:solidFill>
-            <a:srgbClr val="6E747A"/>
-          </a:solidFill>
-          <a:ln>
-            <a:noFill/>
-          </a:ln>
-          <a:effectLst/>
-        </p:spPr>
-        <p:style>
-          <a:lnRef idx="1">
-            <a:schemeClr val="accent1"/>
-          </a:lnRef>
-          <a:fillRef idx="3">
-            <a:schemeClr val="accent1"/>
-          </a:fillRef>
-          <a:effectRef idx="2">
-            <a:schemeClr val="accent1"/>
-          </a:effectRef>
-          <a:fontRef idx="minor">
-            <a:schemeClr val="lt1"/>
-          </a:fontRef>
-        </p:style>
-        <p:txBody>
-          <a:bodyPr rtlCol="0" anchor="ctr"/>
-          <a:lstStyle/>
-          <a:p/>
-        </p:txBody>
-      </p:sp>
-      <p:sp>
-        <p:nvSpPr>
-          <p:cNvPr id="30" name="Rectangle 29"/>
-          <p:cNvSpPr/>
-          <p:nvPr/>
-        </p:nvSpPr>
-        <p:spPr>
-          <a:xfrm>
-            <a:off x="6921322" y="1947672"/>
-            <a:ext cx="21945" cy="329184"/>
-          </a:xfrm>
-          <a:prstGeom prst="rect">
-            <a:avLst/>
-          </a:prstGeom>
-          <a:solidFill>
-            <a:srgbClr val="000000"/>
-          </a:solidFill>
-          <a:ln>
-            <a:noFill/>
-          </a:ln>
-          <a:effectLst/>
-        </p:spPr>
-        <p:style>
-          <a:lnRef idx="1">
-            <a:schemeClr val="accent1"/>
-          </a:lnRef>
-          <a:fillRef idx="3">
-            <a:schemeClr val="accent1"/>
-          </a:fillRef>
-          <a:effectRef idx="2">
-            <a:schemeClr val="accent1"/>
-          </a:effectRef>
-          <a:fontRef idx="minor">
-            <a:schemeClr val="lt1"/>
-          </a:fontRef>
-        </p:style>
-        <p:txBody>
-          <a:bodyPr rtlCol="0" anchor="ctr"/>
-          <a:lstStyle/>
-          <a:p/>
-        </p:txBody>
-      </p:sp>
-      <p:sp>
-        <p:nvSpPr>
-          <p:cNvPr id="31" name="TextBox 30"/>
-          <p:cNvSpPr txBox="1"/>
-          <p:nvPr/>
-        </p:nvSpPr>
-        <p:spPr>
-          <a:xfrm>
-            <a:off x="6400800" y="1723644"/>
-            <a:ext cx="768096" cy="173736"/>
-          </a:xfrm>
-          <a:prstGeom prst="rect">
-            <a:avLst/>
-          </a:prstGeom>
-          <a:noFill/>
-        </p:spPr>
-        <p:txBody>
-          <a:bodyPr wrap="none" lIns="0" rIns="0" tIns="0" bIns="0" anchor="t">
-            <a:spAutoFit/>
-          </a:bodyPr>
-          <a:lstStyle/>
-          <a:p>
-            <a:pPr algn="ctr">
-              <a:lnSpc>
-                <a:spcPct val="100000"/>
-              </a:lnSpc>
-              <a:spcAft>
-                <a:spcPts val="0"/>
-              </a:spcAft>
-            </a:pPr>
-            <a:r>
-              <a:rPr sz="700" b="1" i="0">
-                <a:solidFill>
-                  <a:srgbClr val="000000"/>
-                </a:solidFill>
-                <a:latin typeface="Arial"/>
-              </a:rPr>
-              <a:t>165 record</a:t>
-            </a:r>
-          </a:p>
-        </p:txBody>
-      </p:sp>
-      <p:sp>
-        <p:nvSpPr>
-          <p:cNvPr id="32" name="TextBox 31"/>
-          <p:cNvSpPr txBox="1"/>
-          <p:nvPr/>
-        </p:nvSpPr>
-        <p:spPr>
-          <a:xfrm>
-            <a:off x="4133087" y="2007107"/>
-            <a:ext cx="877824" cy="210312"/>
-          </a:xfrm>
-          <a:prstGeom prst="rect">
-            <a:avLst/>
-          </a:prstGeom>
-          <a:noFill/>
-        </p:spPr>
-        <p:txBody>
-          <a:bodyPr wrap="none" lIns="0" rIns="0" tIns="0" bIns="0" anchor="t">
-            <a:spAutoFit/>
-          </a:bodyPr>
-          <a:lstStyle/>
-          <a:p>
-            <a:pPr algn="l">
-              <a:lnSpc>
-                <a:spcPct val="100000"/>
-              </a:lnSpc>
-              <a:spcAft>
-                <a:spcPts val="0"/>
-              </a:spcAft>
-            </a:pPr>
-            <a:r>
-              <a:rPr sz="1000" b="1" i="0">
-                <a:solidFill>
-                  <a:srgbClr val="DB0011"/>
-                </a:solidFill>
-                <a:latin typeface="Arial"/>
-              </a:rPr>
-              <a:t>JGB 2s10s</a:t>
-            </a:r>
-          </a:p>
-        </p:txBody>
-      </p:sp>
-      <p:sp>
-        <p:nvSpPr>
-          <p:cNvPr id="33" name="TextBox 32"/>
-          <p:cNvSpPr txBox="1"/>
-          <p:nvPr/>
-        </p:nvSpPr>
-        <p:spPr>
-          <a:xfrm>
-            <a:off x="7168896" y="1929384"/>
-            <a:ext cx="987552" cy="201168"/>
-          </a:xfrm>
-          <a:prstGeom prst="rect">
-            <a:avLst/>
-          </a:prstGeom>
-          <a:noFill/>
-        </p:spPr>
-        <p:txBody>
-          <a:bodyPr wrap="none" lIns="0" rIns="0" tIns="0" bIns="0" anchor="t">
-            <a:spAutoFit/>
-          </a:bodyPr>
-          <a:lstStyle/>
-          <a:p>
-            <a:pPr algn="r">
-              <a:lnSpc>
-                <a:spcPct val="100000"/>
-              </a:lnSpc>
-              <a:spcAft>
-                <a:spcPts val="0"/>
-              </a:spcAft>
-            </a:pPr>
-            <a:r>
-              <a:rPr sz="1050" b="1" i="0">
-                <a:solidFill>
-                  <a:srgbClr val="DB0011"/>
-                </a:solidFill>
-                <a:latin typeface="Arial"/>
-              </a:rPr>
-              <a:t>+30bp</a:t>
-            </a:r>
-          </a:p>
-        </p:txBody>
-      </p:sp>
-      <p:sp>
-        <p:nvSpPr>
-          <p:cNvPr id="34" name="TextBox 33"/>
-          <p:cNvSpPr txBox="1"/>
-          <p:nvPr/>
-        </p:nvSpPr>
-        <p:spPr>
-          <a:xfrm>
-            <a:off x="7168896" y="2139696"/>
-            <a:ext cx="987552" cy="164592"/>
-          </a:xfrm>
-          <a:prstGeom prst="rect">
-            <a:avLst/>
-          </a:prstGeom>
-          <a:noFill/>
-        </p:spPr>
-        <p:txBody>
-          <a:bodyPr wrap="none" lIns="0" rIns="0" tIns="0" bIns="0" anchor="t">
-            <a:spAutoFit/>
-          </a:bodyPr>
-          <a:lstStyle/>
-          <a:p>
-            <a:pPr algn="r">
-              <a:lnSpc>
-                <a:spcPct val="100000"/>
-              </a:lnSpc>
-              <a:spcAft>
-                <a:spcPts val="0"/>
-              </a:spcAft>
-            </a:pPr>
-            <a:r>
-              <a:rPr sz="750" b="0" i="0">
-                <a:solidFill>
-                  <a:srgbClr val="767576"/>
-                </a:solidFill>
-                <a:latin typeface="Arial"/>
-              </a:rPr>
-              <a:t>129 → 159bp</a:t>
-            </a:r>
-          </a:p>
-        </p:txBody>
-      </p:sp>
-      <p:sp>
-        <p:nvSpPr>
-          <p:cNvPr id="35" name="Rectangle 34"/>
-          <p:cNvSpPr/>
-          <p:nvPr/>
-        </p:nvSpPr>
-        <p:spPr>
-          <a:xfrm>
-            <a:off x="5065775" y="2688336"/>
-            <a:ext cx="646709" cy="201168"/>
-          </a:xfrm>
-          <a:prstGeom prst="rect">
-            <a:avLst/>
-          </a:prstGeom>
-          <a:solidFill>
-            <a:srgbClr val="F4B4BB"/>
-          </a:solidFill>
-          <a:ln>
-            <a:noFill/>
-          </a:ln>
-          <a:effectLst/>
-        </p:spPr>
-        <p:style>
-          <a:lnRef idx="1">
-            <a:schemeClr val="accent1"/>
-          </a:lnRef>
-          <a:fillRef idx="3">
-            <a:schemeClr val="accent1"/>
-          </a:fillRef>
-          <a:effectRef idx="2">
-            <a:schemeClr val="accent1"/>
-          </a:effectRef>
-          <a:fontRef idx="minor">
-            <a:schemeClr val="lt1"/>
-          </a:fontRef>
-        </p:style>
-        <p:txBody>
-          <a:bodyPr rtlCol="0" anchor="ctr"/>
-          <a:lstStyle/>
-          <a:p/>
-        </p:txBody>
-      </p:sp>
-      <p:sp>
-        <p:nvSpPr>
-          <p:cNvPr id="36" name="Rectangle 35"/>
-          <p:cNvSpPr/>
-          <p:nvPr/>
-        </p:nvSpPr>
-        <p:spPr>
-          <a:xfrm>
-            <a:off x="5712485" y="2688336"/>
-            <a:ext cx="457428" cy="201168"/>
-          </a:xfrm>
-          <a:prstGeom prst="rect">
-            <a:avLst/>
-          </a:prstGeom>
-          <a:solidFill>
-            <a:srgbClr val="FFFFFF"/>
-          </a:solidFill>
-          <a:ln w="9525">
-            <a:solidFill>
-              <a:srgbClr val="DB0011"/>
-            </a:solidFill>
-          </a:ln>
-          <a:effectLst/>
-        </p:spPr>
-        <p:style>
-          <a:lnRef idx="1">
-            <a:schemeClr val="accent1"/>
-          </a:lnRef>
-          <a:fillRef idx="3">
-            <a:schemeClr val="accent1"/>
-          </a:fillRef>
-          <a:effectRef idx="2">
-            <a:schemeClr val="accent1"/>
-          </a:effectRef>
-          <a:fontRef idx="minor">
-            <a:schemeClr val="lt1"/>
-          </a:fontRef>
-        </p:style>
-        <p:txBody>
-          <a:bodyPr rtlCol="0" anchor="ctr"/>
-          <a:lstStyle/>
-          <a:p/>
-        </p:txBody>
-      </p:sp>
-      <p:sp>
-        <p:nvSpPr>
-          <p:cNvPr id="37" name="Rectangle 36"/>
-          <p:cNvSpPr/>
-          <p:nvPr/>
-        </p:nvSpPr>
-        <p:spPr>
-          <a:xfrm>
-            <a:off x="5065775" y="2688336"/>
-            <a:ext cx="210312" cy="201168"/>
-          </a:xfrm>
-          <a:prstGeom prst="rect">
-            <a:avLst/>
-          </a:prstGeom>
-          <a:solidFill>
-            <a:srgbClr val="6E747A"/>
-          </a:solidFill>
-          <a:ln>
-            <a:noFill/>
-          </a:ln>
-          <a:effectLst/>
-        </p:spPr>
-        <p:style>
-          <a:lnRef idx="1">
-            <a:schemeClr val="accent1"/>
-          </a:lnRef>
-          <a:fillRef idx="3">
-            <a:schemeClr val="accent1"/>
-          </a:fillRef>
-          <a:effectRef idx="2">
-            <a:schemeClr val="accent1"/>
-          </a:effectRef>
-          <a:fontRef idx="minor">
-            <a:schemeClr val="lt1"/>
-          </a:fontRef>
-        </p:style>
-        <p:txBody>
-          <a:bodyPr rtlCol="0" anchor="ctr"/>
-          <a:lstStyle/>
-          <a:p/>
-        </p:txBody>
-      </p:sp>
-      <p:sp>
-        <p:nvSpPr>
-          <p:cNvPr id="38" name="Rectangle 37"/>
-          <p:cNvSpPr/>
-          <p:nvPr/>
-        </p:nvSpPr>
-        <p:spPr>
-          <a:xfrm>
-            <a:off x="5701512" y="2624327"/>
-            <a:ext cx="21945" cy="329184"/>
-          </a:xfrm>
-          <a:prstGeom prst="rect">
-            <a:avLst/>
-          </a:prstGeom>
-          <a:solidFill>
-            <a:srgbClr val="000000"/>
-          </a:solidFill>
-          <a:ln>
-            <a:noFill/>
-          </a:ln>
-          <a:effectLst/>
-        </p:spPr>
-        <p:style>
-          <a:lnRef idx="1">
-            <a:schemeClr val="accent1"/>
-          </a:lnRef>
-          <a:fillRef idx="3">
-            <a:schemeClr val="accent1"/>
-          </a:fillRef>
-          <a:effectRef idx="2">
-            <a:schemeClr val="accent1"/>
-          </a:effectRef>
-          <a:fontRef idx="minor">
-            <a:schemeClr val="lt1"/>
-          </a:fontRef>
-        </p:style>
-        <p:txBody>
-          <a:bodyPr rtlCol="0" anchor="ctr"/>
-          <a:lstStyle/>
-          <a:p/>
-        </p:txBody>
-      </p:sp>
-      <p:sp>
-        <p:nvSpPr>
-          <p:cNvPr id="39" name="TextBox 38"/>
-          <p:cNvSpPr txBox="1"/>
-          <p:nvPr/>
-        </p:nvSpPr>
-        <p:spPr>
-          <a:xfrm>
-            <a:off x="5328437" y="2400300"/>
-            <a:ext cx="768096" cy="173736"/>
-          </a:xfrm>
-          <a:prstGeom prst="rect">
-            <a:avLst/>
-          </a:prstGeom>
-          <a:noFill/>
-        </p:spPr>
-        <p:txBody>
-          <a:bodyPr wrap="none" lIns="0" rIns="0" tIns="0" bIns="0" anchor="t">
-            <a:spAutoFit/>
-          </a:bodyPr>
-          <a:lstStyle/>
-          <a:p>
-            <a:pPr algn="ctr">
-              <a:lnSpc>
-                <a:spcPct val="100000"/>
-              </a:lnSpc>
-              <a:spcAft>
-                <a:spcPts val="0"/>
-              </a:spcAft>
-            </a:pPr>
-            <a:r>
-              <a:rPr sz="700" b="1" i="0">
-                <a:solidFill>
-                  <a:srgbClr val="000000"/>
-                </a:solidFill>
-                <a:latin typeface="Arial"/>
-              </a:rPr>
-              <a:t>260 record</a:t>
-            </a:r>
-          </a:p>
-        </p:txBody>
-      </p:sp>
-      <p:sp>
-        <p:nvSpPr>
-          <p:cNvPr id="40" name="TextBox 39"/>
-          <p:cNvSpPr txBox="1"/>
-          <p:nvPr/>
-        </p:nvSpPr>
-        <p:spPr>
-          <a:xfrm>
-            <a:off x="4133087" y="2683763"/>
-            <a:ext cx="877824" cy="210312"/>
-          </a:xfrm>
-          <a:prstGeom prst="rect">
-            <a:avLst/>
-          </a:prstGeom>
-          <a:noFill/>
-        </p:spPr>
-        <p:txBody>
-          <a:bodyPr wrap="none" lIns="0" rIns="0" tIns="0" bIns="0" anchor="t">
-            <a:spAutoFit/>
-          </a:bodyPr>
-          <a:lstStyle/>
-          <a:p>
-            <a:pPr algn="l">
-              <a:lnSpc>
-                <a:spcPct val="100000"/>
-              </a:lnSpc>
-              <a:spcAft>
-                <a:spcPts val="0"/>
-              </a:spcAft>
-            </a:pPr>
-            <a:r>
-              <a:rPr sz="1000" b="1" i="0">
-                <a:solidFill>
-                  <a:srgbClr val="767576"/>
-                </a:solidFill>
-                <a:latin typeface="Arial"/>
-              </a:rPr>
-              <a:t>JGB 2s30s</a:t>
-            </a:r>
-          </a:p>
-        </p:txBody>
-      </p:sp>
-      <p:sp>
-        <p:nvSpPr>
-          <p:cNvPr id="41" name="TextBox 40"/>
-          <p:cNvSpPr txBox="1"/>
-          <p:nvPr/>
-        </p:nvSpPr>
-        <p:spPr>
-          <a:xfrm>
-            <a:off x="7168896" y="2606039"/>
-            <a:ext cx="987552" cy="201168"/>
-          </a:xfrm>
-          <a:prstGeom prst="rect">
-            <a:avLst/>
-          </a:prstGeom>
-          <a:noFill/>
-        </p:spPr>
-        <p:txBody>
-          <a:bodyPr wrap="none" lIns="0" rIns="0" tIns="0" bIns="0" anchor="t">
-            <a:spAutoFit/>
-          </a:bodyPr>
-          <a:lstStyle/>
-          <a:p>
-            <a:pPr algn="r">
-              <a:lnSpc>
-                <a:spcPct val="100000"/>
-              </a:lnSpc>
-              <a:spcAft>
-                <a:spcPts val="0"/>
-              </a:spcAft>
-            </a:pPr>
-            <a:r>
-              <a:rPr sz="1050" b="0" i="0">
-                <a:solidFill>
-                  <a:srgbClr val="767576"/>
-                </a:solidFill>
-                <a:latin typeface="Arial"/>
-              </a:rPr>
-              <a:t>+21bp</a:t>
-            </a:r>
-          </a:p>
-        </p:txBody>
-      </p:sp>
-      <p:sp>
-        <p:nvSpPr>
-          <p:cNvPr id="42" name="TextBox 41"/>
-          <p:cNvSpPr txBox="1"/>
-          <p:nvPr/>
-        </p:nvSpPr>
-        <p:spPr>
-          <a:xfrm>
-            <a:off x="7168896" y="2816351"/>
-            <a:ext cx="987552" cy="164592"/>
-          </a:xfrm>
-          <a:prstGeom prst="rect">
-            <a:avLst/>
-          </a:prstGeom>
-          <a:noFill/>
-        </p:spPr>
-        <p:txBody>
-          <a:bodyPr wrap="none" lIns="0" rIns="0" tIns="0" bIns="0" anchor="t">
-            <a:spAutoFit/>
-          </a:bodyPr>
-          <a:lstStyle/>
-          <a:p>
-            <a:pPr algn="r">
-              <a:lnSpc>
-                <a:spcPct val="100000"/>
-              </a:lnSpc>
-              <a:spcAft>
-                <a:spcPts val="0"/>
-              </a:spcAft>
-            </a:pPr>
-            <a:r>
-              <a:rPr sz="750" b="0" i="0">
-                <a:solidFill>
-                  <a:srgbClr val="767576"/>
-                </a:solidFill>
-                <a:latin typeface="Arial"/>
-              </a:rPr>
-              <a:t>248 → 268bp</a:t>
-            </a:r>
-          </a:p>
-        </p:txBody>
-      </p:sp>
       <p:cxnSp>
         <p:nvCxnSpPr>
-          <p:cNvPr id="43" name="Connector 42"/>
+          <p:cNvPr id="28" name="Connector 27"/>
           <p:cNvCxnSpPr/>
           <p:nvPr/>
         </p:nvCxnSpPr>
         <p:spPr>
           <a:xfrm>
-            <a:off x="5065775" y="3127248"/>
-            <a:ext cx="2103121" cy="0"/>
+            <a:off x="6117336" y="1773936"/>
+            <a:ext cx="0" cy="1353312"/>
           </a:xfrm>
           <a:prstGeom prst="line">
             <a:avLst/>
@@ -6753,230 +6079,20 @@
       </p:cxnSp>
       <p:sp>
         <p:nvSpPr>
-          <p:cNvPr id="44" name="TextBox 43"/>
-          <p:cNvSpPr txBox="1"/>
-          <p:nvPr/>
-        </p:nvSpPr>
-        <p:spPr>
-          <a:xfrm>
-            <a:off x="4791455" y="3163824"/>
-            <a:ext cx="548640" cy="164592"/>
-          </a:xfrm>
-          <a:prstGeom prst="rect">
-            <a:avLst/>
-          </a:prstGeom>
-          <a:noFill/>
-        </p:spPr>
-        <p:txBody>
-          <a:bodyPr wrap="none" lIns="0" rIns="0" tIns="0" bIns="0" anchor="t">
-            <a:spAutoFit/>
-          </a:bodyPr>
-          <a:lstStyle/>
-          <a:p>
-            <a:pPr algn="ctr">
-              <a:lnSpc>
-                <a:spcPct val="100000"/>
-              </a:lnSpc>
-              <a:spcAft>
-                <a:spcPts val="0"/>
-              </a:spcAft>
-            </a:pPr>
-            <a:r>
-              <a:rPr sz="800" b="0" i="0">
-                <a:solidFill>
-                  <a:srgbClr val="767576"/>
-                </a:solidFill>
-                <a:latin typeface="Arial"/>
-              </a:rPr>
-              <a:t>0</a:t>
-            </a:r>
-          </a:p>
-        </p:txBody>
-      </p:sp>
-      <p:sp>
-        <p:nvSpPr>
-          <p:cNvPr id="45" name="TextBox 44"/>
-          <p:cNvSpPr txBox="1"/>
-          <p:nvPr/>
-        </p:nvSpPr>
-        <p:spPr>
-          <a:xfrm>
-            <a:off x="5317236" y="3163824"/>
-            <a:ext cx="548640" cy="164592"/>
-          </a:xfrm>
-          <a:prstGeom prst="rect">
-            <a:avLst/>
-          </a:prstGeom>
-          <a:noFill/>
-        </p:spPr>
-        <p:txBody>
-          <a:bodyPr wrap="none" lIns="0" rIns="0" tIns="0" bIns="0" anchor="t">
-            <a:spAutoFit/>
-          </a:bodyPr>
-          <a:lstStyle/>
-          <a:p>
-            <a:pPr algn="ctr">
-              <a:lnSpc>
-                <a:spcPct val="100000"/>
-              </a:lnSpc>
-              <a:spcAft>
-                <a:spcPts val="0"/>
-              </a:spcAft>
-            </a:pPr>
-            <a:r>
-              <a:rPr sz="800" b="0" i="0">
-                <a:solidFill>
-                  <a:srgbClr val="767576"/>
-                </a:solidFill>
-                <a:latin typeface="Arial"/>
-              </a:rPr>
-              <a:t>+10</a:t>
-            </a:r>
-          </a:p>
-        </p:txBody>
-      </p:sp>
-      <p:sp>
-        <p:nvSpPr>
-          <p:cNvPr id="46" name="TextBox 45"/>
-          <p:cNvSpPr txBox="1"/>
-          <p:nvPr/>
-        </p:nvSpPr>
-        <p:spPr>
-          <a:xfrm>
-            <a:off x="5843016" y="3163824"/>
-            <a:ext cx="548640" cy="164592"/>
-          </a:xfrm>
-          <a:prstGeom prst="rect">
-            <a:avLst/>
-          </a:prstGeom>
-          <a:noFill/>
-        </p:spPr>
-        <p:txBody>
-          <a:bodyPr wrap="none" lIns="0" rIns="0" tIns="0" bIns="0" anchor="t">
-            <a:spAutoFit/>
-          </a:bodyPr>
-          <a:lstStyle/>
-          <a:p>
-            <a:pPr algn="ctr">
-              <a:lnSpc>
-                <a:spcPct val="100000"/>
-              </a:lnSpc>
-              <a:spcAft>
-                <a:spcPts val="0"/>
-              </a:spcAft>
-            </a:pPr>
-            <a:r>
-              <a:rPr sz="800" b="0" i="0">
-                <a:solidFill>
-                  <a:srgbClr val="767576"/>
-                </a:solidFill>
-                <a:latin typeface="Arial"/>
-              </a:rPr>
-              <a:t>+20</a:t>
-            </a:r>
-          </a:p>
-        </p:txBody>
-      </p:sp>
-      <p:sp>
-        <p:nvSpPr>
-          <p:cNvPr id="47" name="TextBox 46"/>
-          <p:cNvSpPr txBox="1"/>
-          <p:nvPr/>
-        </p:nvSpPr>
-        <p:spPr>
-          <a:xfrm>
-            <a:off x="6368795" y="3163824"/>
-            <a:ext cx="548640" cy="164592"/>
-          </a:xfrm>
-          <a:prstGeom prst="rect">
-            <a:avLst/>
-          </a:prstGeom>
-          <a:noFill/>
-        </p:spPr>
-        <p:txBody>
-          <a:bodyPr wrap="none" lIns="0" rIns="0" tIns="0" bIns="0" anchor="t">
-            <a:spAutoFit/>
-          </a:bodyPr>
-          <a:lstStyle/>
-          <a:p>
-            <a:pPr algn="ctr">
-              <a:lnSpc>
-                <a:spcPct val="100000"/>
-              </a:lnSpc>
-              <a:spcAft>
-                <a:spcPts val="0"/>
-              </a:spcAft>
-            </a:pPr>
-            <a:r>
-              <a:rPr sz="800" b="0" i="0">
-                <a:solidFill>
-                  <a:srgbClr val="767576"/>
-                </a:solidFill>
-                <a:latin typeface="Arial"/>
-              </a:rPr>
-              <a:t>+30</a:t>
-            </a:r>
-          </a:p>
-        </p:txBody>
-      </p:sp>
-      <p:sp>
-        <p:nvSpPr>
-          <p:cNvPr id="48" name="TextBox 47"/>
-          <p:cNvSpPr txBox="1"/>
-          <p:nvPr/>
-        </p:nvSpPr>
-        <p:spPr>
-          <a:xfrm>
-            <a:off x="6894576" y="3163824"/>
-            <a:ext cx="548640" cy="164592"/>
-          </a:xfrm>
-          <a:prstGeom prst="rect">
-            <a:avLst/>
-          </a:prstGeom>
-          <a:noFill/>
-        </p:spPr>
-        <p:txBody>
-          <a:bodyPr wrap="none" lIns="0" rIns="0" tIns="0" bIns="0" anchor="t">
-            <a:spAutoFit/>
-          </a:bodyPr>
-          <a:lstStyle/>
-          <a:p>
-            <a:pPr algn="ctr">
-              <a:lnSpc>
-                <a:spcPct val="100000"/>
-              </a:lnSpc>
-              <a:spcAft>
-                <a:spcPts val="0"/>
-              </a:spcAft>
-            </a:pPr>
-            <a:r>
-              <a:rPr sz="800" b="0" i="0">
-                <a:solidFill>
-                  <a:srgbClr val="767576"/>
-                </a:solidFill>
-                <a:latin typeface="Arial"/>
-              </a:rPr>
-              <a:t>+40</a:t>
-            </a:r>
-          </a:p>
-        </p:txBody>
-      </p:sp>
-      <p:sp>
-        <p:nvSpPr>
-          <p:cNvPr id="49" name="Rectangle 48"/>
+          <p:cNvPr id="29" name="Rectangle 28"/>
           <p:cNvSpPr/>
           <p:nvPr/>
         </p:nvSpPr>
         <p:spPr>
           <a:xfrm>
-            <a:off x="4133087" y="3387851"/>
-            <a:ext cx="182880" cy="100584"/>
+            <a:off x="5785043" y="1993392"/>
+            <a:ext cx="664585" cy="237744"/>
           </a:xfrm>
           <a:prstGeom prst="rect">
             <a:avLst/>
           </a:prstGeom>
           <a:solidFill>
-            <a:srgbClr val="6E747A"/>
+            <a:srgbClr val="D7D8D6"/>
           </a:solidFill>
           <a:ln>
             <a:noFill/>
@@ -7005,62 +6121,20 @@
       </p:sp>
       <p:sp>
         <p:nvSpPr>
-          <p:cNvPr id="50" name="TextBox 49"/>
-          <p:cNvSpPr txBox="1"/>
-          <p:nvPr/>
-        </p:nvSpPr>
-        <p:spPr>
-          <a:xfrm>
-            <a:off x="4370831" y="3346703"/>
-            <a:ext cx="1737360" cy="182880"/>
-          </a:xfrm>
-          <a:prstGeom prst="rect">
-            <a:avLst/>
-          </a:prstGeom>
-          <a:noFill/>
-        </p:spPr>
-        <p:txBody>
-          <a:bodyPr wrap="none" lIns="0" rIns="0" tIns="0" bIns="0" anchor="t">
-            <a:spAutoFit/>
-          </a:bodyPr>
-          <a:lstStyle/>
-          <a:p>
-            <a:pPr algn="l">
-              <a:lnSpc>
-                <a:spcPct val="100000"/>
-              </a:lnSpc>
-              <a:spcAft>
-                <a:spcPts val="0"/>
-              </a:spcAft>
-            </a:pPr>
-            <a:r>
-              <a:rPr sz="800" b="0" i="0">
-                <a:solidFill>
-                  <a:srgbClr val="767576"/>
-                </a:solidFill>
-                <a:latin typeface="Arial"/>
-              </a:rPr>
-              <a:t>4bp round trip</a:t>
-            </a:r>
-          </a:p>
-        </p:txBody>
-      </p:sp>
-      <p:sp>
-        <p:nvSpPr>
-          <p:cNvPr id="51" name="Rectangle 50"/>
+          <p:cNvPr id="30" name="Rectangle 29"/>
           <p:cNvSpPr/>
           <p:nvPr/>
         </p:nvSpPr>
         <p:spPr>
           <a:xfrm>
-            <a:off x="6163056" y="3387851"/>
-            <a:ext cx="182880" cy="100584"/>
+            <a:off x="5445069" y="1956816"/>
+            <a:ext cx="23774" cy="310896"/>
           </a:xfrm>
           <a:prstGeom prst="rect">
             <a:avLst/>
           </a:prstGeom>
           <a:solidFill>
-            <a:srgbClr val="F4B4BB"/>
+            <a:srgbClr val="44546A"/>
           </a:solidFill>
           <a:ln>
             <a:noFill/>
@@ -7089,67 +6163,23 @@
       </p:sp>
       <p:sp>
         <p:nvSpPr>
-          <p:cNvPr id="52" name="TextBox 51"/>
-          <p:cNvSpPr txBox="1"/>
-          <p:nvPr/>
-        </p:nvSpPr>
-        <p:spPr>
-          <a:xfrm>
-            <a:off x="6400800" y="3346703"/>
-            <a:ext cx="1737360" cy="182880"/>
-          </a:xfrm>
-          <a:prstGeom prst="rect">
-            <a:avLst/>
-          </a:prstGeom>
-          <a:noFill/>
-        </p:spPr>
-        <p:txBody>
-          <a:bodyPr wrap="none" lIns="0" rIns="0" tIns="0" bIns="0" anchor="t">
-            <a:spAutoFit/>
-          </a:bodyPr>
-          <a:lstStyle/>
-          <a:p>
-            <a:pPr algn="l">
-              <a:lnSpc>
-                <a:spcPct val="100000"/>
-              </a:lnSpc>
-              <a:spcAft>
-                <a:spcPts val="0"/>
-              </a:spcAft>
-            </a:pPr>
-            <a:r>
-              <a:rPr sz="800" b="0" i="0">
-                <a:solidFill>
-                  <a:srgbClr val="767576"/>
-                </a:solidFill>
-                <a:latin typeface="Arial"/>
-              </a:rPr>
-              <a:t>Move on our path</a:t>
-            </a:r>
-          </a:p>
-        </p:txBody>
-      </p:sp>
-      <p:sp>
-        <p:nvSpPr>
-          <p:cNvPr id="53" name="Rectangle 52"/>
+          <p:cNvPr id="31" name="Rectangle 30"/>
           <p:cNvSpPr/>
           <p:nvPr/>
         </p:nvSpPr>
         <p:spPr>
           <a:xfrm>
-            <a:off x="4133087" y="3561587"/>
-            <a:ext cx="182880" cy="100584"/>
+            <a:off x="6749003" y="1956816"/>
+            <a:ext cx="23774" cy="310896"/>
           </a:xfrm>
           <a:prstGeom prst="rect">
             <a:avLst/>
           </a:prstGeom>
           <a:solidFill>
-            <a:srgbClr val="FFFFFF"/>
+            <a:srgbClr val="DB0011"/>
           </a:solidFill>
-          <a:ln w="9525">
-            <a:solidFill>
-              <a:srgbClr val="DB0011"/>
-            </a:solidFill>
+          <a:ln>
+            <a:noFill/>
           </a:ln>
           <a:effectLst/>
         </p:spPr>
@@ -7175,14 +6205,98 @@
       </p:sp>
       <p:sp>
         <p:nvSpPr>
-          <p:cNvPr id="54" name="TextBox 53"/>
+          <p:cNvPr id="32" name="TextBox 31"/>
           <p:cNvSpPr txBox="1"/>
           <p:nvPr/>
         </p:nvSpPr>
         <p:spPr>
           <a:xfrm>
-            <a:off x="4370831" y="3520439"/>
-            <a:ext cx="1737360" cy="182880"/>
+            <a:off x="6345936" y="1769364"/>
+            <a:ext cx="822960" cy="164592"/>
+          </a:xfrm>
+          <a:prstGeom prst="rect">
+            <a:avLst/>
+          </a:prstGeom>
+          <a:noFill/>
+        </p:spPr>
+        <p:txBody>
+          <a:bodyPr wrap="none" lIns="0" rIns="0" tIns="0" bIns="0" anchor="t">
+            <a:spAutoFit/>
+          </a:bodyPr>
+          <a:lstStyle/>
+          <a:p>
+            <a:pPr algn="ctr">
+              <a:lnSpc>
+                <a:spcPct val="100000"/>
+              </a:lnSpc>
+              <a:spcAft>
+                <a:spcPts val="0"/>
+              </a:spcAft>
+            </a:pPr>
+            <a:r>
+              <a:rPr sz="700" b="1" i="0">
+                <a:solidFill>
+                  <a:srgbClr val="DB0011"/>
+                </a:solidFill>
+                <a:latin typeface="Arial"/>
+              </a:rPr>
+              <a:t>target 160</a:t>
+            </a:r>
+          </a:p>
+        </p:txBody>
+      </p:sp>
+      <p:sp>
+        <p:nvSpPr>
+          <p:cNvPr id="33" name="TextBox 32"/>
+          <p:cNvSpPr txBox="1"/>
+          <p:nvPr/>
+        </p:nvSpPr>
+        <p:spPr>
+          <a:xfrm>
+            <a:off x="5065775" y="2286000"/>
+            <a:ext cx="822960" cy="164592"/>
+          </a:xfrm>
+          <a:prstGeom prst="rect">
+            <a:avLst/>
+          </a:prstGeom>
+          <a:noFill/>
+        </p:spPr>
+        <p:txBody>
+          <a:bodyPr wrap="none" lIns="0" rIns="0" tIns="0" bIns="0" anchor="t">
+            <a:spAutoFit/>
+          </a:bodyPr>
+          <a:lstStyle/>
+          <a:p>
+            <a:pPr algn="ctr">
+              <a:lnSpc>
+                <a:spcPct val="100000"/>
+              </a:lnSpc>
+              <a:spcAft>
+                <a:spcPts val="0"/>
+              </a:spcAft>
+            </a:pPr>
+            <a:r>
+              <a:rPr sz="700" b="0" i="0">
+                <a:solidFill>
+                  <a:srgbClr val="767576"/>
+                </a:solidFill>
+                <a:latin typeface="Arial"/>
+              </a:rPr>
+              <a:t>stop 98</a:t>
+            </a:r>
+          </a:p>
+        </p:txBody>
+      </p:sp>
+      <p:sp>
+        <p:nvSpPr>
+          <p:cNvPr id="34" name="TextBox 33"/>
+          <p:cNvSpPr txBox="1"/>
+          <p:nvPr/>
+        </p:nvSpPr>
+        <p:spPr>
+          <a:xfrm>
+            <a:off x="4133087" y="2007107"/>
+            <a:ext cx="877824" cy="210312"/>
           </a:xfrm>
           <a:prstGeom prst="rect">
             <a:avLst/>
@@ -7204,27 +6318,27 @@
               </a:spcAft>
             </a:pPr>
             <a:r>
-              <a:rPr sz="800" b="0" i="0">
+              <a:rPr sz="1000" b="1" i="0">
                 <a:solidFill>
-                  <a:srgbClr val="767576"/>
+                  <a:srgbClr val="DB0011"/>
                 </a:solidFill>
                 <a:latin typeface="Arial"/>
               </a:rPr>
-              <a:t>Beyond the record since 2000</a:t>
-            </a:r>
-          </a:p>
-        </p:txBody>
-      </p:sp>
-      <p:sp>
-        <p:nvSpPr>
-          <p:cNvPr id="55" name="TextBox 54"/>
+              <a:t>JGB 2s10s</a:t>
+            </a:r>
+          </a:p>
+        </p:txBody>
+      </p:sp>
+      <p:sp>
+        <p:nvSpPr>
+          <p:cNvPr id="35" name="TextBox 34"/>
           <p:cNvSpPr txBox="1"/>
           <p:nvPr/>
         </p:nvSpPr>
         <p:spPr>
           <a:xfrm>
-            <a:off x="6236207" y="3584448"/>
-            <a:ext cx="914400" cy="164592"/>
+            <a:off x="7168896" y="1929384"/>
+            <a:ext cx="987552" cy="201168"/>
           </a:xfrm>
           <a:prstGeom prst="rect">
             <a:avLst/>
@@ -7246,27 +6360,27 @@
               </a:spcAft>
             </a:pPr>
             <a:r>
-              <a:rPr sz="850" b="1" i="0">
+              <a:rPr sz="1050" b="1" i="0">
                 <a:solidFill>
                   <a:srgbClr val="DB0011"/>
                 </a:solidFill>
                 <a:latin typeface="Arial"/>
               </a:rPr>
-              <a:t>2s10s</a:t>
-            </a:r>
-          </a:p>
-        </p:txBody>
-      </p:sp>
-      <p:sp>
-        <p:nvSpPr>
-          <p:cNvPr id="56" name="TextBox 55"/>
+              <a:t>1.9σ / 2.0σ</a:t>
+            </a:r>
+          </a:p>
+        </p:txBody>
+      </p:sp>
+      <p:sp>
+        <p:nvSpPr>
+          <p:cNvPr id="36" name="TextBox 35"/>
           <p:cNvSpPr txBox="1"/>
           <p:nvPr/>
         </p:nvSpPr>
         <p:spPr>
           <a:xfrm>
-            <a:off x="7150607" y="3584448"/>
-            <a:ext cx="914400" cy="164592"/>
+            <a:off x="7168896" y="2139696"/>
+            <a:ext cx="987552" cy="164592"/>
           </a:xfrm>
           <a:prstGeom prst="rect">
             <a:avLst/>
@@ -7288,27 +6402,363 @@
               </a:spcAft>
             </a:pPr>
             <a:r>
-              <a:rPr sz="850" b="1" i="0">
+              <a:rPr sz="750" b="0" i="0">
                 <a:solidFill>
                   <a:srgbClr val="767576"/>
                 </a:solidFill>
                 <a:latin typeface="Arial"/>
               </a:rPr>
-              <a:t>2s30s</a:t>
+              <a:t>target / stop</a:t>
+            </a:r>
+          </a:p>
+        </p:txBody>
+      </p:sp>
+      <p:sp>
+        <p:nvSpPr>
+          <p:cNvPr id="37" name="Rectangle 36"/>
+          <p:cNvSpPr/>
+          <p:nvPr/>
+        </p:nvSpPr>
+        <p:spPr>
+          <a:xfrm>
+            <a:off x="5623102" y="2670048"/>
+            <a:ext cx="988466" cy="237744"/>
+          </a:xfrm>
+          <a:prstGeom prst="rect">
+            <a:avLst/>
+          </a:prstGeom>
+          <a:solidFill>
+            <a:srgbClr val="D7D8D6"/>
+          </a:solidFill>
+          <a:ln>
+            <a:noFill/>
+          </a:ln>
+          <a:effectLst/>
+        </p:spPr>
+        <p:style>
+          <a:lnRef idx="1">
+            <a:schemeClr val="accent1"/>
+          </a:lnRef>
+          <a:fillRef idx="3">
+            <a:schemeClr val="accent1"/>
+          </a:fillRef>
+          <a:effectRef idx="2">
+            <a:schemeClr val="accent1"/>
+          </a:effectRef>
+          <a:fontRef idx="minor">
+            <a:schemeClr val="lt1"/>
+          </a:fontRef>
+        </p:style>
+        <p:txBody>
+          <a:bodyPr rtlCol="0" anchor="ctr"/>
+          <a:lstStyle/>
+          <a:p/>
+        </p:txBody>
+      </p:sp>
+      <p:sp>
+        <p:nvSpPr>
+          <p:cNvPr id="38" name="Rectangle 37"/>
+          <p:cNvSpPr/>
+          <p:nvPr/>
+        </p:nvSpPr>
+        <p:spPr>
+          <a:xfrm>
+            <a:off x="5779465" y="2633472"/>
+            <a:ext cx="23774" cy="310896"/>
+          </a:xfrm>
+          <a:prstGeom prst="rect">
+            <a:avLst/>
+          </a:prstGeom>
+          <a:solidFill>
+            <a:srgbClr val="44546A"/>
+          </a:solidFill>
+          <a:ln>
+            <a:noFill/>
+          </a:ln>
+          <a:effectLst/>
+        </p:spPr>
+        <p:style>
+          <a:lnRef idx="1">
+            <a:schemeClr val="accent1"/>
+          </a:lnRef>
+          <a:fillRef idx="3">
+            <a:schemeClr val="accent1"/>
+          </a:fillRef>
+          <a:effectRef idx="2">
+            <a:schemeClr val="accent1"/>
+          </a:effectRef>
+          <a:fontRef idx="minor">
+            <a:schemeClr val="lt1"/>
+          </a:fontRef>
+        </p:style>
+        <p:txBody>
+          <a:bodyPr rtlCol="0" anchor="ctr"/>
+          <a:lstStyle/>
+          <a:p/>
+        </p:txBody>
+      </p:sp>
+      <p:sp>
+        <p:nvSpPr>
+          <p:cNvPr id="39" name="Rectangle 38"/>
+          <p:cNvSpPr/>
+          <p:nvPr/>
+        </p:nvSpPr>
+        <p:spPr>
+          <a:xfrm>
+            <a:off x="6326276" y="2633472"/>
+            <a:ext cx="23774" cy="310896"/>
+          </a:xfrm>
+          <a:prstGeom prst="rect">
+            <a:avLst/>
+          </a:prstGeom>
+          <a:solidFill>
+            <a:srgbClr val="DB0011"/>
+          </a:solidFill>
+          <a:ln>
+            <a:noFill/>
+          </a:ln>
+          <a:effectLst/>
+        </p:spPr>
+        <p:style>
+          <a:lnRef idx="1">
+            <a:schemeClr val="accent1"/>
+          </a:lnRef>
+          <a:fillRef idx="3">
+            <a:schemeClr val="accent1"/>
+          </a:fillRef>
+          <a:effectRef idx="2">
+            <a:schemeClr val="accent1"/>
+          </a:effectRef>
+          <a:fontRef idx="minor">
+            <a:schemeClr val="lt1"/>
+          </a:fontRef>
+        </p:style>
+        <p:txBody>
+          <a:bodyPr rtlCol="0" anchor="ctr"/>
+          <a:lstStyle/>
+          <a:p/>
+        </p:txBody>
+      </p:sp>
+      <p:sp>
+        <p:nvSpPr>
+          <p:cNvPr id="40" name="TextBox 39"/>
+          <p:cNvSpPr txBox="1"/>
+          <p:nvPr/>
+        </p:nvSpPr>
+        <p:spPr>
+          <a:xfrm>
+            <a:off x="5926683" y="2446020"/>
+            <a:ext cx="822960" cy="164592"/>
+          </a:xfrm>
+          <a:prstGeom prst="rect">
+            <a:avLst/>
+          </a:prstGeom>
+          <a:noFill/>
+        </p:spPr>
+        <p:txBody>
+          <a:bodyPr wrap="none" lIns="0" rIns="0" tIns="0" bIns="0" anchor="t">
+            <a:spAutoFit/>
+          </a:bodyPr>
+          <a:lstStyle/>
+          <a:p>
+            <a:pPr algn="ctr">
+              <a:lnSpc>
+                <a:spcPct val="100000"/>
+              </a:lnSpc>
+              <a:spcAft>
+                <a:spcPts val="0"/>
+              </a:spcAft>
+            </a:pPr>
+            <a:r>
+              <a:rPr sz="700" b="1" i="0">
+                <a:solidFill>
+                  <a:srgbClr val="DB0011"/>
+                </a:solidFill>
+                <a:latin typeface="Arial"/>
+              </a:rPr>
+              <a:t>target 258</a:t>
+            </a:r>
+          </a:p>
+        </p:txBody>
+      </p:sp>
+      <p:sp>
+        <p:nvSpPr>
+          <p:cNvPr id="41" name="TextBox 40"/>
+          <p:cNvSpPr txBox="1"/>
+          <p:nvPr/>
+        </p:nvSpPr>
+        <p:spPr>
+          <a:xfrm>
+            <a:off x="5379872" y="2962656"/>
+            <a:ext cx="822960" cy="164592"/>
+          </a:xfrm>
+          <a:prstGeom prst="rect">
+            <a:avLst/>
+          </a:prstGeom>
+          <a:noFill/>
+        </p:spPr>
+        <p:txBody>
+          <a:bodyPr wrap="none" lIns="0" rIns="0" tIns="0" bIns="0" anchor="t">
+            <a:spAutoFit/>
+          </a:bodyPr>
+          <a:lstStyle/>
+          <a:p>
+            <a:pPr algn="ctr">
+              <a:lnSpc>
+                <a:spcPct val="100000"/>
+              </a:lnSpc>
+              <a:spcAft>
+                <a:spcPts val="0"/>
+              </a:spcAft>
+            </a:pPr>
+            <a:r>
+              <a:rPr sz="700" b="0" i="0">
+                <a:solidFill>
+                  <a:srgbClr val="767576"/>
+                </a:solidFill>
+                <a:latin typeface="Arial"/>
+              </a:rPr>
+              <a:t>stop 232</a:t>
+            </a:r>
+          </a:p>
+        </p:txBody>
+      </p:sp>
+      <p:sp>
+        <p:nvSpPr>
+          <p:cNvPr id="42" name="TextBox 41"/>
+          <p:cNvSpPr txBox="1"/>
+          <p:nvPr/>
+        </p:nvSpPr>
+        <p:spPr>
+          <a:xfrm>
+            <a:off x="4133087" y="2683763"/>
+            <a:ext cx="877824" cy="210312"/>
+          </a:xfrm>
+          <a:prstGeom prst="rect">
+            <a:avLst/>
+          </a:prstGeom>
+          <a:noFill/>
+        </p:spPr>
+        <p:txBody>
+          <a:bodyPr wrap="none" lIns="0" rIns="0" tIns="0" bIns="0" anchor="t">
+            <a:spAutoFit/>
+          </a:bodyPr>
+          <a:lstStyle/>
+          <a:p>
+            <a:pPr algn="l">
+              <a:lnSpc>
+                <a:spcPct val="100000"/>
+              </a:lnSpc>
+              <a:spcAft>
+                <a:spcPts val="0"/>
+              </a:spcAft>
+            </a:pPr>
+            <a:r>
+              <a:rPr sz="1000" b="1" i="0">
+                <a:solidFill>
+                  <a:srgbClr val="767576"/>
+                </a:solidFill>
+                <a:latin typeface="Arial"/>
+              </a:rPr>
+              <a:t>JGB 2s30s</a:t>
+            </a:r>
+          </a:p>
+        </p:txBody>
+      </p:sp>
+      <p:sp>
+        <p:nvSpPr>
+          <p:cNvPr id="43" name="TextBox 42"/>
+          <p:cNvSpPr txBox="1"/>
+          <p:nvPr/>
+        </p:nvSpPr>
+        <p:spPr>
+          <a:xfrm>
+            <a:off x="7168896" y="2606039"/>
+            <a:ext cx="987552" cy="201168"/>
+          </a:xfrm>
+          <a:prstGeom prst="rect">
+            <a:avLst/>
+          </a:prstGeom>
+          <a:noFill/>
+        </p:spPr>
+        <p:txBody>
+          <a:bodyPr wrap="none" lIns="0" rIns="0" tIns="0" bIns="0" anchor="t">
+            <a:spAutoFit/>
+          </a:bodyPr>
+          <a:lstStyle/>
+          <a:p>
+            <a:pPr algn="r">
+              <a:lnSpc>
+                <a:spcPct val="100000"/>
+              </a:lnSpc>
+              <a:spcAft>
+                <a:spcPts val="0"/>
+              </a:spcAft>
+            </a:pPr>
+            <a:r>
+              <a:rPr sz="1050" b="0" i="0">
+                <a:solidFill>
+                  <a:srgbClr val="767576"/>
+                </a:solidFill>
+                <a:latin typeface="Arial"/>
+              </a:rPr>
+              <a:t>0.5σ / 0.7σ</a:t>
+            </a:r>
+          </a:p>
+        </p:txBody>
+      </p:sp>
+      <p:sp>
+        <p:nvSpPr>
+          <p:cNvPr id="44" name="TextBox 43"/>
+          <p:cNvSpPr txBox="1"/>
+          <p:nvPr/>
+        </p:nvSpPr>
+        <p:spPr>
+          <a:xfrm>
+            <a:off x="7168896" y="2816351"/>
+            <a:ext cx="987552" cy="164592"/>
+          </a:xfrm>
+          <a:prstGeom prst="rect">
+            <a:avLst/>
+          </a:prstGeom>
+          <a:noFill/>
+        </p:spPr>
+        <p:txBody>
+          <a:bodyPr wrap="none" lIns="0" rIns="0" tIns="0" bIns="0" anchor="t">
+            <a:spAutoFit/>
+          </a:bodyPr>
+          <a:lstStyle/>
+          <a:p>
+            <a:pPr algn="r">
+              <a:lnSpc>
+                <a:spcPct val="100000"/>
+              </a:lnSpc>
+              <a:spcAft>
+                <a:spcPts val="0"/>
+              </a:spcAft>
+            </a:pPr>
+            <a:r>
+              <a:rPr sz="750" b="0" i="0">
+                <a:solidFill>
+                  <a:srgbClr val="767576"/>
+                </a:solidFill>
+                <a:latin typeface="Arial"/>
+              </a:rPr>
+              <a:t>target / stop</a:t>
             </a:r>
           </a:p>
         </p:txBody>
       </p:sp>
       <p:cxnSp>
         <p:nvCxnSpPr>
-          <p:cNvPr id="57" name="Connector 56"/>
+          <p:cNvPr id="45" name="Connector 44"/>
           <p:cNvCxnSpPr/>
           <p:nvPr/>
         </p:nvCxnSpPr>
         <p:spPr>
           <a:xfrm>
-            <a:off x="4133087" y="3767328"/>
-            <a:ext cx="3931921" cy="0"/>
+            <a:off x="5065775" y="3127248"/>
+            <a:ext cx="2103121" cy="0"/>
           </a:xfrm>
           <a:prstGeom prst="line">
             <a:avLst/>
@@ -7336,14 +6786,266 @@
       </p:cxnSp>
       <p:sp>
         <p:nvSpPr>
-          <p:cNvPr id="58" name="TextBox 57"/>
+          <p:cNvPr id="46" name="TextBox 45"/>
           <p:cNvSpPr txBox="1"/>
           <p:nvPr/>
         </p:nvSpPr>
         <p:spPr>
           <a:xfrm>
-            <a:off x="4133087" y="3822191"/>
-            <a:ext cx="2029967" cy="164592"/>
+            <a:off x="4791455" y="3163824"/>
+            <a:ext cx="548640" cy="164592"/>
+          </a:xfrm>
+          <a:prstGeom prst="rect">
+            <a:avLst/>
+          </a:prstGeom>
+          <a:noFill/>
+        </p:spPr>
+        <p:txBody>
+          <a:bodyPr wrap="none" lIns="0" rIns="0" tIns="0" bIns="0" anchor="t">
+            <a:spAutoFit/>
+          </a:bodyPr>
+          <a:lstStyle/>
+          <a:p>
+            <a:pPr algn="ctr">
+              <a:lnSpc>
+                <a:spcPct val="100000"/>
+              </a:lnSpc>
+              <a:spcAft>
+                <a:spcPts val="0"/>
+              </a:spcAft>
+            </a:pPr>
+            <a:r>
+              <a:rPr sz="800" b="0" i="0">
+                <a:solidFill>
+                  <a:srgbClr val="767576"/>
+                </a:solidFill>
+                <a:latin typeface="Arial"/>
+              </a:rPr>
+              <a:t>−50</a:t>
+            </a:r>
+          </a:p>
+        </p:txBody>
+      </p:sp>
+      <p:sp>
+        <p:nvSpPr>
+          <p:cNvPr id="47" name="TextBox 46"/>
+          <p:cNvSpPr txBox="1"/>
+          <p:nvPr/>
+        </p:nvSpPr>
+        <p:spPr>
+          <a:xfrm>
+            <a:off x="5317236" y="3163824"/>
+            <a:ext cx="548640" cy="164592"/>
+          </a:xfrm>
+          <a:prstGeom prst="rect">
+            <a:avLst/>
+          </a:prstGeom>
+          <a:noFill/>
+        </p:spPr>
+        <p:txBody>
+          <a:bodyPr wrap="none" lIns="0" rIns="0" tIns="0" bIns="0" anchor="t">
+            <a:spAutoFit/>
+          </a:bodyPr>
+          <a:lstStyle/>
+          <a:p>
+            <a:pPr algn="ctr">
+              <a:lnSpc>
+                <a:spcPct val="100000"/>
+              </a:lnSpc>
+              <a:spcAft>
+                <a:spcPts val="0"/>
+              </a:spcAft>
+            </a:pPr>
+            <a:r>
+              <a:rPr sz="800" b="0" i="0">
+                <a:solidFill>
+                  <a:srgbClr val="767576"/>
+                </a:solidFill>
+                <a:latin typeface="Arial"/>
+              </a:rPr>
+              <a:t>−25</a:t>
+            </a:r>
+          </a:p>
+        </p:txBody>
+      </p:sp>
+      <p:sp>
+        <p:nvSpPr>
+          <p:cNvPr id="48" name="TextBox 47"/>
+          <p:cNvSpPr txBox="1"/>
+          <p:nvPr/>
+        </p:nvSpPr>
+        <p:spPr>
+          <a:xfrm>
+            <a:off x="5843016" y="3163824"/>
+            <a:ext cx="548640" cy="164592"/>
+          </a:xfrm>
+          <a:prstGeom prst="rect">
+            <a:avLst/>
+          </a:prstGeom>
+          <a:noFill/>
+        </p:spPr>
+        <p:txBody>
+          <a:bodyPr wrap="none" lIns="0" rIns="0" tIns="0" bIns="0" anchor="t">
+            <a:spAutoFit/>
+          </a:bodyPr>
+          <a:lstStyle/>
+          <a:p>
+            <a:pPr algn="ctr">
+              <a:lnSpc>
+                <a:spcPct val="100000"/>
+              </a:lnSpc>
+              <a:spcAft>
+                <a:spcPts val="0"/>
+              </a:spcAft>
+            </a:pPr>
+            <a:r>
+              <a:rPr sz="800" b="0" i="0">
+                <a:solidFill>
+                  <a:srgbClr val="767576"/>
+                </a:solidFill>
+                <a:latin typeface="Arial"/>
+              </a:rPr>
+              <a:t>0</a:t>
+            </a:r>
+          </a:p>
+        </p:txBody>
+      </p:sp>
+      <p:sp>
+        <p:nvSpPr>
+          <p:cNvPr id="49" name="TextBox 48"/>
+          <p:cNvSpPr txBox="1"/>
+          <p:nvPr/>
+        </p:nvSpPr>
+        <p:spPr>
+          <a:xfrm>
+            <a:off x="6368795" y="3163824"/>
+            <a:ext cx="548640" cy="164592"/>
+          </a:xfrm>
+          <a:prstGeom prst="rect">
+            <a:avLst/>
+          </a:prstGeom>
+          <a:noFill/>
+        </p:spPr>
+        <p:txBody>
+          <a:bodyPr wrap="none" lIns="0" rIns="0" tIns="0" bIns="0" anchor="t">
+            <a:spAutoFit/>
+          </a:bodyPr>
+          <a:lstStyle/>
+          <a:p>
+            <a:pPr algn="ctr">
+              <a:lnSpc>
+                <a:spcPct val="100000"/>
+              </a:lnSpc>
+              <a:spcAft>
+                <a:spcPts val="0"/>
+              </a:spcAft>
+            </a:pPr>
+            <a:r>
+              <a:rPr sz="800" b="0" i="0">
+                <a:solidFill>
+                  <a:srgbClr val="767576"/>
+                </a:solidFill>
+                <a:latin typeface="Arial"/>
+              </a:rPr>
+              <a:t>+25</a:t>
+            </a:r>
+          </a:p>
+        </p:txBody>
+      </p:sp>
+      <p:sp>
+        <p:nvSpPr>
+          <p:cNvPr id="50" name="TextBox 49"/>
+          <p:cNvSpPr txBox="1"/>
+          <p:nvPr/>
+        </p:nvSpPr>
+        <p:spPr>
+          <a:xfrm>
+            <a:off x="6894576" y="3163824"/>
+            <a:ext cx="548640" cy="164592"/>
+          </a:xfrm>
+          <a:prstGeom prst="rect">
+            <a:avLst/>
+          </a:prstGeom>
+          <a:noFill/>
+        </p:spPr>
+        <p:txBody>
+          <a:bodyPr wrap="none" lIns="0" rIns="0" tIns="0" bIns="0" anchor="t">
+            <a:spAutoFit/>
+          </a:bodyPr>
+          <a:lstStyle/>
+          <a:p>
+            <a:pPr algn="ctr">
+              <a:lnSpc>
+                <a:spcPct val="100000"/>
+              </a:lnSpc>
+              <a:spcAft>
+                <a:spcPts val="0"/>
+              </a:spcAft>
+            </a:pPr>
+            <a:r>
+              <a:rPr sz="800" b="0" i="0">
+                <a:solidFill>
+                  <a:srgbClr val="767576"/>
+                </a:solidFill>
+                <a:latin typeface="Arial"/>
+              </a:rPr>
+              <a:t>+50</a:t>
+            </a:r>
+          </a:p>
+        </p:txBody>
+      </p:sp>
+      <p:sp>
+        <p:nvSpPr>
+          <p:cNvPr id="51" name="Rectangle 50"/>
+          <p:cNvSpPr/>
+          <p:nvPr/>
+        </p:nvSpPr>
+        <p:spPr>
+          <a:xfrm>
+            <a:off x="4133087" y="3387851"/>
+            <a:ext cx="182880" cy="100584"/>
+          </a:xfrm>
+          <a:prstGeom prst="rect">
+            <a:avLst/>
+          </a:prstGeom>
+          <a:solidFill>
+            <a:srgbClr val="D7D8D6"/>
+          </a:solidFill>
+          <a:ln>
+            <a:noFill/>
+          </a:ln>
+          <a:effectLst/>
+        </p:spPr>
+        <p:style>
+          <a:lnRef idx="1">
+            <a:schemeClr val="accent1"/>
+          </a:lnRef>
+          <a:fillRef idx="3">
+            <a:schemeClr val="accent1"/>
+          </a:fillRef>
+          <a:effectRef idx="2">
+            <a:schemeClr val="accent1"/>
+          </a:effectRef>
+          <a:fontRef idx="minor">
+            <a:schemeClr val="lt1"/>
+          </a:fontRef>
+        </p:style>
+        <p:txBody>
+          <a:bodyPr rtlCol="0" anchor="ctr"/>
+          <a:lstStyle/>
+          <a:p/>
+        </p:txBody>
+      </p:sp>
+      <p:sp>
+        <p:nvSpPr>
+          <p:cNvPr id="52" name="TextBox 51"/>
+          <p:cNvSpPr txBox="1"/>
+          <p:nvPr/>
+        </p:nvSpPr>
+        <p:spPr>
+          <a:xfrm>
+            <a:off x="4370831" y="3346703"/>
+            <a:ext cx="1737360" cy="182880"/>
           </a:xfrm>
           <a:prstGeom prst="rect">
             <a:avLst/>
@@ -7367,24 +7069,192 @@
             <a:r>
               <a:rPr sz="800" b="0" i="0">
                 <a:solidFill>
-                  <a:srgbClr val="000000"/>
+                  <a:srgbClr val="767576"/>
                 </a:solidFill>
                 <a:latin typeface="Arial"/>
               </a:rPr>
-              <a:t>Percentile since 2000</a:t>
-            </a:r>
-          </a:p>
-        </p:txBody>
-      </p:sp>
-      <p:sp>
-        <p:nvSpPr>
-          <p:cNvPr id="59" name="TextBox 58"/>
+              <a:t>±1 quarter of realised noise</a:t>
+            </a:r>
+          </a:p>
+        </p:txBody>
+      </p:sp>
+      <p:sp>
+        <p:nvSpPr>
+          <p:cNvPr id="53" name="Rectangle 52"/>
+          <p:cNvSpPr/>
+          <p:nvPr/>
+        </p:nvSpPr>
+        <p:spPr>
+          <a:xfrm>
+            <a:off x="6163056" y="3364991"/>
+            <a:ext cx="23774" cy="146304"/>
+          </a:xfrm>
+          <a:prstGeom prst="rect">
+            <a:avLst/>
+          </a:prstGeom>
+          <a:solidFill>
+            <a:srgbClr val="DB0011"/>
+          </a:solidFill>
+          <a:ln>
+            <a:noFill/>
+          </a:ln>
+          <a:effectLst/>
+        </p:spPr>
+        <p:style>
+          <a:lnRef idx="1">
+            <a:schemeClr val="accent1"/>
+          </a:lnRef>
+          <a:fillRef idx="3">
+            <a:schemeClr val="accent1"/>
+          </a:fillRef>
+          <a:effectRef idx="2">
+            <a:schemeClr val="accent1"/>
+          </a:effectRef>
+          <a:fontRef idx="minor">
+            <a:schemeClr val="lt1"/>
+          </a:fontRef>
+        </p:style>
+        <p:txBody>
+          <a:bodyPr rtlCol="0" anchor="ctr"/>
+          <a:lstStyle/>
+          <a:p/>
+        </p:txBody>
+      </p:sp>
+      <p:sp>
+        <p:nvSpPr>
+          <p:cNvPr id="54" name="TextBox 53"/>
           <p:cNvSpPr txBox="1"/>
           <p:nvPr/>
         </p:nvSpPr>
         <p:spPr>
           <a:xfrm>
-            <a:off x="6236207" y="3822191"/>
+            <a:off x="6241694" y="3346703"/>
+            <a:ext cx="962680" cy="182880"/>
+          </a:xfrm>
+          <a:prstGeom prst="rect">
+            <a:avLst/>
+          </a:prstGeom>
+          <a:noFill/>
+        </p:spPr>
+        <p:txBody>
+          <a:bodyPr wrap="none" lIns="0" rIns="0" tIns="0" bIns="0" anchor="t">
+            <a:spAutoFit/>
+          </a:bodyPr>
+          <a:lstStyle/>
+          <a:p>
+            <a:pPr algn="l">
+              <a:lnSpc>
+                <a:spcPct val="100000"/>
+              </a:lnSpc>
+              <a:spcAft>
+                <a:spcPts val="0"/>
+              </a:spcAft>
+            </a:pPr>
+            <a:r>
+              <a:rPr sz="800" b="0" i="0">
+                <a:solidFill>
+                  <a:srgbClr val="767576"/>
+                </a:solidFill>
+                <a:latin typeface="Arial"/>
+              </a:rPr>
+              <a:t>Target</a:t>
+            </a:r>
+          </a:p>
+        </p:txBody>
+      </p:sp>
+      <p:sp>
+        <p:nvSpPr>
+          <p:cNvPr id="55" name="Rectangle 54"/>
+          <p:cNvSpPr/>
+          <p:nvPr/>
+        </p:nvSpPr>
+        <p:spPr>
+          <a:xfrm>
+            <a:off x="7259238" y="3364991"/>
+            <a:ext cx="23774" cy="146304"/>
+          </a:xfrm>
+          <a:prstGeom prst="rect">
+            <a:avLst/>
+          </a:prstGeom>
+          <a:solidFill>
+            <a:srgbClr val="44546A"/>
+          </a:solidFill>
+          <a:ln>
+            <a:noFill/>
+          </a:ln>
+          <a:effectLst/>
+        </p:spPr>
+        <p:style>
+          <a:lnRef idx="1">
+            <a:schemeClr val="accent1"/>
+          </a:lnRef>
+          <a:fillRef idx="3">
+            <a:schemeClr val="accent1"/>
+          </a:fillRef>
+          <a:effectRef idx="2">
+            <a:schemeClr val="accent1"/>
+          </a:effectRef>
+          <a:fontRef idx="minor">
+            <a:schemeClr val="lt1"/>
+          </a:fontRef>
+        </p:style>
+        <p:txBody>
+          <a:bodyPr rtlCol="0" anchor="ctr"/>
+          <a:lstStyle/>
+          <a:p/>
+        </p:txBody>
+      </p:sp>
+      <p:sp>
+        <p:nvSpPr>
+          <p:cNvPr id="56" name="TextBox 55"/>
+          <p:cNvSpPr txBox="1"/>
+          <p:nvPr/>
+        </p:nvSpPr>
+        <p:spPr>
+          <a:xfrm>
+            <a:off x="7337877" y="3346703"/>
+            <a:ext cx="800282" cy="182880"/>
+          </a:xfrm>
+          <a:prstGeom prst="rect">
+            <a:avLst/>
+          </a:prstGeom>
+          <a:noFill/>
+        </p:spPr>
+        <p:txBody>
+          <a:bodyPr wrap="none" lIns="0" rIns="0" tIns="0" bIns="0" anchor="t">
+            <a:spAutoFit/>
+          </a:bodyPr>
+          <a:lstStyle/>
+          <a:p>
+            <a:pPr algn="l">
+              <a:lnSpc>
+                <a:spcPct val="100000"/>
+              </a:lnSpc>
+              <a:spcAft>
+                <a:spcPts val="0"/>
+              </a:spcAft>
+            </a:pPr>
+            <a:r>
+              <a:rPr sz="800" b="0" i="0">
+                <a:solidFill>
+                  <a:srgbClr val="767576"/>
+                </a:solidFill>
+                <a:latin typeface="Arial"/>
+              </a:rPr>
+              <a:t>Stop</a:t>
+            </a:r>
+          </a:p>
+        </p:txBody>
+      </p:sp>
+      <p:sp>
+        <p:nvSpPr>
+          <p:cNvPr id="57" name="TextBox 56"/>
+          <p:cNvSpPr txBox="1"/>
+          <p:nvPr/>
+        </p:nvSpPr>
+        <p:spPr>
+          <a:xfrm>
+            <a:off x="6236207" y="3584448"/>
             <a:ext cx="914400" cy="164592"/>
           </a:xfrm>
           <a:prstGeom prst="rect">
@@ -7413,20 +7283,20 @@
                 </a:solidFill>
                 <a:latin typeface="Arial"/>
               </a:rPr>
-              <a:t>93rd</a:t>
-            </a:r>
-          </a:p>
-        </p:txBody>
-      </p:sp>
-      <p:sp>
-        <p:nvSpPr>
-          <p:cNvPr id="60" name="TextBox 59"/>
+              <a:t>2s10s</a:t>
+            </a:r>
+          </a:p>
+        </p:txBody>
+      </p:sp>
+      <p:sp>
+        <p:nvSpPr>
+          <p:cNvPr id="58" name="TextBox 57"/>
           <p:cNvSpPr txBox="1"/>
           <p:nvPr/>
         </p:nvSpPr>
         <p:spPr>
           <a:xfrm>
-            <a:off x="7150607" y="3822191"/>
+            <a:off x="7150607" y="3584448"/>
             <a:ext cx="914400" cy="164592"/>
           </a:xfrm>
           <a:prstGeom prst="rect">
@@ -7449,34 +7319,34 @@
               </a:spcAft>
             </a:pPr>
             <a:r>
-              <a:rPr sz="850" b="0" i="0">
+              <a:rPr sz="850" b="1" i="0">
                 <a:solidFill>
                   <a:srgbClr val="767576"/>
                 </a:solidFill>
                 <a:latin typeface="Arial"/>
               </a:rPr>
-              <a:t>99th</a:t>
+              <a:t>2s30s</a:t>
             </a:r>
           </a:p>
         </p:txBody>
       </p:sp>
       <p:cxnSp>
         <p:nvCxnSpPr>
-          <p:cNvPr id="61" name="Connector 60"/>
+          <p:cNvPr id="59" name="Connector 58"/>
           <p:cNvCxnSpPr/>
           <p:nvPr/>
         </p:nvCxnSpPr>
         <p:spPr>
           <a:xfrm>
-            <a:off x="4133087" y="3968496"/>
+            <a:off x="4133087" y="3767328"/>
             <a:ext cx="3931921" cy="0"/>
           </a:xfrm>
           <a:prstGeom prst="line">
             <a:avLst/>
           </a:prstGeom>
-          <a:ln w="6350">
+          <a:ln w="9525">
             <a:solidFill>
-              <a:srgbClr val="D0CECE"/>
+              <a:srgbClr val="000000"/>
             </a:solidFill>
           </a:ln>
         </p:spPr>
@@ -7497,13 +7367,13 @@
       </p:cxnSp>
       <p:sp>
         <p:nvSpPr>
-          <p:cNvPr id="62" name="TextBox 61"/>
+          <p:cNvPr id="60" name="TextBox 59"/>
           <p:cNvSpPr txBox="1"/>
           <p:nvPr/>
         </p:nvSpPr>
         <p:spPr>
           <a:xfrm>
-            <a:off x="4133087" y="4005072"/>
+            <a:off x="4133087" y="3822191"/>
             <a:ext cx="2029967" cy="164592"/>
           </a:xfrm>
           <a:prstGeom prst="rect">
@@ -7532,20 +7402,20 @@
                 </a:solidFill>
                 <a:latin typeface="Arial"/>
               </a:rPr>
-              <a:t>Notional per ¥1bn back leg</a:t>
-            </a:r>
-          </a:p>
-        </p:txBody>
-      </p:sp>
-      <p:sp>
-        <p:nvSpPr>
-          <p:cNvPr id="63" name="TextBox 62"/>
+              <a:t>Percentile since 2000</a:t>
+            </a:r>
+          </a:p>
+        </p:txBody>
+      </p:sp>
+      <p:sp>
+        <p:nvSpPr>
+          <p:cNvPr id="61" name="TextBox 60"/>
           <p:cNvSpPr txBox="1"/>
           <p:nvPr/>
         </p:nvSpPr>
         <p:spPr>
           <a:xfrm>
-            <a:off x="6236207" y="4005072"/>
+            <a:off x="6236207" y="3822191"/>
             <a:ext cx="914400" cy="164592"/>
           </a:xfrm>
           <a:prstGeom prst="rect">
@@ -7574,20 +7444,20 @@
                 </a:solidFill>
                 <a:latin typeface="Arial"/>
               </a:rPr>
-              <a:t>¥5.5bn</a:t>
-            </a:r>
-          </a:p>
-        </p:txBody>
-      </p:sp>
-      <p:sp>
-        <p:nvSpPr>
-          <p:cNvPr id="64" name="TextBox 63"/>
+              <a:t>93rd</a:t>
+            </a:r>
+          </a:p>
+        </p:txBody>
+      </p:sp>
+      <p:sp>
+        <p:nvSpPr>
+          <p:cNvPr id="62" name="TextBox 61"/>
           <p:cNvSpPr txBox="1"/>
           <p:nvPr/>
         </p:nvSpPr>
         <p:spPr>
           <a:xfrm>
-            <a:off x="7150607" y="4005072"/>
+            <a:off x="7150607" y="3822191"/>
             <a:ext cx="914400" cy="164592"/>
           </a:xfrm>
           <a:prstGeom prst="rect">
@@ -7616,20 +7486,20 @@
                 </a:solidFill>
                 <a:latin typeface="Arial"/>
               </a:rPr>
-              <a:t>¥10.3bn</a:t>
+              <a:t>99th</a:t>
             </a:r>
           </a:p>
         </p:txBody>
       </p:sp>
       <p:cxnSp>
         <p:nvCxnSpPr>
-          <p:cNvPr id="65" name="Connector 64"/>
+          <p:cNvPr id="63" name="Connector 62"/>
           <p:cNvCxnSpPr/>
           <p:nvPr/>
         </p:nvCxnSpPr>
         <p:spPr>
           <a:xfrm>
-            <a:off x="4133087" y="4151376"/>
+            <a:off x="4133087" y="3968496"/>
             <a:ext cx="3931921" cy="0"/>
           </a:xfrm>
           <a:prstGeom prst="line">
@@ -7658,13 +7528,13 @@
       </p:cxnSp>
       <p:sp>
         <p:nvSpPr>
-          <p:cNvPr id="66" name="TextBox 65"/>
+          <p:cNvPr id="64" name="TextBox 63"/>
           <p:cNvSpPr txBox="1"/>
           <p:nvPr/>
         </p:nvSpPr>
         <p:spPr>
           <a:xfrm>
-            <a:off x="4133087" y="4187952"/>
+            <a:off x="4133087" y="4005072"/>
             <a:ext cx="2029967" cy="164592"/>
           </a:xfrm>
           <a:prstGeom prst="rect">
@@ -7693,20 +7563,20 @@
                 </a:solidFill>
                 <a:latin typeface="Arial"/>
               </a:rPr>
-              <a:t>Risk : reward, net of costs</a:t>
-            </a:r>
-          </a:p>
-        </p:txBody>
-      </p:sp>
-      <p:sp>
-        <p:nvSpPr>
-          <p:cNvPr id="67" name="TextBox 66"/>
+              <a:t>Notional per ¥1bn back leg</a:t>
+            </a:r>
+          </a:p>
+        </p:txBody>
+      </p:sp>
+      <p:sp>
+        <p:nvSpPr>
+          <p:cNvPr id="65" name="TextBox 64"/>
           <p:cNvSpPr txBox="1"/>
           <p:nvPr/>
         </p:nvSpPr>
         <p:spPr>
           <a:xfrm>
-            <a:off x="6236207" y="4187952"/>
+            <a:off x="6236207" y="4005072"/>
             <a:ext cx="914400" cy="164592"/>
           </a:xfrm>
           <a:prstGeom prst="rect">
@@ -7735,20 +7605,20 @@
                 </a:solidFill>
                 <a:latin typeface="Arial"/>
               </a:rPr>
-              <a:t>2.1 : 1</a:t>
-            </a:r>
-          </a:p>
-        </p:txBody>
-      </p:sp>
-      <p:sp>
-        <p:nvSpPr>
-          <p:cNvPr id="68" name="TextBox 67"/>
+              <a:t>¥5.5bn</a:t>
+            </a:r>
+          </a:p>
+        </p:txBody>
+      </p:sp>
+      <p:sp>
+        <p:nvSpPr>
+          <p:cNvPr id="66" name="TextBox 65"/>
           <p:cNvSpPr txBox="1"/>
           <p:nvPr/>
         </p:nvSpPr>
         <p:spPr>
           <a:xfrm>
-            <a:off x="7150607" y="4187952"/>
+            <a:off x="7150607" y="4005072"/>
             <a:ext cx="914400" cy="164592"/>
           </a:xfrm>
           <a:prstGeom prst="rect">
@@ -7777,20 +7647,20 @@
                 </a:solidFill>
                 <a:latin typeface="Arial"/>
               </a:rPr>
-              <a:t>1.1 : 1</a:t>
+              <a:t>¥10.3bn</a:t>
             </a:r>
           </a:p>
         </p:txBody>
       </p:sp>
       <p:cxnSp>
         <p:nvCxnSpPr>
-          <p:cNvPr id="69" name="Connector 68"/>
+          <p:cNvPr id="67" name="Connector 66"/>
           <p:cNvCxnSpPr/>
           <p:nvPr/>
         </p:nvCxnSpPr>
         <p:spPr>
           <a:xfrm>
-            <a:off x="4133087" y="4334256"/>
+            <a:off x="4133087" y="4151376"/>
             <a:ext cx="3931921" cy="0"/>
           </a:xfrm>
           <a:prstGeom prst="line">
@@ -7819,7 +7689,168 @@
       </p:cxnSp>
       <p:sp>
         <p:nvSpPr>
+          <p:cNvPr id="68" name="TextBox 67"/>
+          <p:cNvSpPr txBox="1"/>
+          <p:nvPr/>
+        </p:nvSpPr>
+        <p:spPr>
+          <a:xfrm>
+            <a:off x="4133087" y="4187952"/>
+            <a:ext cx="2029967" cy="164592"/>
+          </a:xfrm>
+          <a:prstGeom prst="rect">
+            <a:avLst/>
+          </a:prstGeom>
+          <a:noFill/>
+        </p:spPr>
+        <p:txBody>
+          <a:bodyPr wrap="none" lIns="0" rIns="0" tIns="0" bIns="0" anchor="t">
+            <a:spAutoFit/>
+          </a:bodyPr>
+          <a:lstStyle/>
+          <a:p>
+            <a:pPr algn="l">
+              <a:lnSpc>
+                <a:spcPct val="100000"/>
+              </a:lnSpc>
+              <a:spcAft>
+                <a:spcPts val="0"/>
+              </a:spcAft>
+            </a:pPr>
+            <a:r>
+              <a:rPr sz="800" b="0" i="0">
+                <a:solidFill>
+                  <a:srgbClr val="000000"/>
+                </a:solidFill>
+                <a:latin typeface="Arial"/>
+              </a:rPr>
+              <a:t>Risk : reward, net of costs</a:t>
+            </a:r>
+          </a:p>
+        </p:txBody>
+      </p:sp>
+      <p:sp>
+        <p:nvSpPr>
+          <p:cNvPr id="69" name="TextBox 68"/>
+          <p:cNvSpPr txBox="1"/>
+          <p:nvPr/>
+        </p:nvSpPr>
+        <p:spPr>
+          <a:xfrm>
+            <a:off x="6236207" y="4187952"/>
+            <a:ext cx="914400" cy="164592"/>
+          </a:xfrm>
+          <a:prstGeom prst="rect">
+            <a:avLst/>
+          </a:prstGeom>
+          <a:noFill/>
+        </p:spPr>
+        <p:txBody>
+          <a:bodyPr wrap="none" lIns="0" rIns="0" tIns="0" bIns="0" anchor="t">
+            <a:spAutoFit/>
+          </a:bodyPr>
+          <a:lstStyle/>
+          <a:p>
+            <a:pPr algn="r">
+              <a:lnSpc>
+                <a:spcPct val="100000"/>
+              </a:lnSpc>
+              <a:spcAft>
+                <a:spcPts val="0"/>
+              </a:spcAft>
+            </a:pPr>
+            <a:r>
+              <a:rPr sz="850" b="1" i="0">
+                <a:solidFill>
+                  <a:srgbClr val="DB0011"/>
+                </a:solidFill>
+                <a:latin typeface="Arial"/>
+              </a:rPr>
+              <a:t>2.1 : 1</a:t>
+            </a:r>
+          </a:p>
+        </p:txBody>
+      </p:sp>
+      <p:sp>
+        <p:nvSpPr>
           <p:cNvPr id="70" name="TextBox 69"/>
+          <p:cNvSpPr txBox="1"/>
+          <p:nvPr/>
+        </p:nvSpPr>
+        <p:spPr>
+          <a:xfrm>
+            <a:off x="7150607" y="4187952"/>
+            <a:ext cx="914400" cy="164592"/>
+          </a:xfrm>
+          <a:prstGeom prst="rect">
+            <a:avLst/>
+          </a:prstGeom>
+          <a:noFill/>
+        </p:spPr>
+        <p:txBody>
+          <a:bodyPr wrap="none" lIns="0" rIns="0" tIns="0" bIns="0" anchor="t">
+            <a:spAutoFit/>
+          </a:bodyPr>
+          <a:lstStyle/>
+          <a:p>
+            <a:pPr algn="r">
+              <a:lnSpc>
+                <a:spcPct val="100000"/>
+              </a:lnSpc>
+              <a:spcAft>
+                <a:spcPts val="0"/>
+              </a:spcAft>
+            </a:pPr>
+            <a:r>
+              <a:rPr sz="850" b="0" i="0">
+                <a:solidFill>
+                  <a:srgbClr val="767576"/>
+                </a:solidFill>
+                <a:latin typeface="Arial"/>
+              </a:rPr>
+              <a:t>1.1 : 1</a:t>
+            </a:r>
+          </a:p>
+        </p:txBody>
+      </p:sp>
+      <p:cxnSp>
+        <p:nvCxnSpPr>
+          <p:cNvPr id="71" name="Connector 70"/>
+          <p:cNvCxnSpPr/>
+          <p:nvPr/>
+        </p:nvCxnSpPr>
+        <p:spPr>
+          <a:xfrm>
+            <a:off x="4133087" y="4334256"/>
+            <a:ext cx="3931921" cy="0"/>
+          </a:xfrm>
+          <a:prstGeom prst="line">
+            <a:avLst/>
+          </a:prstGeom>
+          <a:ln w="6350">
+            <a:solidFill>
+              <a:srgbClr val="D0CECE"/>
+            </a:solidFill>
+          </a:ln>
+        </p:spPr>
+        <p:style>
+          <a:lnRef idx="2">
+            <a:schemeClr val="accent1"/>
+          </a:lnRef>
+          <a:fillRef idx="0">
+            <a:schemeClr val="accent1"/>
+          </a:fillRef>
+          <a:effectRef idx="1">
+            <a:schemeClr val="accent1"/>
+          </a:effectRef>
+          <a:fontRef idx="minor">
+            <a:schemeClr val="tx1"/>
+          </a:fontRef>
+        </p:style>
+      </p:cxnSp>
+      <p:sp>
+        <p:nvSpPr>
+          <p:cNvPr id="72" name="TextBox 71"/>
           <p:cNvSpPr txBox="1"/>
           <p:nvPr/>
         </p:nvSpPr>
@@ -7854,14 +7885,14 @@
                 </a:solidFill>
                 <a:latin typeface="Arial"/>
               </a:rPr>
-              <a:t>6.8%</a:t>
-            </a:r>
-          </a:p>
-        </p:txBody>
-      </p:sp>
-      <p:sp>
-        <p:nvSpPr>
-          <p:cNvPr id="71" name="TextBox 70"/>
+              <a:t>1.5x</a:t>
+            </a:r>
+          </a:p>
+        </p:txBody>
+      </p:sp>
+      <p:sp>
+        <p:nvSpPr>
+          <p:cNvPr id="73" name="TextBox 72"/>
           <p:cNvSpPr txBox="1"/>
           <p:nvPr/>
         </p:nvSpPr>
@@ -7896,14 +7927,14 @@
                 </a:solidFill>
                 <a:latin typeface="Arial"/>
               </a:rPr>
-              <a:t>of weeks since 2000 closed steeper</a:t>
-            </a:r>
-          </a:p>
-        </p:txBody>
-      </p:sp>
-      <p:sp>
-        <p:nvSpPr>
-          <p:cNvPr id="72" name="TextBox 71"/>
+              <a:t>the volatility 2s30s carries, for a smaller move</a:t>
+            </a:r>
+          </a:p>
+        </p:txBody>
+      </p:sp>
+      <p:sp>
+        <p:nvSpPr>
+          <p:cNvPr id="74" name="TextBox 73"/>
           <p:cNvSpPr txBox="1"/>
           <p:nvPr/>
         </p:nvSpPr>
@@ -7945,7 +7976,7 @@
       </p:sp>
       <p:sp>
         <p:nvSpPr>
-          <p:cNvPr id="73" name="TextBox 72"/>
+          <p:cNvPr id="75" name="TextBox 74"/>
           <p:cNvSpPr txBox="1"/>
           <p:nvPr/>
         </p:nvSpPr>
@@ -7987,7 +8018,7 @@
       </p:sp>
       <p:sp>
         <p:nvSpPr>
-          <p:cNvPr id="74" name="TextBox 73"/>
+          <p:cNvPr id="76" name="TextBox 75"/>
           <p:cNvSpPr txBox="1"/>
           <p:nvPr/>
         </p:nvSpPr>
@@ -8029,7 +8060,7 @@
       </p:sp>
       <p:sp>
         <p:nvSpPr>
-          <p:cNvPr id="75" name="TextBox 74"/>
+          <p:cNvPr id="77" name="TextBox 76"/>
           <p:cNvSpPr txBox="1"/>
           <p:nvPr/>
         </p:nvSpPr>
@@ -8071,7 +8102,7 @@
       </p:sp>
       <p:graphicFrame>
         <p:nvGraphicFramePr>
-          <p:cNvPr id="76" name="Chart 75"/>
+          <p:cNvPr id="78" name="Chart 77"/>
           <p:cNvGraphicFramePr>
             <a:graphicFrameLocks noGrp="1"/>
           </p:cNvGraphicFramePr>
@@ -8089,7 +8120,7 @@
       </p:graphicFrame>
       <p:sp>
         <p:nvSpPr>
-          <p:cNvPr id="77" name="TextBox 76"/>
+          <p:cNvPr id="79" name="TextBox 78"/>
           <p:cNvSpPr txBox="1"/>
           <p:nvPr/>
         </p:nvSpPr>
@@ -8131,7 +8162,7 @@
       </p:sp>
       <p:sp>
         <p:nvSpPr>
-          <p:cNvPr id="78" name="TextBox 77"/>
+          <p:cNvPr id="80" name="TextBox 79"/>
           <p:cNvSpPr txBox="1"/>
           <p:nvPr/>
         </p:nvSpPr>
@@ -8173,7 +8204,7 @@
       </p:sp>
       <p:sp>
         <p:nvSpPr>
-          <p:cNvPr id="79" name="TextBox 78"/>
+          <p:cNvPr id="81" name="TextBox 80"/>
           <p:cNvSpPr txBox="1"/>
           <p:nvPr/>
         </p:nvSpPr>
@@ -8215,7 +8246,7 @@
       </p:sp>
       <p:sp>
         <p:nvSpPr>
-          <p:cNvPr id="80" name="TextBox 79"/>
+          <p:cNvPr id="82" name="TextBox 81"/>
           <p:cNvSpPr txBox="1"/>
           <p:nvPr/>
         </p:nvSpPr>
@@ -8257,7 +8288,7 @@
       </p:sp>
       <p:sp>
         <p:nvSpPr>
-          <p:cNvPr id="81" name="TextBox 80"/>
+          <p:cNvPr id="83" name="TextBox 82"/>
           <p:cNvSpPr txBox="1"/>
           <p:nvPr/>
         </p:nvSpPr>
@@ -8299,7 +8330,7 @@
       </p:sp>
       <p:graphicFrame>
         <p:nvGraphicFramePr>
-          <p:cNvPr id="82" name="Table 81"/>
+          <p:cNvPr id="84" name="Table 83"/>
           <p:cNvGraphicFramePr>
             <a:graphicFrameLocks noGrp="1"/>
           </p:cNvGraphicFramePr>
@@ -8801,7 +8832,7 @@
       </p:graphicFrame>
       <p:sp>
         <p:nvSpPr>
-          <p:cNvPr id="83" name="TextBox 82"/>
+          <p:cNvPr id="85" name="TextBox 84"/>
           <p:cNvSpPr txBox="1"/>
           <p:nvPr/>
         </p:nvSpPr>
@@ -8843,7 +8874,7 @@
       </p:sp>
       <p:sp>
         <p:nvSpPr>
-          <p:cNvPr id="84" name="TextBox 83"/>
+          <p:cNvPr id="86" name="TextBox 85"/>
           <p:cNvSpPr txBox="1"/>
           <p:nvPr/>
         </p:nvSpPr>
@@ -8878,49 +8909,7 @@
                 </a:solidFill>
                 <a:latin typeface="Arial"/>
               </a:rPr>
-              <a:t>MoF JGB curve at 31-Jul-26, weekly since 2000, n = 1,387. Slide 3's panel is a different window: month-end to May-26, five years, so its levels and percentiles will not tie to these. Cashflow-level pricing on the annual JPY OIS schedule. Our path is a scenario: 2y +10bp, 10y +40bp.</a:t>
-            </a:r>
-          </a:p>
-        </p:txBody>
-      </p:sp>
-      <p:sp>
-        <p:nvSpPr>
-          <p:cNvPr id="85" name="TextBox 84"/>
-          <p:cNvSpPr txBox="1"/>
-          <p:nvPr/>
-        </p:nvSpPr>
-        <p:spPr>
-          <a:xfrm>
-            <a:off x="8503920" y="6108192"/>
-            <a:ext cx="3218688" cy="201168"/>
-          </a:xfrm>
-          <a:prstGeom prst="rect">
-            <a:avLst/>
-          </a:prstGeom>
-          <a:noFill/>
-        </p:spPr>
-        <p:txBody>
-          <a:bodyPr wrap="none" lIns="0" rIns="0" tIns="0" bIns="0" anchor="t">
-            <a:spAutoFit/>
-          </a:bodyPr>
-          <a:lstStyle/>
-          <a:p>
-            <a:pPr algn="r">
-              <a:lnSpc>
-                <a:spcPct val="100000"/>
-              </a:lnSpc>
-              <a:spcAft>
-                <a:spcPts val="0"/>
-              </a:spcAft>
-            </a:pPr>
-            <a:r>
-              <a:rPr sz="800" b="0" i="0">
-                <a:solidFill>
-                  <a:srgbClr val="BFBFBF"/>
-                </a:solidFill>
-                <a:latin typeface="Arial"/>
-              </a:rPr>
-              <a:t>INTERNAL</a:t>
+              <a:t>MoF JGB curve at 31-Jul-26, weekly since 2000, n = 1,387. Cashflow-level pricing on the annual JPY OIS schedule. Our path is a scenario: 2y +10bp, 10y +40bp.</a:t>
             </a:r>
           </a:p>
         </p:txBody>

</xml_diff>

<commit_message>
Tighten the noise axis on the risk-led slide
</commit_message>
<xml_diff>
--- a/JGB_2s10s_Steepener_Risk.pptx
+++ b/JGB_2s10s_Steepener_Risk.pptx
@@ -6085,8 +6085,8 @@
         </p:nvSpPr>
         <p:spPr>
           <a:xfrm>
-            <a:off x="5785043" y="1993392"/>
-            <a:ext cx="664585" cy="237744"/>
+            <a:off x="5701969" y="1993392"/>
+            <a:ext cx="830732" cy="237744"/>
           </a:xfrm>
           <a:prstGeom prst="rect">
             <a:avLst/>
@@ -6127,7 +6127,7 @@
         </p:nvSpPr>
         <p:spPr>
           <a:xfrm>
-            <a:off x="5445069" y="1956816"/>
+            <a:off x="5279974" y="1956816"/>
             <a:ext cx="23774" cy="310896"/>
           </a:xfrm>
           <a:prstGeom prst="rect">
@@ -6169,7 +6169,7 @@
         </p:nvSpPr>
         <p:spPr>
           <a:xfrm>
-            <a:off x="6749003" y="1956816"/>
+            <a:off x="6909892" y="1956816"/>
             <a:ext cx="23774" cy="310896"/>
           </a:xfrm>
           <a:prstGeom prst="rect">
@@ -6421,8 +6421,8 @@
         </p:nvSpPr>
         <p:spPr>
           <a:xfrm>
-            <a:off x="5623102" y="2670048"/>
-            <a:ext cx="988466" cy="237744"/>
+            <a:off x="5499544" y="2670048"/>
+            <a:ext cx="1235583" cy="237744"/>
           </a:xfrm>
           <a:prstGeom prst="rect">
             <a:avLst/>
@@ -6463,7 +6463,7 @@
         </p:nvSpPr>
         <p:spPr>
           <a:xfrm>
-            <a:off x="5779465" y="2633472"/>
+            <a:off x="5697969" y="2633472"/>
             <a:ext cx="23774" cy="310896"/>
           </a:xfrm>
           <a:prstGeom prst="rect">
@@ -6505,7 +6505,7 @@
         </p:nvSpPr>
         <p:spPr>
           <a:xfrm>
-            <a:off x="6326276" y="2633472"/>
+            <a:off x="6381483" y="2633472"/>
             <a:ext cx="23774" cy="310896"/>
           </a:xfrm>
           <a:prstGeom prst="rect">
@@ -6547,7 +6547,7 @@
         </p:nvSpPr>
         <p:spPr>
           <a:xfrm>
-            <a:off x="5926683" y="2446020"/>
+            <a:off x="5981890" y="2446020"/>
             <a:ext cx="822960" cy="164592"/>
           </a:xfrm>
           <a:prstGeom prst="rect">
@@ -6589,7 +6589,7 @@
         </p:nvSpPr>
         <p:spPr>
           <a:xfrm>
-            <a:off x="5379872" y="2962656"/>
+            <a:off x="5298376" y="2962656"/>
             <a:ext cx="822960" cy="164592"/>
           </a:xfrm>
           <a:prstGeom prst="rect">
@@ -6821,7 +6821,7 @@
                 </a:solidFill>
                 <a:latin typeface="Arial"/>
               </a:rPr>
-              <a:t>−50</a:t>
+              <a:t>−40</a:t>
             </a:r>
           </a:p>
         </p:txBody>
@@ -6863,7 +6863,7 @@
                 </a:solidFill>
                 <a:latin typeface="Arial"/>
               </a:rPr>
-              <a:t>−25</a:t>
+              <a:t>−20</a:t>
             </a:r>
           </a:p>
         </p:txBody>
@@ -6947,7 +6947,7 @@
                 </a:solidFill>
                 <a:latin typeface="Arial"/>
               </a:rPr>
-              <a:t>+25</a:t>
+              <a:t>+20</a:t>
             </a:r>
           </a:p>
         </p:txBody>
@@ -6989,7 +6989,7 @@
                 </a:solidFill>
                 <a:latin typeface="Arial"/>
               </a:rPr>
-              <a:t>+50</a:t>
+              <a:t>+40</a:t>
             </a:r>
           </a:p>
         </p:txBody>
@@ -7927,7 +7927,7 @@
                 </a:solidFill>
                 <a:latin typeface="Arial"/>
               </a:rPr>
-              <a:t>the volatility 2s30s carries, for a smaller move</a:t>
+              <a:t>the noise 2s30s carries, for less move</a:t>
             </a:r>
           </a:p>
         </p:txBody>

</xml_diff>

<commit_message>
Count how often each stop was actually hit
</commit_message>
<xml_diff>
--- a/JGB_2s10s_Steepener_Risk.pptx
+++ b/JGB_2s10s_Steepener_Risk.pptx
@@ -5820,7 +5820,7 @@
                 </a:solidFill>
                 <a:latin typeface="Arial"/>
               </a:rPr>
-              <a:t>Exhibit 5. The whole 2s30s trade fits inside one quarter of its own noise. The 2s10s trade does not</a:t>
+              <a:t>Exhibit 5. The 2s30s stop sits inside its own noise and would have been hit 57% of the time. Ours 17%</a:t>
             </a:r>
           </a:p>
         </p:txBody>
@@ -6366,7 +6366,7 @@
                 </a:solidFill>
                 <a:latin typeface="Arial"/>
               </a:rPr>
-              <a:t>1.9σ / 2.0σ</a:t>
+              <a:t>17%</a:t>
             </a:r>
           </a:p>
         </p:txBody>
@@ -6408,7 +6408,7 @@
                 </a:solidFill>
                 <a:latin typeface="Arial"/>
               </a:rPr>
-              <a:t>target / stop</a:t>
+              <a:t>of entries stopped out</a:t>
             </a:r>
           </a:p>
         </p:txBody>
@@ -6702,7 +6702,7 @@
                 </a:solidFill>
                 <a:latin typeface="Arial"/>
               </a:rPr>
-              <a:t>0.5σ / 0.7σ</a:t>
+              <a:t>57%</a:t>
             </a:r>
           </a:p>
         </p:txBody>
@@ -6744,7 +6744,7 @@
                 </a:solidFill>
                 <a:latin typeface="Arial"/>
               </a:rPr>
-              <a:t>target / stop</a:t>
+              <a:t>of entries stopped out</a:t>
             </a:r>
           </a:p>
         </p:txBody>
@@ -8909,7 +8909,7 @@
                 </a:solidFill>
                 <a:latin typeface="Arial"/>
               </a:rPr>
-              <a:t>MoF JGB curve at 31-Jul-26, weekly since 2000, n = 1,387. Cashflow-level pricing on the annual JPY OIS schedule. Our path is a scenario: 2y +10bp, 10y +40bp.</a:t>
+              <a:t>MoF JGB curve at 31-Jul-26, weekly since 2000, n = 1,387. Stops tested on every entry at or above the 85th percentile, worst point over the next 26 weeks. Noise is the QT era, n = 121. Cashflow-level pricing on the annual JPY OIS schedule. Our path is a scenario: 2y +10bp, 10y +40bp.</a:t>
             </a:r>
           </a:p>
         </p:txBody>

</xml_diff>

<commit_message>
Show what each spread keeps of a 10-year-led sell-off
</commit_message>
<xml_diff>
--- a/JGB_2s10s_Steepener_Risk.pptx
+++ b/JGB_2s10s_Steepener_Risk.pptx
@@ -5820,7 +5820,7 @@
                 </a:solidFill>
                 <a:latin typeface="Arial"/>
               </a:rPr>
-              <a:t>Exhibit 5. The 2s30s stop sits inside its own noise and would have been hit 57% of the time. Ours 17%</a:t>
+              <a:t>Exhibit 5. The taper hits the 10-year. 2s10s keeps 5.1bp of every 10bp it sells off, 2s30s only 2.6bp</a:t>
             </a:r>
           </a:p>
         </p:txBody>
@@ -5862,7 +5862,7 @@
                 </a:solidFill>
                 <a:latin typeface="Arial"/>
               </a:rPr>
-              <a:t>Trade plan vs one quarter of realised volatility, bp from today</a:t>
+              <a:t>Pass-through of a 10bp 10-year-led sell-off, QT-era betas, bp</a:t>
             </a:r>
           </a:p>
         </p:txBody>
@@ -6042,16 +6042,688 @@
           </a:fontRef>
         </p:style>
       </p:cxnSp>
+      <p:sp>
+        <p:nvSpPr>
+          <p:cNvPr id="28" name="Rectangle 27"/>
+          <p:cNvSpPr/>
+          <p:nvPr/>
+        </p:nvSpPr>
+        <p:spPr>
+          <a:xfrm>
+            <a:off x="5065775" y="2002536"/>
+            <a:ext cx="1911927" cy="219456"/>
+          </a:xfrm>
+          <a:prstGeom prst="rect">
+            <a:avLst/>
+          </a:prstGeom>
+          <a:solidFill>
+            <a:srgbClr val="F4B4BB"/>
+          </a:solidFill>
+          <a:ln>
+            <a:noFill/>
+          </a:ln>
+          <a:effectLst/>
+        </p:spPr>
+        <p:style>
+          <a:lnRef idx="1">
+            <a:schemeClr val="accent1"/>
+          </a:lnRef>
+          <a:fillRef idx="3">
+            <a:schemeClr val="accent1"/>
+          </a:fillRef>
+          <a:effectRef idx="2">
+            <a:schemeClr val="accent1"/>
+          </a:effectRef>
+          <a:fontRef idx="minor">
+            <a:schemeClr val="lt1"/>
+          </a:fontRef>
+        </p:style>
+        <p:txBody>
+          <a:bodyPr rtlCol="0" anchor="ctr"/>
+          <a:lstStyle/>
+          <a:p/>
+        </p:txBody>
+      </p:sp>
+      <p:sp>
+        <p:nvSpPr>
+          <p:cNvPr id="29" name="Rectangle 28"/>
+          <p:cNvSpPr/>
+          <p:nvPr/>
+        </p:nvSpPr>
+        <p:spPr>
+          <a:xfrm>
+            <a:off x="6002620" y="2002536"/>
+            <a:ext cx="975082" cy="219456"/>
+          </a:xfrm>
+          <a:prstGeom prst="rect">
+            <a:avLst/>
+          </a:prstGeom>
+          <a:solidFill>
+            <a:srgbClr val="DB0011"/>
+          </a:solidFill>
+          <a:ln>
+            <a:noFill/>
+          </a:ln>
+          <a:effectLst/>
+        </p:spPr>
+        <p:style>
+          <a:lnRef idx="1">
+            <a:schemeClr val="accent1"/>
+          </a:lnRef>
+          <a:fillRef idx="3">
+            <a:schemeClr val="accent1"/>
+          </a:fillRef>
+          <a:effectRef idx="2">
+            <a:schemeClr val="accent1"/>
+          </a:effectRef>
+          <a:fontRef idx="minor">
+            <a:schemeClr val="lt1"/>
+          </a:fontRef>
+        </p:style>
+        <p:txBody>
+          <a:bodyPr rtlCol="0" anchor="ctr"/>
+          <a:lstStyle/>
+          <a:p/>
+        </p:txBody>
+      </p:sp>
+      <p:sp>
+        <p:nvSpPr>
+          <p:cNvPr id="30" name="Rectangle 29"/>
+          <p:cNvSpPr/>
+          <p:nvPr/>
+        </p:nvSpPr>
+        <p:spPr>
+          <a:xfrm>
+            <a:off x="5065775" y="2002536"/>
+            <a:ext cx="936844" cy="219456"/>
+          </a:xfrm>
+          <a:prstGeom prst="rect">
+            <a:avLst/>
+          </a:prstGeom>
+          <a:solidFill>
+            <a:srgbClr val="6E747A"/>
+          </a:solidFill>
+          <a:ln>
+            <a:noFill/>
+          </a:ln>
+          <a:effectLst/>
+        </p:spPr>
+        <p:style>
+          <a:lnRef idx="1">
+            <a:schemeClr val="accent1"/>
+          </a:lnRef>
+          <a:fillRef idx="3">
+            <a:schemeClr val="accent1"/>
+          </a:fillRef>
+          <a:effectRef idx="2">
+            <a:schemeClr val="accent1"/>
+          </a:effectRef>
+          <a:fontRef idx="minor">
+            <a:schemeClr val="lt1"/>
+          </a:fontRef>
+        </p:style>
+        <p:txBody>
+          <a:bodyPr rtlCol="0" anchor="ctr"/>
+          <a:lstStyle/>
+          <a:p/>
+        </p:txBody>
+      </p:sp>
+      <p:sp>
+        <p:nvSpPr>
+          <p:cNvPr id="31" name="TextBox 30"/>
+          <p:cNvSpPr txBox="1"/>
+          <p:nvPr/>
+        </p:nvSpPr>
+        <p:spPr>
+          <a:xfrm>
+            <a:off x="6374199" y="2007107"/>
+            <a:ext cx="548640" cy="210312"/>
+          </a:xfrm>
+          <a:prstGeom prst="rect">
+            <a:avLst/>
+          </a:prstGeom>
+          <a:noFill/>
+        </p:spPr>
+        <p:txBody>
+          <a:bodyPr wrap="none" lIns="0" rIns="0" tIns="0" bIns="0" anchor="t">
+            <a:spAutoFit/>
+          </a:bodyPr>
+          <a:lstStyle/>
+          <a:p>
+            <a:pPr algn="r">
+              <a:lnSpc>
+                <a:spcPct val="100000"/>
+              </a:lnSpc>
+              <a:spcAft>
+                <a:spcPts val="0"/>
+              </a:spcAft>
+            </a:pPr>
+            <a:r>
+              <a:rPr sz="850" b="1" i="0">
+                <a:solidFill>
+                  <a:srgbClr val="FFFFFF"/>
+                </a:solidFill>
+                <a:latin typeface="Arial"/>
+              </a:rPr>
+              <a:t>+5.1</a:t>
+            </a:r>
+          </a:p>
+        </p:txBody>
+      </p:sp>
+      <p:sp>
+        <p:nvSpPr>
+          <p:cNvPr id="32" name="TextBox 31"/>
+          <p:cNvSpPr txBox="1"/>
+          <p:nvPr/>
+        </p:nvSpPr>
+        <p:spPr>
+          <a:xfrm>
+            <a:off x="7032567" y="2020824"/>
+            <a:ext cx="914400" cy="164592"/>
+          </a:xfrm>
+          <a:prstGeom prst="rect">
+            <a:avLst/>
+          </a:prstGeom>
+          <a:noFill/>
+        </p:spPr>
+        <p:txBody>
+          <a:bodyPr wrap="none" lIns="0" rIns="0" tIns="0" bIns="0" anchor="t">
+            <a:spAutoFit/>
+          </a:bodyPr>
+          <a:lstStyle/>
+          <a:p>
+            <a:pPr algn="l">
+              <a:lnSpc>
+                <a:spcPct val="100000"/>
+              </a:lnSpc>
+              <a:spcAft>
+                <a:spcPts val="0"/>
+              </a:spcAft>
+            </a:pPr>
+            <a:r>
+              <a:rPr sz="700" b="0" i="0">
+                <a:solidFill>
+                  <a:srgbClr val="767576"/>
+                </a:solidFill>
+                <a:latin typeface="Arial"/>
+              </a:rPr>
+              <a:t>10y +10.0</a:t>
+            </a:r>
+          </a:p>
+        </p:txBody>
+      </p:sp>
+      <p:sp>
+        <p:nvSpPr>
+          <p:cNvPr id="33" name="TextBox 32"/>
+          <p:cNvSpPr txBox="1"/>
+          <p:nvPr/>
+        </p:nvSpPr>
+        <p:spPr>
+          <a:xfrm>
+            <a:off x="4133087" y="2007107"/>
+            <a:ext cx="877824" cy="210312"/>
+          </a:xfrm>
+          <a:prstGeom prst="rect">
+            <a:avLst/>
+          </a:prstGeom>
+          <a:noFill/>
+        </p:spPr>
+        <p:txBody>
+          <a:bodyPr wrap="none" lIns="0" rIns="0" tIns="0" bIns="0" anchor="t">
+            <a:spAutoFit/>
+          </a:bodyPr>
+          <a:lstStyle/>
+          <a:p>
+            <a:pPr algn="l">
+              <a:lnSpc>
+                <a:spcPct val="100000"/>
+              </a:lnSpc>
+              <a:spcAft>
+                <a:spcPts val="0"/>
+              </a:spcAft>
+            </a:pPr>
+            <a:r>
+              <a:rPr sz="1000" b="1" i="0">
+                <a:solidFill>
+                  <a:srgbClr val="DB0011"/>
+                </a:solidFill>
+                <a:latin typeface="Arial"/>
+              </a:rPr>
+              <a:t>JGB 2s10s</a:t>
+            </a:r>
+          </a:p>
+        </p:txBody>
+      </p:sp>
+      <p:sp>
+        <p:nvSpPr>
+          <p:cNvPr id="34" name="TextBox 33"/>
+          <p:cNvSpPr txBox="1"/>
+          <p:nvPr/>
+        </p:nvSpPr>
+        <p:spPr>
+          <a:xfrm>
+            <a:off x="7168896" y="1929384"/>
+            <a:ext cx="987552" cy="201168"/>
+          </a:xfrm>
+          <a:prstGeom prst="rect">
+            <a:avLst/>
+          </a:prstGeom>
+          <a:noFill/>
+        </p:spPr>
+        <p:txBody>
+          <a:bodyPr wrap="none" lIns="0" rIns="0" tIns="0" bIns="0" anchor="t">
+            <a:spAutoFit/>
+          </a:bodyPr>
+          <a:lstStyle/>
+          <a:p>
+            <a:pPr algn="r">
+              <a:lnSpc>
+                <a:spcPct val="100000"/>
+              </a:lnSpc>
+              <a:spcAft>
+                <a:spcPts val="0"/>
+              </a:spcAft>
+            </a:pPr>
+            <a:r>
+              <a:rPr sz="1050" b="1" i="0">
+                <a:solidFill>
+                  <a:srgbClr val="DB0011"/>
+                </a:solidFill>
+                <a:latin typeface="Arial"/>
+              </a:rPr>
+              <a:t>5.1bp</a:t>
+            </a:r>
+          </a:p>
+        </p:txBody>
+      </p:sp>
+      <p:sp>
+        <p:nvSpPr>
+          <p:cNvPr id="35" name="TextBox 34"/>
+          <p:cNvSpPr txBox="1"/>
+          <p:nvPr/>
+        </p:nvSpPr>
+        <p:spPr>
+          <a:xfrm>
+            <a:off x="7168896" y="2139696"/>
+            <a:ext cx="987552" cy="164592"/>
+          </a:xfrm>
+          <a:prstGeom prst="rect">
+            <a:avLst/>
+          </a:prstGeom>
+          <a:noFill/>
+        </p:spPr>
+        <p:txBody>
+          <a:bodyPr wrap="none" lIns="0" rIns="0" tIns="0" bIns="0" anchor="t">
+            <a:spAutoFit/>
+          </a:bodyPr>
+          <a:lstStyle/>
+          <a:p>
+            <a:pPr algn="r">
+              <a:lnSpc>
+                <a:spcPct val="100000"/>
+              </a:lnSpc>
+              <a:spcAft>
+                <a:spcPts val="0"/>
+              </a:spcAft>
+            </a:pPr>
+            <a:r>
+              <a:rPr sz="750" b="0" i="0">
+                <a:solidFill>
+                  <a:srgbClr val="767576"/>
+                </a:solidFill>
+                <a:latin typeface="Arial"/>
+              </a:rPr>
+              <a:t>kept per 10bp</a:t>
+            </a:r>
+          </a:p>
+        </p:txBody>
+      </p:sp>
+      <p:sp>
+        <p:nvSpPr>
+          <p:cNvPr id="36" name="Rectangle 35"/>
+          <p:cNvSpPr/>
+          <p:nvPr/>
+        </p:nvSpPr>
+        <p:spPr>
+          <a:xfrm>
+            <a:off x="5065775" y="2679191"/>
+            <a:ext cx="1433945" cy="219456"/>
+          </a:xfrm>
+          <a:prstGeom prst="rect">
+            <a:avLst/>
+          </a:prstGeom>
+          <a:solidFill>
+            <a:srgbClr val="D7D8D6"/>
+          </a:solidFill>
+          <a:ln>
+            <a:noFill/>
+          </a:ln>
+          <a:effectLst/>
+        </p:spPr>
+        <p:style>
+          <a:lnRef idx="1">
+            <a:schemeClr val="accent1"/>
+          </a:lnRef>
+          <a:fillRef idx="3">
+            <a:schemeClr val="accent1"/>
+          </a:fillRef>
+          <a:effectRef idx="2">
+            <a:schemeClr val="accent1"/>
+          </a:effectRef>
+          <a:fontRef idx="minor">
+            <a:schemeClr val="lt1"/>
+          </a:fontRef>
+        </p:style>
+        <p:txBody>
+          <a:bodyPr rtlCol="0" anchor="ctr"/>
+          <a:lstStyle/>
+          <a:p/>
+        </p:txBody>
+      </p:sp>
+      <p:sp>
+        <p:nvSpPr>
+          <p:cNvPr id="37" name="Rectangle 36"/>
+          <p:cNvSpPr/>
+          <p:nvPr/>
+        </p:nvSpPr>
+        <p:spPr>
+          <a:xfrm>
+            <a:off x="6002620" y="2679191"/>
+            <a:ext cx="497101" cy="219456"/>
+          </a:xfrm>
+          <a:prstGeom prst="rect">
+            <a:avLst/>
+          </a:prstGeom>
+          <a:solidFill>
+            <a:srgbClr val="44546A"/>
+          </a:solidFill>
+          <a:ln>
+            <a:noFill/>
+          </a:ln>
+          <a:effectLst/>
+        </p:spPr>
+        <p:style>
+          <a:lnRef idx="1">
+            <a:schemeClr val="accent1"/>
+          </a:lnRef>
+          <a:fillRef idx="3">
+            <a:schemeClr val="accent1"/>
+          </a:fillRef>
+          <a:effectRef idx="2">
+            <a:schemeClr val="accent1"/>
+          </a:effectRef>
+          <a:fontRef idx="minor">
+            <a:schemeClr val="lt1"/>
+          </a:fontRef>
+        </p:style>
+        <p:txBody>
+          <a:bodyPr rtlCol="0" anchor="ctr"/>
+          <a:lstStyle/>
+          <a:p/>
+        </p:txBody>
+      </p:sp>
+      <p:sp>
+        <p:nvSpPr>
+          <p:cNvPr id="38" name="Rectangle 37"/>
+          <p:cNvSpPr/>
+          <p:nvPr/>
+        </p:nvSpPr>
+        <p:spPr>
+          <a:xfrm>
+            <a:off x="5065775" y="2679191"/>
+            <a:ext cx="936844" cy="219456"/>
+          </a:xfrm>
+          <a:prstGeom prst="rect">
+            <a:avLst/>
+          </a:prstGeom>
+          <a:solidFill>
+            <a:srgbClr val="6E747A"/>
+          </a:solidFill>
+          <a:ln>
+            <a:noFill/>
+          </a:ln>
+          <a:effectLst/>
+        </p:spPr>
+        <p:style>
+          <a:lnRef idx="1">
+            <a:schemeClr val="accent1"/>
+          </a:lnRef>
+          <a:fillRef idx="3">
+            <a:schemeClr val="accent1"/>
+          </a:fillRef>
+          <a:effectRef idx="2">
+            <a:schemeClr val="accent1"/>
+          </a:effectRef>
+          <a:fontRef idx="minor">
+            <a:schemeClr val="lt1"/>
+          </a:fontRef>
+        </p:style>
+        <p:txBody>
+          <a:bodyPr rtlCol="0" anchor="ctr"/>
+          <a:lstStyle/>
+          <a:p/>
+        </p:txBody>
+      </p:sp>
+      <p:sp>
+        <p:nvSpPr>
+          <p:cNvPr id="39" name="TextBox 38"/>
+          <p:cNvSpPr txBox="1"/>
+          <p:nvPr/>
+        </p:nvSpPr>
+        <p:spPr>
+          <a:xfrm>
+            <a:off x="6554585" y="2683763"/>
+            <a:ext cx="502920" cy="210312"/>
+          </a:xfrm>
+          <a:prstGeom prst="rect">
+            <a:avLst/>
+          </a:prstGeom>
+          <a:noFill/>
+        </p:spPr>
+        <p:txBody>
+          <a:bodyPr wrap="none" lIns="0" rIns="0" tIns="0" bIns="0" anchor="t">
+            <a:spAutoFit/>
+          </a:bodyPr>
+          <a:lstStyle/>
+          <a:p>
+            <a:pPr algn="l">
+              <a:lnSpc>
+                <a:spcPct val="100000"/>
+              </a:lnSpc>
+              <a:spcAft>
+                <a:spcPts val="0"/>
+              </a:spcAft>
+            </a:pPr>
+            <a:r>
+              <a:rPr sz="850" b="1" i="0">
+                <a:solidFill>
+                  <a:srgbClr val="767576"/>
+                </a:solidFill>
+                <a:latin typeface="Arial"/>
+              </a:rPr>
+              <a:t>+2.6</a:t>
+            </a:r>
+          </a:p>
+        </p:txBody>
+      </p:sp>
+      <p:sp>
+        <p:nvSpPr>
+          <p:cNvPr id="40" name="TextBox 39"/>
+          <p:cNvSpPr txBox="1"/>
+          <p:nvPr/>
+        </p:nvSpPr>
+        <p:spPr>
+          <a:xfrm>
+            <a:off x="6938633" y="2697479"/>
+            <a:ext cx="914400" cy="164592"/>
+          </a:xfrm>
+          <a:prstGeom prst="rect">
+            <a:avLst/>
+          </a:prstGeom>
+          <a:noFill/>
+        </p:spPr>
+        <p:txBody>
+          <a:bodyPr wrap="none" lIns="0" rIns="0" tIns="0" bIns="0" anchor="t">
+            <a:spAutoFit/>
+          </a:bodyPr>
+          <a:lstStyle/>
+          <a:p>
+            <a:pPr algn="l">
+              <a:lnSpc>
+                <a:spcPct val="100000"/>
+              </a:lnSpc>
+              <a:spcAft>
+                <a:spcPts val="0"/>
+              </a:spcAft>
+            </a:pPr>
+            <a:r>
+              <a:rPr sz="700" b="0" i="0">
+                <a:solidFill>
+                  <a:srgbClr val="767576"/>
+                </a:solidFill>
+                <a:latin typeface="Arial"/>
+              </a:rPr>
+              <a:t>30y +7.5</a:t>
+            </a:r>
+          </a:p>
+        </p:txBody>
+      </p:sp>
+      <p:sp>
+        <p:nvSpPr>
+          <p:cNvPr id="41" name="TextBox 40"/>
+          <p:cNvSpPr txBox="1"/>
+          <p:nvPr/>
+        </p:nvSpPr>
+        <p:spPr>
+          <a:xfrm>
+            <a:off x="4133087" y="2683763"/>
+            <a:ext cx="877824" cy="210312"/>
+          </a:xfrm>
+          <a:prstGeom prst="rect">
+            <a:avLst/>
+          </a:prstGeom>
+          <a:noFill/>
+        </p:spPr>
+        <p:txBody>
+          <a:bodyPr wrap="none" lIns="0" rIns="0" tIns="0" bIns="0" anchor="t">
+            <a:spAutoFit/>
+          </a:bodyPr>
+          <a:lstStyle/>
+          <a:p>
+            <a:pPr algn="l">
+              <a:lnSpc>
+                <a:spcPct val="100000"/>
+              </a:lnSpc>
+              <a:spcAft>
+                <a:spcPts val="0"/>
+              </a:spcAft>
+            </a:pPr>
+            <a:r>
+              <a:rPr sz="1000" b="1" i="0">
+                <a:solidFill>
+                  <a:srgbClr val="767576"/>
+                </a:solidFill>
+                <a:latin typeface="Arial"/>
+              </a:rPr>
+              <a:t>JGB 2s30s</a:t>
+            </a:r>
+          </a:p>
+        </p:txBody>
+      </p:sp>
+      <p:sp>
+        <p:nvSpPr>
+          <p:cNvPr id="42" name="TextBox 41"/>
+          <p:cNvSpPr txBox="1"/>
+          <p:nvPr/>
+        </p:nvSpPr>
+        <p:spPr>
+          <a:xfrm>
+            <a:off x="7168896" y="2606039"/>
+            <a:ext cx="987552" cy="201168"/>
+          </a:xfrm>
+          <a:prstGeom prst="rect">
+            <a:avLst/>
+          </a:prstGeom>
+          <a:noFill/>
+        </p:spPr>
+        <p:txBody>
+          <a:bodyPr wrap="none" lIns="0" rIns="0" tIns="0" bIns="0" anchor="t">
+            <a:spAutoFit/>
+          </a:bodyPr>
+          <a:lstStyle/>
+          <a:p>
+            <a:pPr algn="r">
+              <a:lnSpc>
+                <a:spcPct val="100000"/>
+              </a:lnSpc>
+              <a:spcAft>
+                <a:spcPts val="0"/>
+              </a:spcAft>
+            </a:pPr>
+            <a:r>
+              <a:rPr sz="1050" b="0" i="0">
+                <a:solidFill>
+                  <a:srgbClr val="767576"/>
+                </a:solidFill>
+                <a:latin typeface="Arial"/>
+              </a:rPr>
+              <a:t>2.6bp</a:t>
+            </a:r>
+          </a:p>
+        </p:txBody>
+      </p:sp>
+      <p:sp>
+        <p:nvSpPr>
+          <p:cNvPr id="43" name="TextBox 42"/>
+          <p:cNvSpPr txBox="1"/>
+          <p:nvPr/>
+        </p:nvSpPr>
+        <p:spPr>
+          <a:xfrm>
+            <a:off x="7168896" y="2816351"/>
+            <a:ext cx="987552" cy="164592"/>
+          </a:xfrm>
+          <a:prstGeom prst="rect">
+            <a:avLst/>
+          </a:prstGeom>
+          <a:noFill/>
+        </p:spPr>
+        <p:txBody>
+          <a:bodyPr wrap="none" lIns="0" rIns="0" tIns="0" bIns="0" anchor="t">
+            <a:spAutoFit/>
+          </a:bodyPr>
+          <a:lstStyle/>
+          <a:p>
+            <a:pPr algn="r">
+              <a:lnSpc>
+                <a:spcPct val="100000"/>
+              </a:lnSpc>
+              <a:spcAft>
+                <a:spcPts val="0"/>
+              </a:spcAft>
+            </a:pPr>
+            <a:r>
+              <a:rPr sz="750" b="0" i="0">
+                <a:solidFill>
+                  <a:srgbClr val="767576"/>
+                </a:solidFill>
+                <a:latin typeface="Arial"/>
+              </a:rPr>
+              <a:t>kept per 10bp</a:t>
+            </a:r>
+          </a:p>
+        </p:txBody>
+      </p:sp>
       <p:cxnSp>
         <p:nvCxnSpPr>
-          <p:cNvPr id="28" name="Connector 27"/>
+          <p:cNvPr id="44" name="Connector 43"/>
           <p:cNvCxnSpPr/>
           <p:nvPr/>
         </p:nvCxnSpPr>
         <p:spPr>
           <a:xfrm>
-            <a:off x="6117336" y="1773936"/>
-            <a:ext cx="0" cy="1353312"/>
+            <a:off x="5065775" y="3127248"/>
+            <a:ext cx="2103121" cy="0"/>
           </a:xfrm>
           <a:prstGeom prst="line">
             <a:avLst/>
@@ -6079,20 +6751,230 @@
       </p:cxnSp>
       <p:sp>
         <p:nvSpPr>
-          <p:cNvPr id="29" name="Rectangle 28"/>
+          <p:cNvPr id="45" name="TextBox 44"/>
+          <p:cNvSpPr txBox="1"/>
+          <p:nvPr/>
+        </p:nvSpPr>
+        <p:spPr>
+          <a:xfrm>
+            <a:off x="4791455" y="3163824"/>
+            <a:ext cx="548640" cy="164592"/>
+          </a:xfrm>
+          <a:prstGeom prst="rect">
+            <a:avLst/>
+          </a:prstGeom>
+          <a:noFill/>
+        </p:spPr>
+        <p:txBody>
+          <a:bodyPr wrap="none" lIns="0" rIns="0" tIns="0" bIns="0" anchor="t">
+            <a:spAutoFit/>
+          </a:bodyPr>
+          <a:lstStyle/>
+          <a:p>
+            <a:pPr algn="ctr">
+              <a:lnSpc>
+                <a:spcPct val="100000"/>
+              </a:lnSpc>
+              <a:spcAft>
+                <a:spcPts val="0"/>
+              </a:spcAft>
+            </a:pPr>
+            <a:r>
+              <a:rPr sz="800" b="0" i="0">
+                <a:solidFill>
+                  <a:srgbClr val="767576"/>
+                </a:solidFill>
+                <a:latin typeface="Arial"/>
+              </a:rPr>
+              <a:t>0</a:t>
+            </a:r>
+          </a:p>
+        </p:txBody>
+      </p:sp>
+      <p:sp>
+        <p:nvSpPr>
+          <p:cNvPr id="46" name="TextBox 45"/>
+          <p:cNvSpPr txBox="1"/>
+          <p:nvPr/>
+        </p:nvSpPr>
+        <p:spPr>
+          <a:xfrm>
+            <a:off x="5317236" y="3163824"/>
+            <a:ext cx="548640" cy="164592"/>
+          </a:xfrm>
+          <a:prstGeom prst="rect">
+            <a:avLst/>
+          </a:prstGeom>
+          <a:noFill/>
+        </p:spPr>
+        <p:txBody>
+          <a:bodyPr wrap="none" lIns="0" rIns="0" tIns="0" bIns="0" anchor="t">
+            <a:spAutoFit/>
+          </a:bodyPr>
+          <a:lstStyle/>
+          <a:p>
+            <a:pPr algn="ctr">
+              <a:lnSpc>
+                <a:spcPct val="100000"/>
+              </a:lnSpc>
+              <a:spcAft>
+                <a:spcPts val="0"/>
+              </a:spcAft>
+            </a:pPr>
+            <a:r>
+              <a:rPr sz="800" b="0" i="0">
+                <a:solidFill>
+                  <a:srgbClr val="767576"/>
+                </a:solidFill>
+                <a:latin typeface="Arial"/>
+              </a:rPr>
+              <a:t>2.5</a:t>
+            </a:r>
+          </a:p>
+        </p:txBody>
+      </p:sp>
+      <p:sp>
+        <p:nvSpPr>
+          <p:cNvPr id="47" name="TextBox 46"/>
+          <p:cNvSpPr txBox="1"/>
+          <p:nvPr/>
+        </p:nvSpPr>
+        <p:spPr>
+          <a:xfrm>
+            <a:off x="5843016" y="3163824"/>
+            <a:ext cx="548640" cy="164592"/>
+          </a:xfrm>
+          <a:prstGeom prst="rect">
+            <a:avLst/>
+          </a:prstGeom>
+          <a:noFill/>
+        </p:spPr>
+        <p:txBody>
+          <a:bodyPr wrap="none" lIns="0" rIns="0" tIns="0" bIns="0" anchor="t">
+            <a:spAutoFit/>
+          </a:bodyPr>
+          <a:lstStyle/>
+          <a:p>
+            <a:pPr algn="ctr">
+              <a:lnSpc>
+                <a:spcPct val="100000"/>
+              </a:lnSpc>
+              <a:spcAft>
+                <a:spcPts val="0"/>
+              </a:spcAft>
+            </a:pPr>
+            <a:r>
+              <a:rPr sz="800" b="0" i="0">
+                <a:solidFill>
+                  <a:srgbClr val="767576"/>
+                </a:solidFill>
+                <a:latin typeface="Arial"/>
+              </a:rPr>
+              <a:t>5</a:t>
+            </a:r>
+          </a:p>
+        </p:txBody>
+      </p:sp>
+      <p:sp>
+        <p:nvSpPr>
+          <p:cNvPr id="48" name="TextBox 47"/>
+          <p:cNvSpPr txBox="1"/>
+          <p:nvPr/>
+        </p:nvSpPr>
+        <p:spPr>
+          <a:xfrm>
+            <a:off x="6368795" y="3163824"/>
+            <a:ext cx="548640" cy="164592"/>
+          </a:xfrm>
+          <a:prstGeom prst="rect">
+            <a:avLst/>
+          </a:prstGeom>
+          <a:noFill/>
+        </p:spPr>
+        <p:txBody>
+          <a:bodyPr wrap="none" lIns="0" rIns="0" tIns="0" bIns="0" anchor="t">
+            <a:spAutoFit/>
+          </a:bodyPr>
+          <a:lstStyle/>
+          <a:p>
+            <a:pPr algn="ctr">
+              <a:lnSpc>
+                <a:spcPct val="100000"/>
+              </a:lnSpc>
+              <a:spcAft>
+                <a:spcPts val="0"/>
+              </a:spcAft>
+            </a:pPr>
+            <a:r>
+              <a:rPr sz="800" b="0" i="0">
+                <a:solidFill>
+                  <a:srgbClr val="767576"/>
+                </a:solidFill>
+                <a:latin typeface="Arial"/>
+              </a:rPr>
+              <a:t>7.5</a:t>
+            </a:r>
+          </a:p>
+        </p:txBody>
+      </p:sp>
+      <p:sp>
+        <p:nvSpPr>
+          <p:cNvPr id="49" name="TextBox 48"/>
+          <p:cNvSpPr txBox="1"/>
+          <p:nvPr/>
+        </p:nvSpPr>
+        <p:spPr>
+          <a:xfrm>
+            <a:off x="6894576" y="3163824"/>
+            <a:ext cx="548640" cy="164592"/>
+          </a:xfrm>
+          <a:prstGeom prst="rect">
+            <a:avLst/>
+          </a:prstGeom>
+          <a:noFill/>
+        </p:spPr>
+        <p:txBody>
+          <a:bodyPr wrap="none" lIns="0" rIns="0" tIns="0" bIns="0" anchor="t">
+            <a:spAutoFit/>
+          </a:bodyPr>
+          <a:lstStyle/>
+          <a:p>
+            <a:pPr algn="ctr">
+              <a:lnSpc>
+                <a:spcPct val="100000"/>
+              </a:lnSpc>
+              <a:spcAft>
+                <a:spcPts val="0"/>
+              </a:spcAft>
+            </a:pPr>
+            <a:r>
+              <a:rPr sz="800" b="0" i="0">
+                <a:solidFill>
+                  <a:srgbClr val="767576"/>
+                </a:solidFill>
+                <a:latin typeface="Arial"/>
+              </a:rPr>
+              <a:t>10</a:t>
+            </a:r>
+          </a:p>
+        </p:txBody>
+      </p:sp>
+      <p:sp>
+        <p:nvSpPr>
+          <p:cNvPr id="50" name="Rectangle 49"/>
           <p:cNvSpPr/>
           <p:nvPr/>
         </p:nvSpPr>
         <p:spPr>
           <a:xfrm>
-            <a:off x="5701969" y="1993392"/>
-            <a:ext cx="830732" cy="237744"/>
+            <a:off x="4133087" y="3387851"/>
+            <a:ext cx="182880" cy="100584"/>
           </a:xfrm>
           <a:prstGeom prst="rect">
             <a:avLst/>
           </a:prstGeom>
           <a:solidFill>
-            <a:srgbClr val="D7D8D6"/>
+            <a:srgbClr val="6E747A"/>
           </a:solidFill>
           <a:ln>
             <a:noFill/>
@@ -6121,20 +7003,62 @@
       </p:sp>
       <p:sp>
         <p:nvSpPr>
-          <p:cNvPr id="30" name="Rectangle 29"/>
+          <p:cNvPr id="51" name="TextBox 50"/>
+          <p:cNvSpPr txBox="1"/>
+          <p:nvPr/>
+        </p:nvSpPr>
+        <p:spPr>
+          <a:xfrm>
+            <a:off x="4370831" y="3346703"/>
+            <a:ext cx="2224552" cy="182880"/>
+          </a:xfrm>
+          <a:prstGeom prst="rect">
+            <a:avLst/>
+          </a:prstGeom>
+          <a:noFill/>
+        </p:spPr>
+        <p:txBody>
+          <a:bodyPr wrap="none" lIns="0" rIns="0" tIns="0" bIns="0" anchor="t">
+            <a:spAutoFit/>
+          </a:bodyPr>
+          <a:lstStyle/>
+          <a:p>
+            <a:pPr algn="l">
+              <a:lnSpc>
+                <a:spcPct val="100000"/>
+              </a:lnSpc>
+              <a:spcAft>
+                <a:spcPts val="0"/>
+              </a:spcAft>
+            </a:pPr>
+            <a:r>
+              <a:rPr sz="800" b="0" i="0">
+                <a:solidFill>
+                  <a:srgbClr val="767576"/>
+                </a:solidFill>
+                <a:latin typeface="Arial"/>
+              </a:rPr>
+              <a:t>Given back as the 2y follows, 0.49</a:t>
+            </a:r>
+          </a:p>
+        </p:txBody>
+      </p:sp>
+      <p:sp>
+        <p:nvSpPr>
+          <p:cNvPr id="52" name="Rectangle 51"/>
           <p:cNvSpPr/>
           <p:nvPr/>
         </p:nvSpPr>
         <p:spPr>
           <a:xfrm>
-            <a:off x="5279974" y="1956816"/>
-            <a:ext cx="23774" cy="310896"/>
+            <a:off x="6650248" y="3364991"/>
+            <a:ext cx="23774" cy="146304"/>
           </a:xfrm>
           <a:prstGeom prst="rect">
             <a:avLst/>
           </a:prstGeom>
           <a:solidFill>
-            <a:srgbClr val="44546A"/>
+            <a:srgbClr val="DB0011"/>
           </a:solidFill>
           <a:ln>
             <a:noFill/>
@@ -6163,140 +7087,14 @@
       </p:sp>
       <p:sp>
         <p:nvSpPr>
-          <p:cNvPr id="31" name="Rectangle 30"/>
-          <p:cNvSpPr/>
-          <p:nvPr/>
-        </p:nvSpPr>
-        <p:spPr>
-          <a:xfrm>
-            <a:off x="6909892" y="1956816"/>
-            <a:ext cx="23774" cy="310896"/>
-          </a:xfrm>
-          <a:prstGeom prst="rect">
-            <a:avLst/>
-          </a:prstGeom>
-          <a:solidFill>
-            <a:srgbClr val="DB0011"/>
-          </a:solidFill>
-          <a:ln>
-            <a:noFill/>
-          </a:ln>
-          <a:effectLst/>
-        </p:spPr>
-        <p:style>
-          <a:lnRef idx="1">
-            <a:schemeClr val="accent1"/>
-          </a:lnRef>
-          <a:fillRef idx="3">
-            <a:schemeClr val="accent1"/>
-          </a:fillRef>
-          <a:effectRef idx="2">
-            <a:schemeClr val="accent1"/>
-          </a:effectRef>
-          <a:fontRef idx="minor">
-            <a:schemeClr val="lt1"/>
-          </a:fontRef>
-        </p:style>
-        <p:txBody>
-          <a:bodyPr rtlCol="0" anchor="ctr"/>
-          <a:lstStyle/>
-          <a:p/>
-        </p:txBody>
-      </p:sp>
-      <p:sp>
-        <p:nvSpPr>
-          <p:cNvPr id="32" name="TextBox 31"/>
+          <p:cNvPr id="53" name="TextBox 52"/>
           <p:cNvSpPr txBox="1"/>
           <p:nvPr/>
         </p:nvSpPr>
         <p:spPr>
           <a:xfrm>
-            <a:off x="6345936" y="1769364"/>
-            <a:ext cx="822960" cy="164592"/>
-          </a:xfrm>
-          <a:prstGeom prst="rect">
-            <a:avLst/>
-          </a:prstGeom>
-          <a:noFill/>
-        </p:spPr>
-        <p:txBody>
-          <a:bodyPr wrap="none" lIns="0" rIns="0" tIns="0" bIns="0" anchor="t">
-            <a:spAutoFit/>
-          </a:bodyPr>
-          <a:lstStyle/>
-          <a:p>
-            <a:pPr algn="ctr">
-              <a:lnSpc>
-                <a:spcPct val="100000"/>
-              </a:lnSpc>
-              <a:spcAft>
-                <a:spcPts val="0"/>
-              </a:spcAft>
-            </a:pPr>
-            <a:r>
-              <a:rPr sz="700" b="1" i="0">
-                <a:solidFill>
-                  <a:srgbClr val="DB0011"/>
-                </a:solidFill>
-                <a:latin typeface="Arial"/>
-              </a:rPr>
-              <a:t>target 160</a:t>
-            </a:r>
-          </a:p>
-        </p:txBody>
-      </p:sp>
-      <p:sp>
-        <p:nvSpPr>
-          <p:cNvPr id="33" name="TextBox 32"/>
-          <p:cNvSpPr txBox="1"/>
-          <p:nvPr/>
-        </p:nvSpPr>
-        <p:spPr>
-          <a:xfrm>
-            <a:off x="5065775" y="2286000"/>
-            <a:ext cx="822960" cy="164592"/>
-          </a:xfrm>
-          <a:prstGeom prst="rect">
-            <a:avLst/>
-          </a:prstGeom>
-          <a:noFill/>
-        </p:spPr>
-        <p:txBody>
-          <a:bodyPr wrap="none" lIns="0" rIns="0" tIns="0" bIns="0" anchor="t">
-            <a:spAutoFit/>
-          </a:bodyPr>
-          <a:lstStyle/>
-          <a:p>
-            <a:pPr algn="ctr">
-              <a:lnSpc>
-                <a:spcPct val="100000"/>
-              </a:lnSpc>
-              <a:spcAft>
-                <a:spcPts val="0"/>
-              </a:spcAft>
-            </a:pPr>
-            <a:r>
-              <a:rPr sz="700" b="0" i="0">
-                <a:solidFill>
-                  <a:srgbClr val="767576"/>
-                </a:solidFill>
-                <a:latin typeface="Arial"/>
-              </a:rPr>
-              <a:t>stop 98</a:t>
-            </a:r>
-          </a:p>
-        </p:txBody>
-      </p:sp>
-      <p:sp>
-        <p:nvSpPr>
-          <p:cNvPr id="34" name="TextBox 33"/>
-          <p:cNvSpPr txBox="1"/>
-          <p:nvPr/>
-        </p:nvSpPr>
-        <p:spPr>
-          <a:xfrm>
-            <a:off x="4133087" y="2007107"/>
-            <a:ext cx="877824" cy="210312"/>
+            <a:off x="6728886" y="3346703"/>
+            <a:ext cx="1409273" cy="182880"/>
           </a:xfrm>
           <a:prstGeom prst="rect">
             <a:avLst/>
@@ -6318,27 +7116,27 @@
               </a:spcAft>
             </a:pPr>
             <a:r>
-              <a:rPr sz="1000" b="1" i="0">
+              <a:rPr sz="800" b="0" i="0">
                 <a:solidFill>
-                  <a:srgbClr val="DB0011"/>
+                  <a:srgbClr val="767576"/>
                 </a:solidFill>
                 <a:latin typeface="Arial"/>
               </a:rPr>
-              <a:t>JGB 2s10s</a:t>
-            </a:r>
-          </a:p>
-        </p:txBody>
-      </p:sp>
-      <p:sp>
-        <p:nvSpPr>
-          <p:cNvPr id="35" name="TextBox 34"/>
+              <a:t>Kept</a:t>
+            </a:r>
+          </a:p>
+        </p:txBody>
+      </p:sp>
+      <p:sp>
+        <p:nvSpPr>
+          <p:cNvPr id="54" name="TextBox 53"/>
           <p:cNvSpPr txBox="1"/>
           <p:nvPr/>
         </p:nvSpPr>
         <p:spPr>
           <a:xfrm>
-            <a:off x="7168896" y="1929384"/>
-            <a:ext cx="987552" cy="201168"/>
+            <a:off x="6236207" y="3584448"/>
+            <a:ext cx="914400" cy="164592"/>
           </a:xfrm>
           <a:prstGeom prst="rect">
             <a:avLst/>
@@ -6360,27 +7158,27 @@
               </a:spcAft>
             </a:pPr>
             <a:r>
-              <a:rPr sz="1050" b="1" i="0">
+              <a:rPr sz="850" b="1" i="0">
                 <a:solidFill>
                   <a:srgbClr val="DB0011"/>
                 </a:solidFill>
                 <a:latin typeface="Arial"/>
               </a:rPr>
-              <a:t>17%</a:t>
-            </a:r>
-          </a:p>
-        </p:txBody>
-      </p:sp>
-      <p:sp>
-        <p:nvSpPr>
-          <p:cNvPr id="36" name="TextBox 35"/>
+              <a:t>2s10s</a:t>
+            </a:r>
+          </a:p>
+        </p:txBody>
+      </p:sp>
+      <p:sp>
+        <p:nvSpPr>
+          <p:cNvPr id="55" name="TextBox 54"/>
           <p:cNvSpPr txBox="1"/>
           <p:nvPr/>
         </p:nvSpPr>
         <p:spPr>
           <a:xfrm>
-            <a:off x="7168896" y="2139696"/>
-            <a:ext cx="987552" cy="164592"/>
+            <a:off x="7150607" y="3584448"/>
+            <a:ext cx="914400" cy="164592"/>
           </a:xfrm>
           <a:prstGeom prst="rect">
             <a:avLst/>
@@ -6402,363 +7200,27 @@
               </a:spcAft>
             </a:pPr>
             <a:r>
-              <a:rPr sz="750" b="0" i="0">
+              <a:rPr sz="850" b="1" i="0">
                 <a:solidFill>
                   <a:srgbClr val="767576"/>
                 </a:solidFill>
                 <a:latin typeface="Arial"/>
               </a:rPr>
-              <a:t>of entries stopped out</a:t>
-            </a:r>
-          </a:p>
-        </p:txBody>
-      </p:sp>
-      <p:sp>
-        <p:nvSpPr>
-          <p:cNvPr id="37" name="Rectangle 36"/>
-          <p:cNvSpPr/>
-          <p:nvPr/>
-        </p:nvSpPr>
-        <p:spPr>
-          <a:xfrm>
-            <a:off x="5499544" y="2670048"/>
-            <a:ext cx="1235583" cy="237744"/>
-          </a:xfrm>
-          <a:prstGeom prst="rect">
-            <a:avLst/>
-          </a:prstGeom>
-          <a:solidFill>
-            <a:srgbClr val="D7D8D6"/>
-          </a:solidFill>
-          <a:ln>
-            <a:noFill/>
-          </a:ln>
-          <a:effectLst/>
-        </p:spPr>
-        <p:style>
-          <a:lnRef idx="1">
-            <a:schemeClr val="accent1"/>
-          </a:lnRef>
-          <a:fillRef idx="3">
-            <a:schemeClr val="accent1"/>
-          </a:fillRef>
-          <a:effectRef idx="2">
-            <a:schemeClr val="accent1"/>
-          </a:effectRef>
-          <a:fontRef idx="minor">
-            <a:schemeClr val="lt1"/>
-          </a:fontRef>
-        </p:style>
-        <p:txBody>
-          <a:bodyPr rtlCol="0" anchor="ctr"/>
-          <a:lstStyle/>
-          <a:p/>
-        </p:txBody>
-      </p:sp>
-      <p:sp>
-        <p:nvSpPr>
-          <p:cNvPr id="38" name="Rectangle 37"/>
-          <p:cNvSpPr/>
-          <p:nvPr/>
-        </p:nvSpPr>
-        <p:spPr>
-          <a:xfrm>
-            <a:off x="5697969" y="2633472"/>
-            <a:ext cx="23774" cy="310896"/>
-          </a:xfrm>
-          <a:prstGeom prst="rect">
-            <a:avLst/>
-          </a:prstGeom>
-          <a:solidFill>
-            <a:srgbClr val="44546A"/>
-          </a:solidFill>
-          <a:ln>
-            <a:noFill/>
-          </a:ln>
-          <a:effectLst/>
-        </p:spPr>
-        <p:style>
-          <a:lnRef idx="1">
-            <a:schemeClr val="accent1"/>
-          </a:lnRef>
-          <a:fillRef idx="3">
-            <a:schemeClr val="accent1"/>
-          </a:fillRef>
-          <a:effectRef idx="2">
-            <a:schemeClr val="accent1"/>
-          </a:effectRef>
-          <a:fontRef idx="minor">
-            <a:schemeClr val="lt1"/>
-          </a:fontRef>
-        </p:style>
-        <p:txBody>
-          <a:bodyPr rtlCol="0" anchor="ctr"/>
-          <a:lstStyle/>
-          <a:p/>
-        </p:txBody>
-      </p:sp>
-      <p:sp>
-        <p:nvSpPr>
-          <p:cNvPr id="39" name="Rectangle 38"/>
-          <p:cNvSpPr/>
-          <p:nvPr/>
-        </p:nvSpPr>
-        <p:spPr>
-          <a:xfrm>
-            <a:off x="6381483" y="2633472"/>
-            <a:ext cx="23774" cy="310896"/>
-          </a:xfrm>
-          <a:prstGeom prst="rect">
-            <a:avLst/>
-          </a:prstGeom>
-          <a:solidFill>
-            <a:srgbClr val="DB0011"/>
-          </a:solidFill>
-          <a:ln>
-            <a:noFill/>
-          </a:ln>
-          <a:effectLst/>
-        </p:spPr>
-        <p:style>
-          <a:lnRef idx="1">
-            <a:schemeClr val="accent1"/>
-          </a:lnRef>
-          <a:fillRef idx="3">
-            <a:schemeClr val="accent1"/>
-          </a:fillRef>
-          <a:effectRef idx="2">
-            <a:schemeClr val="accent1"/>
-          </a:effectRef>
-          <a:fontRef idx="minor">
-            <a:schemeClr val="lt1"/>
-          </a:fontRef>
-        </p:style>
-        <p:txBody>
-          <a:bodyPr rtlCol="0" anchor="ctr"/>
-          <a:lstStyle/>
-          <a:p/>
-        </p:txBody>
-      </p:sp>
-      <p:sp>
-        <p:nvSpPr>
-          <p:cNvPr id="40" name="TextBox 39"/>
-          <p:cNvSpPr txBox="1"/>
-          <p:nvPr/>
-        </p:nvSpPr>
-        <p:spPr>
-          <a:xfrm>
-            <a:off x="5981890" y="2446020"/>
-            <a:ext cx="822960" cy="164592"/>
-          </a:xfrm>
-          <a:prstGeom prst="rect">
-            <a:avLst/>
-          </a:prstGeom>
-          <a:noFill/>
-        </p:spPr>
-        <p:txBody>
-          <a:bodyPr wrap="none" lIns="0" rIns="0" tIns="0" bIns="0" anchor="t">
-            <a:spAutoFit/>
-          </a:bodyPr>
-          <a:lstStyle/>
-          <a:p>
-            <a:pPr algn="ctr">
-              <a:lnSpc>
-                <a:spcPct val="100000"/>
-              </a:lnSpc>
-              <a:spcAft>
-                <a:spcPts val="0"/>
-              </a:spcAft>
-            </a:pPr>
-            <a:r>
-              <a:rPr sz="700" b="1" i="0">
-                <a:solidFill>
-                  <a:srgbClr val="DB0011"/>
-                </a:solidFill>
-                <a:latin typeface="Arial"/>
-              </a:rPr>
-              <a:t>target 258</a:t>
-            </a:r>
-          </a:p>
-        </p:txBody>
-      </p:sp>
-      <p:sp>
-        <p:nvSpPr>
-          <p:cNvPr id="41" name="TextBox 40"/>
-          <p:cNvSpPr txBox="1"/>
-          <p:nvPr/>
-        </p:nvSpPr>
-        <p:spPr>
-          <a:xfrm>
-            <a:off x="5298376" y="2962656"/>
-            <a:ext cx="822960" cy="164592"/>
-          </a:xfrm>
-          <a:prstGeom prst="rect">
-            <a:avLst/>
-          </a:prstGeom>
-          <a:noFill/>
-        </p:spPr>
-        <p:txBody>
-          <a:bodyPr wrap="none" lIns="0" rIns="0" tIns="0" bIns="0" anchor="t">
-            <a:spAutoFit/>
-          </a:bodyPr>
-          <a:lstStyle/>
-          <a:p>
-            <a:pPr algn="ctr">
-              <a:lnSpc>
-                <a:spcPct val="100000"/>
-              </a:lnSpc>
-              <a:spcAft>
-                <a:spcPts val="0"/>
-              </a:spcAft>
-            </a:pPr>
-            <a:r>
-              <a:rPr sz="700" b="0" i="0">
-                <a:solidFill>
-                  <a:srgbClr val="767576"/>
-                </a:solidFill>
-                <a:latin typeface="Arial"/>
-              </a:rPr>
-              <a:t>stop 232</a:t>
-            </a:r>
-          </a:p>
-        </p:txBody>
-      </p:sp>
-      <p:sp>
-        <p:nvSpPr>
-          <p:cNvPr id="42" name="TextBox 41"/>
-          <p:cNvSpPr txBox="1"/>
-          <p:nvPr/>
-        </p:nvSpPr>
-        <p:spPr>
-          <a:xfrm>
-            <a:off x="4133087" y="2683763"/>
-            <a:ext cx="877824" cy="210312"/>
-          </a:xfrm>
-          <a:prstGeom prst="rect">
-            <a:avLst/>
-          </a:prstGeom>
-          <a:noFill/>
-        </p:spPr>
-        <p:txBody>
-          <a:bodyPr wrap="none" lIns="0" rIns="0" tIns="0" bIns="0" anchor="t">
-            <a:spAutoFit/>
-          </a:bodyPr>
-          <a:lstStyle/>
-          <a:p>
-            <a:pPr algn="l">
-              <a:lnSpc>
-                <a:spcPct val="100000"/>
-              </a:lnSpc>
-              <a:spcAft>
-                <a:spcPts val="0"/>
-              </a:spcAft>
-            </a:pPr>
-            <a:r>
-              <a:rPr sz="1000" b="1" i="0">
-                <a:solidFill>
-                  <a:srgbClr val="767576"/>
-                </a:solidFill>
-                <a:latin typeface="Arial"/>
-              </a:rPr>
-              <a:t>JGB 2s30s</a:t>
-            </a:r>
-          </a:p>
-        </p:txBody>
-      </p:sp>
-      <p:sp>
-        <p:nvSpPr>
-          <p:cNvPr id="43" name="TextBox 42"/>
-          <p:cNvSpPr txBox="1"/>
-          <p:nvPr/>
-        </p:nvSpPr>
-        <p:spPr>
-          <a:xfrm>
-            <a:off x="7168896" y="2606039"/>
-            <a:ext cx="987552" cy="201168"/>
-          </a:xfrm>
-          <a:prstGeom prst="rect">
-            <a:avLst/>
-          </a:prstGeom>
-          <a:noFill/>
-        </p:spPr>
-        <p:txBody>
-          <a:bodyPr wrap="none" lIns="0" rIns="0" tIns="0" bIns="0" anchor="t">
-            <a:spAutoFit/>
-          </a:bodyPr>
-          <a:lstStyle/>
-          <a:p>
-            <a:pPr algn="r">
-              <a:lnSpc>
-                <a:spcPct val="100000"/>
-              </a:lnSpc>
-              <a:spcAft>
-                <a:spcPts val="0"/>
-              </a:spcAft>
-            </a:pPr>
-            <a:r>
-              <a:rPr sz="1050" b="0" i="0">
-                <a:solidFill>
-                  <a:srgbClr val="767576"/>
-                </a:solidFill>
-                <a:latin typeface="Arial"/>
-              </a:rPr>
-              <a:t>57%</a:t>
-            </a:r>
-          </a:p>
-        </p:txBody>
-      </p:sp>
-      <p:sp>
-        <p:nvSpPr>
-          <p:cNvPr id="44" name="TextBox 43"/>
-          <p:cNvSpPr txBox="1"/>
-          <p:nvPr/>
-        </p:nvSpPr>
-        <p:spPr>
-          <a:xfrm>
-            <a:off x="7168896" y="2816351"/>
-            <a:ext cx="987552" cy="164592"/>
-          </a:xfrm>
-          <a:prstGeom prst="rect">
-            <a:avLst/>
-          </a:prstGeom>
-          <a:noFill/>
-        </p:spPr>
-        <p:txBody>
-          <a:bodyPr wrap="none" lIns="0" rIns="0" tIns="0" bIns="0" anchor="t">
-            <a:spAutoFit/>
-          </a:bodyPr>
-          <a:lstStyle/>
-          <a:p>
-            <a:pPr algn="r">
-              <a:lnSpc>
-                <a:spcPct val="100000"/>
-              </a:lnSpc>
-              <a:spcAft>
-                <a:spcPts val="0"/>
-              </a:spcAft>
-            </a:pPr>
-            <a:r>
-              <a:rPr sz="750" b="0" i="0">
-                <a:solidFill>
-                  <a:srgbClr val="767576"/>
-                </a:solidFill>
-                <a:latin typeface="Arial"/>
-              </a:rPr>
-              <a:t>of entries stopped out</a:t>
+              <a:t>2s30s</a:t>
             </a:r>
           </a:p>
         </p:txBody>
       </p:sp>
       <p:cxnSp>
         <p:nvCxnSpPr>
-          <p:cNvPr id="45" name="Connector 44"/>
+          <p:cNvPr id="56" name="Connector 55"/>
           <p:cNvCxnSpPr/>
           <p:nvPr/>
         </p:nvCxnSpPr>
         <p:spPr>
           <a:xfrm>
-            <a:off x="5065775" y="3127248"/>
-            <a:ext cx="2103121" cy="0"/>
+            <a:off x="4133087" y="3767328"/>
+            <a:ext cx="3931921" cy="0"/>
           </a:xfrm>
           <a:prstGeom prst="line">
             <a:avLst/>
@@ -6786,266 +7248,14 @@
       </p:cxnSp>
       <p:sp>
         <p:nvSpPr>
-          <p:cNvPr id="46" name="TextBox 45"/>
+          <p:cNvPr id="57" name="TextBox 56"/>
           <p:cNvSpPr txBox="1"/>
           <p:nvPr/>
         </p:nvSpPr>
         <p:spPr>
           <a:xfrm>
-            <a:off x="4791455" y="3163824"/>
-            <a:ext cx="548640" cy="164592"/>
-          </a:xfrm>
-          <a:prstGeom prst="rect">
-            <a:avLst/>
-          </a:prstGeom>
-          <a:noFill/>
-        </p:spPr>
-        <p:txBody>
-          <a:bodyPr wrap="none" lIns="0" rIns="0" tIns="0" bIns="0" anchor="t">
-            <a:spAutoFit/>
-          </a:bodyPr>
-          <a:lstStyle/>
-          <a:p>
-            <a:pPr algn="ctr">
-              <a:lnSpc>
-                <a:spcPct val="100000"/>
-              </a:lnSpc>
-              <a:spcAft>
-                <a:spcPts val="0"/>
-              </a:spcAft>
-            </a:pPr>
-            <a:r>
-              <a:rPr sz="800" b="0" i="0">
-                <a:solidFill>
-                  <a:srgbClr val="767576"/>
-                </a:solidFill>
-                <a:latin typeface="Arial"/>
-              </a:rPr>
-              <a:t>−40</a:t>
-            </a:r>
-          </a:p>
-        </p:txBody>
-      </p:sp>
-      <p:sp>
-        <p:nvSpPr>
-          <p:cNvPr id="47" name="TextBox 46"/>
-          <p:cNvSpPr txBox="1"/>
-          <p:nvPr/>
-        </p:nvSpPr>
-        <p:spPr>
-          <a:xfrm>
-            <a:off x="5317236" y="3163824"/>
-            <a:ext cx="548640" cy="164592"/>
-          </a:xfrm>
-          <a:prstGeom prst="rect">
-            <a:avLst/>
-          </a:prstGeom>
-          <a:noFill/>
-        </p:spPr>
-        <p:txBody>
-          <a:bodyPr wrap="none" lIns="0" rIns="0" tIns="0" bIns="0" anchor="t">
-            <a:spAutoFit/>
-          </a:bodyPr>
-          <a:lstStyle/>
-          <a:p>
-            <a:pPr algn="ctr">
-              <a:lnSpc>
-                <a:spcPct val="100000"/>
-              </a:lnSpc>
-              <a:spcAft>
-                <a:spcPts val="0"/>
-              </a:spcAft>
-            </a:pPr>
-            <a:r>
-              <a:rPr sz="800" b="0" i="0">
-                <a:solidFill>
-                  <a:srgbClr val="767576"/>
-                </a:solidFill>
-                <a:latin typeface="Arial"/>
-              </a:rPr>
-              <a:t>−20</a:t>
-            </a:r>
-          </a:p>
-        </p:txBody>
-      </p:sp>
-      <p:sp>
-        <p:nvSpPr>
-          <p:cNvPr id="48" name="TextBox 47"/>
-          <p:cNvSpPr txBox="1"/>
-          <p:nvPr/>
-        </p:nvSpPr>
-        <p:spPr>
-          <a:xfrm>
-            <a:off x="5843016" y="3163824"/>
-            <a:ext cx="548640" cy="164592"/>
-          </a:xfrm>
-          <a:prstGeom prst="rect">
-            <a:avLst/>
-          </a:prstGeom>
-          <a:noFill/>
-        </p:spPr>
-        <p:txBody>
-          <a:bodyPr wrap="none" lIns="0" rIns="0" tIns="0" bIns="0" anchor="t">
-            <a:spAutoFit/>
-          </a:bodyPr>
-          <a:lstStyle/>
-          <a:p>
-            <a:pPr algn="ctr">
-              <a:lnSpc>
-                <a:spcPct val="100000"/>
-              </a:lnSpc>
-              <a:spcAft>
-                <a:spcPts val="0"/>
-              </a:spcAft>
-            </a:pPr>
-            <a:r>
-              <a:rPr sz="800" b="0" i="0">
-                <a:solidFill>
-                  <a:srgbClr val="767576"/>
-                </a:solidFill>
-                <a:latin typeface="Arial"/>
-              </a:rPr>
-              <a:t>0</a:t>
-            </a:r>
-          </a:p>
-        </p:txBody>
-      </p:sp>
-      <p:sp>
-        <p:nvSpPr>
-          <p:cNvPr id="49" name="TextBox 48"/>
-          <p:cNvSpPr txBox="1"/>
-          <p:nvPr/>
-        </p:nvSpPr>
-        <p:spPr>
-          <a:xfrm>
-            <a:off x="6368795" y="3163824"/>
-            <a:ext cx="548640" cy="164592"/>
-          </a:xfrm>
-          <a:prstGeom prst="rect">
-            <a:avLst/>
-          </a:prstGeom>
-          <a:noFill/>
-        </p:spPr>
-        <p:txBody>
-          <a:bodyPr wrap="none" lIns="0" rIns="0" tIns="0" bIns="0" anchor="t">
-            <a:spAutoFit/>
-          </a:bodyPr>
-          <a:lstStyle/>
-          <a:p>
-            <a:pPr algn="ctr">
-              <a:lnSpc>
-                <a:spcPct val="100000"/>
-              </a:lnSpc>
-              <a:spcAft>
-                <a:spcPts val="0"/>
-              </a:spcAft>
-            </a:pPr>
-            <a:r>
-              <a:rPr sz="800" b="0" i="0">
-                <a:solidFill>
-                  <a:srgbClr val="767576"/>
-                </a:solidFill>
-                <a:latin typeface="Arial"/>
-              </a:rPr>
-              <a:t>+20</a:t>
-            </a:r>
-          </a:p>
-        </p:txBody>
-      </p:sp>
-      <p:sp>
-        <p:nvSpPr>
-          <p:cNvPr id="50" name="TextBox 49"/>
-          <p:cNvSpPr txBox="1"/>
-          <p:nvPr/>
-        </p:nvSpPr>
-        <p:spPr>
-          <a:xfrm>
-            <a:off x="6894576" y="3163824"/>
-            <a:ext cx="548640" cy="164592"/>
-          </a:xfrm>
-          <a:prstGeom prst="rect">
-            <a:avLst/>
-          </a:prstGeom>
-          <a:noFill/>
-        </p:spPr>
-        <p:txBody>
-          <a:bodyPr wrap="none" lIns="0" rIns="0" tIns="0" bIns="0" anchor="t">
-            <a:spAutoFit/>
-          </a:bodyPr>
-          <a:lstStyle/>
-          <a:p>
-            <a:pPr algn="ctr">
-              <a:lnSpc>
-                <a:spcPct val="100000"/>
-              </a:lnSpc>
-              <a:spcAft>
-                <a:spcPts val="0"/>
-              </a:spcAft>
-            </a:pPr>
-            <a:r>
-              <a:rPr sz="800" b="0" i="0">
-                <a:solidFill>
-                  <a:srgbClr val="767576"/>
-                </a:solidFill>
-                <a:latin typeface="Arial"/>
-              </a:rPr>
-              <a:t>+40</a:t>
-            </a:r>
-          </a:p>
-        </p:txBody>
-      </p:sp>
-      <p:sp>
-        <p:nvSpPr>
-          <p:cNvPr id="51" name="Rectangle 50"/>
-          <p:cNvSpPr/>
-          <p:nvPr/>
-        </p:nvSpPr>
-        <p:spPr>
-          <a:xfrm>
-            <a:off x="4133087" y="3387851"/>
-            <a:ext cx="182880" cy="100584"/>
-          </a:xfrm>
-          <a:prstGeom prst="rect">
-            <a:avLst/>
-          </a:prstGeom>
-          <a:solidFill>
-            <a:srgbClr val="D7D8D6"/>
-          </a:solidFill>
-          <a:ln>
-            <a:noFill/>
-          </a:ln>
-          <a:effectLst/>
-        </p:spPr>
-        <p:style>
-          <a:lnRef idx="1">
-            <a:schemeClr val="accent1"/>
-          </a:lnRef>
-          <a:fillRef idx="3">
-            <a:schemeClr val="accent1"/>
-          </a:fillRef>
-          <a:effectRef idx="2">
-            <a:schemeClr val="accent1"/>
-          </a:effectRef>
-          <a:fontRef idx="minor">
-            <a:schemeClr val="lt1"/>
-          </a:fontRef>
-        </p:style>
-        <p:txBody>
-          <a:bodyPr rtlCol="0" anchor="ctr"/>
-          <a:lstStyle/>
-          <a:p/>
-        </p:txBody>
-      </p:sp>
-      <p:sp>
-        <p:nvSpPr>
-          <p:cNvPr id="52" name="TextBox 51"/>
-          <p:cNvSpPr txBox="1"/>
-          <p:nvPr/>
-        </p:nvSpPr>
-        <p:spPr>
-          <a:xfrm>
-            <a:off x="4370831" y="3346703"/>
-            <a:ext cx="1737360" cy="182880"/>
+            <a:off x="4133087" y="3822191"/>
+            <a:ext cx="2029967" cy="164592"/>
           </a:xfrm>
           <a:prstGeom prst="rect">
             <a:avLst/>
@@ -7069,192 +7279,24 @@
             <a:r>
               <a:rPr sz="800" b="0" i="0">
                 <a:solidFill>
-                  <a:srgbClr val="767576"/>
+                  <a:srgbClr val="000000"/>
                 </a:solidFill>
                 <a:latin typeface="Arial"/>
               </a:rPr>
-              <a:t>±1 quarter of realised noise</a:t>
-            </a:r>
-          </a:p>
-        </p:txBody>
-      </p:sp>
-      <p:sp>
-        <p:nvSpPr>
-          <p:cNvPr id="53" name="Rectangle 52"/>
-          <p:cNvSpPr/>
-          <p:nvPr/>
-        </p:nvSpPr>
-        <p:spPr>
-          <a:xfrm>
-            <a:off x="6163056" y="3364991"/>
-            <a:ext cx="23774" cy="146304"/>
-          </a:xfrm>
-          <a:prstGeom prst="rect">
-            <a:avLst/>
-          </a:prstGeom>
-          <a:solidFill>
-            <a:srgbClr val="DB0011"/>
-          </a:solidFill>
-          <a:ln>
-            <a:noFill/>
-          </a:ln>
-          <a:effectLst/>
-        </p:spPr>
-        <p:style>
-          <a:lnRef idx="1">
-            <a:schemeClr val="accent1"/>
-          </a:lnRef>
-          <a:fillRef idx="3">
-            <a:schemeClr val="accent1"/>
-          </a:fillRef>
-          <a:effectRef idx="2">
-            <a:schemeClr val="accent1"/>
-          </a:effectRef>
-          <a:fontRef idx="minor">
-            <a:schemeClr val="lt1"/>
-          </a:fontRef>
-        </p:style>
-        <p:txBody>
-          <a:bodyPr rtlCol="0" anchor="ctr"/>
-          <a:lstStyle/>
-          <a:p/>
-        </p:txBody>
-      </p:sp>
-      <p:sp>
-        <p:nvSpPr>
-          <p:cNvPr id="54" name="TextBox 53"/>
+              <a:t>Percentile since 2000</a:t>
+            </a:r>
+          </a:p>
+        </p:txBody>
+      </p:sp>
+      <p:sp>
+        <p:nvSpPr>
+          <p:cNvPr id="58" name="TextBox 57"/>
           <p:cNvSpPr txBox="1"/>
           <p:nvPr/>
         </p:nvSpPr>
         <p:spPr>
           <a:xfrm>
-            <a:off x="6241694" y="3346703"/>
-            <a:ext cx="962680" cy="182880"/>
-          </a:xfrm>
-          <a:prstGeom prst="rect">
-            <a:avLst/>
-          </a:prstGeom>
-          <a:noFill/>
-        </p:spPr>
-        <p:txBody>
-          <a:bodyPr wrap="none" lIns="0" rIns="0" tIns="0" bIns="0" anchor="t">
-            <a:spAutoFit/>
-          </a:bodyPr>
-          <a:lstStyle/>
-          <a:p>
-            <a:pPr algn="l">
-              <a:lnSpc>
-                <a:spcPct val="100000"/>
-              </a:lnSpc>
-              <a:spcAft>
-                <a:spcPts val="0"/>
-              </a:spcAft>
-            </a:pPr>
-            <a:r>
-              <a:rPr sz="800" b="0" i="0">
-                <a:solidFill>
-                  <a:srgbClr val="767576"/>
-                </a:solidFill>
-                <a:latin typeface="Arial"/>
-              </a:rPr>
-              <a:t>Target</a:t>
-            </a:r>
-          </a:p>
-        </p:txBody>
-      </p:sp>
-      <p:sp>
-        <p:nvSpPr>
-          <p:cNvPr id="55" name="Rectangle 54"/>
-          <p:cNvSpPr/>
-          <p:nvPr/>
-        </p:nvSpPr>
-        <p:spPr>
-          <a:xfrm>
-            <a:off x="7259238" y="3364991"/>
-            <a:ext cx="23774" cy="146304"/>
-          </a:xfrm>
-          <a:prstGeom prst="rect">
-            <a:avLst/>
-          </a:prstGeom>
-          <a:solidFill>
-            <a:srgbClr val="44546A"/>
-          </a:solidFill>
-          <a:ln>
-            <a:noFill/>
-          </a:ln>
-          <a:effectLst/>
-        </p:spPr>
-        <p:style>
-          <a:lnRef idx="1">
-            <a:schemeClr val="accent1"/>
-          </a:lnRef>
-          <a:fillRef idx="3">
-            <a:schemeClr val="accent1"/>
-          </a:fillRef>
-          <a:effectRef idx="2">
-            <a:schemeClr val="accent1"/>
-          </a:effectRef>
-          <a:fontRef idx="minor">
-            <a:schemeClr val="lt1"/>
-          </a:fontRef>
-        </p:style>
-        <p:txBody>
-          <a:bodyPr rtlCol="0" anchor="ctr"/>
-          <a:lstStyle/>
-          <a:p/>
-        </p:txBody>
-      </p:sp>
-      <p:sp>
-        <p:nvSpPr>
-          <p:cNvPr id="56" name="TextBox 55"/>
-          <p:cNvSpPr txBox="1"/>
-          <p:nvPr/>
-        </p:nvSpPr>
-        <p:spPr>
-          <a:xfrm>
-            <a:off x="7337877" y="3346703"/>
-            <a:ext cx="800282" cy="182880"/>
-          </a:xfrm>
-          <a:prstGeom prst="rect">
-            <a:avLst/>
-          </a:prstGeom>
-          <a:noFill/>
-        </p:spPr>
-        <p:txBody>
-          <a:bodyPr wrap="none" lIns="0" rIns="0" tIns="0" bIns="0" anchor="t">
-            <a:spAutoFit/>
-          </a:bodyPr>
-          <a:lstStyle/>
-          <a:p>
-            <a:pPr algn="l">
-              <a:lnSpc>
-                <a:spcPct val="100000"/>
-              </a:lnSpc>
-              <a:spcAft>
-                <a:spcPts val="0"/>
-              </a:spcAft>
-            </a:pPr>
-            <a:r>
-              <a:rPr sz="800" b="0" i="0">
-                <a:solidFill>
-                  <a:srgbClr val="767576"/>
-                </a:solidFill>
-                <a:latin typeface="Arial"/>
-              </a:rPr>
-              <a:t>Stop</a:t>
-            </a:r>
-          </a:p>
-        </p:txBody>
-      </p:sp>
-      <p:sp>
-        <p:nvSpPr>
-          <p:cNvPr id="57" name="TextBox 56"/>
-          <p:cNvSpPr txBox="1"/>
-          <p:nvPr/>
-        </p:nvSpPr>
-        <p:spPr>
-          <a:xfrm>
-            <a:off x="6236207" y="3584448"/>
+            <a:off x="6236207" y="3822191"/>
             <a:ext cx="914400" cy="164592"/>
           </a:xfrm>
           <a:prstGeom prst="rect">
@@ -7283,20 +7325,20 @@
                 </a:solidFill>
                 <a:latin typeface="Arial"/>
               </a:rPr>
-              <a:t>2s10s</a:t>
-            </a:r>
-          </a:p>
-        </p:txBody>
-      </p:sp>
-      <p:sp>
-        <p:nvSpPr>
-          <p:cNvPr id="58" name="TextBox 57"/>
+              <a:t>93rd</a:t>
+            </a:r>
+          </a:p>
+        </p:txBody>
+      </p:sp>
+      <p:sp>
+        <p:nvSpPr>
+          <p:cNvPr id="59" name="TextBox 58"/>
           <p:cNvSpPr txBox="1"/>
           <p:nvPr/>
         </p:nvSpPr>
         <p:spPr>
           <a:xfrm>
-            <a:off x="7150607" y="3584448"/>
+            <a:off x="7150607" y="3822191"/>
             <a:ext cx="914400" cy="164592"/>
           </a:xfrm>
           <a:prstGeom prst="rect">
@@ -7319,34 +7361,34 @@
               </a:spcAft>
             </a:pPr>
             <a:r>
-              <a:rPr sz="850" b="1" i="0">
+              <a:rPr sz="850" b="0" i="0">
                 <a:solidFill>
                   <a:srgbClr val="767576"/>
                 </a:solidFill>
                 <a:latin typeface="Arial"/>
               </a:rPr>
-              <a:t>2s30s</a:t>
+              <a:t>99th</a:t>
             </a:r>
           </a:p>
         </p:txBody>
       </p:sp>
       <p:cxnSp>
         <p:nvCxnSpPr>
-          <p:cNvPr id="59" name="Connector 58"/>
+          <p:cNvPr id="60" name="Connector 59"/>
           <p:cNvCxnSpPr/>
           <p:nvPr/>
         </p:nvCxnSpPr>
         <p:spPr>
           <a:xfrm>
-            <a:off x="4133087" y="3767328"/>
+            <a:off x="4133087" y="3968496"/>
             <a:ext cx="3931921" cy="0"/>
           </a:xfrm>
           <a:prstGeom prst="line">
             <a:avLst/>
           </a:prstGeom>
-          <a:ln w="9525">
+          <a:ln w="6350">
             <a:solidFill>
-              <a:srgbClr val="000000"/>
+              <a:srgbClr val="D0CECE"/>
             </a:solidFill>
           </a:ln>
         </p:spPr>
@@ -7367,13 +7409,13 @@
       </p:cxnSp>
       <p:sp>
         <p:nvSpPr>
-          <p:cNvPr id="60" name="TextBox 59"/>
+          <p:cNvPr id="61" name="TextBox 60"/>
           <p:cNvSpPr txBox="1"/>
           <p:nvPr/>
         </p:nvSpPr>
         <p:spPr>
           <a:xfrm>
-            <a:off x="4133087" y="3822191"/>
+            <a:off x="4133087" y="4005072"/>
             <a:ext cx="2029967" cy="164592"/>
           </a:xfrm>
           <a:prstGeom prst="rect">
@@ -7402,20 +7444,20 @@
                 </a:solidFill>
                 <a:latin typeface="Arial"/>
               </a:rPr>
-              <a:t>Percentile since 2000</a:t>
-            </a:r>
-          </a:p>
-        </p:txBody>
-      </p:sp>
-      <p:sp>
-        <p:nvSpPr>
-          <p:cNvPr id="61" name="TextBox 60"/>
+              <a:t>Notional per ¥1bn back leg</a:t>
+            </a:r>
+          </a:p>
+        </p:txBody>
+      </p:sp>
+      <p:sp>
+        <p:nvSpPr>
+          <p:cNvPr id="62" name="TextBox 61"/>
           <p:cNvSpPr txBox="1"/>
           <p:nvPr/>
         </p:nvSpPr>
         <p:spPr>
           <a:xfrm>
-            <a:off x="6236207" y="3822191"/>
+            <a:off x="6236207" y="4005072"/>
             <a:ext cx="914400" cy="164592"/>
           </a:xfrm>
           <a:prstGeom prst="rect">
@@ -7444,20 +7486,20 @@
                 </a:solidFill>
                 <a:latin typeface="Arial"/>
               </a:rPr>
-              <a:t>93rd</a:t>
-            </a:r>
-          </a:p>
-        </p:txBody>
-      </p:sp>
-      <p:sp>
-        <p:nvSpPr>
-          <p:cNvPr id="62" name="TextBox 61"/>
+              <a:t>¥5.5bn</a:t>
+            </a:r>
+          </a:p>
+        </p:txBody>
+      </p:sp>
+      <p:sp>
+        <p:nvSpPr>
+          <p:cNvPr id="63" name="TextBox 62"/>
           <p:cNvSpPr txBox="1"/>
           <p:nvPr/>
         </p:nvSpPr>
         <p:spPr>
           <a:xfrm>
-            <a:off x="7150607" y="3822191"/>
+            <a:off x="7150607" y="4005072"/>
             <a:ext cx="914400" cy="164592"/>
           </a:xfrm>
           <a:prstGeom prst="rect">
@@ -7486,20 +7528,20 @@
                 </a:solidFill>
                 <a:latin typeface="Arial"/>
               </a:rPr>
-              <a:t>99th</a:t>
+              <a:t>¥10.3bn</a:t>
             </a:r>
           </a:p>
         </p:txBody>
       </p:sp>
       <p:cxnSp>
         <p:nvCxnSpPr>
-          <p:cNvPr id="63" name="Connector 62"/>
+          <p:cNvPr id="64" name="Connector 63"/>
           <p:cNvCxnSpPr/>
           <p:nvPr/>
         </p:nvCxnSpPr>
         <p:spPr>
           <a:xfrm>
-            <a:off x="4133087" y="3968496"/>
+            <a:off x="4133087" y="4151376"/>
             <a:ext cx="3931921" cy="0"/>
           </a:xfrm>
           <a:prstGeom prst="line">
@@ -7528,13 +7570,13 @@
       </p:cxnSp>
       <p:sp>
         <p:nvSpPr>
-          <p:cNvPr id="64" name="TextBox 63"/>
+          <p:cNvPr id="65" name="TextBox 64"/>
           <p:cNvSpPr txBox="1"/>
           <p:nvPr/>
         </p:nvSpPr>
         <p:spPr>
           <a:xfrm>
-            <a:off x="4133087" y="4005072"/>
+            <a:off x="4133087" y="4187952"/>
             <a:ext cx="2029967" cy="164592"/>
           </a:xfrm>
           <a:prstGeom prst="rect">
@@ -7563,20 +7605,20 @@
                 </a:solidFill>
                 <a:latin typeface="Arial"/>
               </a:rPr>
-              <a:t>Notional per ¥1bn back leg</a:t>
-            </a:r>
-          </a:p>
-        </p:txBody>
-      </p:sp>
-      <p:sp>
-        <p:nvSpPr>
-          <p:cNvPr id="65" name="TextBox 64"/>
+              <a:t>Risk : reward, net of costs</a:t>
+            </a:r>
+          </a:p>
+        </p:txBody>
+      </p:sp>
+      <p:sp>
+        <p:nvSpPr>
+          <p:cNvPr id="66" name="TextBox 65"/>
           <p:cNvSpPr txBox="1"/>
           <p:nvPr/>
         </p:nvSpPr>
         <p:spPr>
           <a:xfrm>
-            <a:off x="6236207" y="4005072"/>
+            <a:off x="6236207" y="4187952"/>
             <a:ext cx="914400" cy="164592"/>
           </a:xfrm>
           <a:prstGeom prst="rect">
@@ -7605,20 +7647,20 @@
                 </a:solidFill>
                 <a:latin typeface="Arial"/>
               </a:rPr>
-              <a:t>¥5.5bn</a:t>
-            </a:r>
-          </a:p>
-        </p:txBody>
-      </p:sp>
-      <p:sp>
-        <p:nvSpPr>
-          <p:cNvPr id="66" name="TextBox 65"/>
+              <a:t>2.1 : 1</a:t>
+            </a:r>
+          </a:p>
+        </p:txBody>
+      </p:sp>
+      <p:sp>
+        <p:nvSpPr>
+          <p:cNvPr id="67" name="TextBox 66"/>
           <p:cNvSpPr txBox="1"/>
           <p:nvPr/>
         </p:nvSpPr>
         <p:spPr>
           <a:xfrm>
-            <a:off x="7150607" y="4005072"/>
+            <a:off x="7150607" y="4187952"/>
             <a:ext cx="914400" cy="164592"/>
           </a:xfrm>
           <a:prstGeom prst="rect">
@@ -7647,20 +7689,20 @@
                 </a:solidFill>
                 <a:latin typeface="Arial"/>
               </a:rPr>
-              <a:t>¥10.3bn</a:t>
+              <a:t>1.1 : 1</a:t>
             </a:r>
           </a:p>
         </p:txBody>
       </p:sp>
       <p:cxnSp>
         <p:nvCxnSpPr>
-          <p:cNvPr id="67" name="Connector 66"/>
+          <p:cNvPr id="68" name="Connector 67"/>
           <p:cNvCxnSpPr/>
           <p:nvPr/>
         </p:nvCxnSpPr>
         <p:spPr>
           <a:xfrm>
-            <a:off x="4133087" y="4151376"/>
+            <a:off x="4133087" y="4334256"/>
             <a:ext cx="3931921" cy="0"/>
           </a:xfrm>
           <a:prstGeom prst="line">
@@ -7689,168 +7731,7 @@
       </p:cxnSp>
       <p:sp>
         <p:nvSpPr>
-          <p:cNvPr id="68" name="TextBox 67"/>
-          <p:cNvSpPr txBox="1"/>
-          <p:nvPr/>
-        </p:nvSpPr>
-        <p:spPr>
-          <a:xfrm>
-            <a:off x="4133087" y="4187952"/>
-            <a:ext cx="2029967" cy="164592"/>
-          </a:xfrm>
-          <a:prstGeom prst="rect">
-            <a:avLst/>
-          </a:prstGeom>
-          <a:noFill/>
-        </p:spPr>
-        <p:txBody>
-          <a:bodyPr wrap="none" lIns="0" rIns="0" tIns="0" bIns="0" anchor="t">
-            <a:spAutoFit/>
-          </a:bodyPr>
-          <a:lstStyle/>
-          <a:p>
-            <a:pPr algn="l">
-              <a:lnSpc>
-                <a:spcPct val="100000"/>
-              </a:lnSpc>
-              <a:spcAft>
-                <a:spcPts val="0"/>
-              </a:spcAft>
-            </a:pPr>
-            <a:r>
-              <a:rPr sz="800" b="0" i="0">
-                <a:solidFill>
-                  <a:srgbClr val="000000"/>
-                </a:solidFill>
-                <a:latin typeface="Arial"/>
-              </a:rPr>
-              <a:t>Risk : reward, net of costs</a:t>
-            </a:r>
-          </a:p>
-        </p:txBody>
-      </p:sp>
-      <p:sp>
-        <p:nvSpPr>
           <p:cNvPr id="69" name="TextBox 68"/>
-          <p:cNvSpPr txBox="1"/>
-          <p:nvPr/>
-        </p:nvSpPr>
-        <p:spPr>
-          <a:xfrm>
-            <a:off x="6236207" y="4187952"/>
-            <a:ext cx="914400" cy="164592"/>
-          </a:xfrm>
-          <a:prstGeom prst="rect">
-            <a:avLst/>
-          </a:prstGeom>
-          <a:noFill/>
-        </p:spPr>
-        <p:txBody>
-          <a:bodyPr wrap="none" lIns="0" rIns="0" tIns="0" bIns="0" anchor="t">
-            <a:spAutoFit/>
-          </a:bodyPr>
-          <a:lstStyle/>
-          <a:p>
-            <a:pPr algn="r">
-              <a:lnSpc>
-                <a:spcPct val="100000"/>
-              </a:lnSpc>
-              <a:spcAft>
-                <a:spcPts val="0"/>
-              </a:spcAft>
-            </a:pPr>
-            <a:r>
-              <a:rPr sz="850" b="1" i="0">
-                <a:solidFill>
-                  <a:srgbClr val="DB0011"/>
-                </a:solidFill>
-                <a:latin typeface="Arial"/>
-              </a:rPr>
-              <a:t>2.1 : 1</a:t>
-            </a:r>
-          </a:p>
-        </p:txBody>
-      </p:sp>
-      <p:sp>
-        <p:nvSpPr>
-          <p:cNvPr id="70" name="TextBox 69"/>
-          <p:cNvSpPr txBox="1"/>
-          <p:nvPr/>
-        </p:nvSpPr>
-        <p:spPr>
-          <a:xfrm>
-            <a:off x="7150607" y="4187952"/>
-            <a:ext cx="914400" cy="164592"/>
-          </a:xfrm>
-          <a:prstGeom prst="rect">
-            <a:avLst/>
-          </a:prstGeom>
-          <a:noFill/>
-        </p:spPr>
-        <p:txBody>
-          <a:bodyPr wrap="none" lIns="0" rIns="0" tIns="0" bIns="0" anchor="t">
-            <a:spAutoFit/>
-          </a:bodyPr>
-          <a:lstStyle/>
-          <a:p>
-            <a:pPr algn="r">
-              <a:lnSpc>
-                <a:spcPct val="100000"/>
-              </a:lnSpc>
-              <a:spcAft>
-                <a:spcPts val="0"/>
-              </a:spcAft>
-            </a:pPr>
-            <a:r>
-              <a:rPr sz="850" b="0" i="0">
-                <a:solidFill>
-                  <a:srgbClr val="767576"/>
-                </a:solidFill>
-                <a:latin typeface="Arial"/>
-              </a:rPr>
-              <a:t>1.1 : 1</a:t>
-            </a:r>
-          </a:p>
-        </p:txBody>
-      </p:sp>
-      <p:cxnSp>
-        <p:nvCxnSpPr>
-          <p:cNvPr id="71" name="Connector 70"/>
-          <p:cNvCxnSpPr/>
-          <p:nvPr/>
-        </p:nvCxnSpPr>
-        <p:spPr>
-          <a:xfrm>
-            <a:off x="4133087" y="4334256"/>
-            <a:ext cx="3931921" cy="0"/>
-          </a:xfrm>
-          <a:prstGeom prst="line">
-            <a:avLst/>
-          </a:prstGeom>
-          <a:ln w="6350">
-            <a:solidFill>
-              <a:srgbClr val="D0CECE"/>
-            </a:solidFill>
-          </a:ln>
-        </p:spPr>
-        <p:style>
-          <a:lnRef idx="2">
-            <a:schemeClr val="accent1"/>
-          </a:lnRef>
-          <a:fillRef idx="0">
-            <a:schemeClr val="accent1"/>
-          </a:fillRef>
-          <a:effectRef idx="1">
-            <a:schemeClr val="accent1"/>
-          </a:effectRef>
-          <a:fontRef idx="minor">
-            <a:schemeClr val="tx1"/>
-          </a:fontRef>
-        </p:style>
-      </p:cxnSp>
-      <p:sp>
-        <p:nvSpPr>
-          <p:cNvPr id="72" name="TextBox 71"/>
           <p:cNvSpPr txBox="1"/>
           <p:nvPr/>
         </p:nvSpPr>
@@ -7885,14 +7766,14 @@
                 </a:solidFill>
                 <a:latin typeface="Arial"/>
               </a:rPr>
-              <a:t>1.5x</a:t>
-            </a:r>
-          </a:p>
-        </p:txBody>
-      </p:sp>
-      <p:sp>
-        <p:nvSpPr>
-          <p:cNvPr id="73" name="TextBox 72"/>
+              <a:t>17% vs 57%</a:t>
+            </a:r>
+          </a:p>
+        </p:txBody>
+      </p:sp>
+      <p:sp>
+        <p:nvSpPr>
+          <p:cNvPr id="70" name="TextBox 69"/>
           <p:cNvSpPr txBox="1"/>
           <p:nvPr/>
         </p:nvSpPr>
@@ -7927,14 +7808,14 @@
                 </a:solidFill>
                 <a:latin typeface="Arial"/>
               </a:rPr>
-              <a:t>the noise 2s30s carries, for less move</a:t>
-            </a:r>
-          </a:p>
-        </p:txBody>
-      </p:sp>
-      <p:sp>
-        <p:nvSpPr>
-          <p:cNvPr id="74" name="TextBox 73"/>
+              <a:t>of comparable entries stopped out</a:t>
+            </a:r>
+          </a:p>
+        </p:txBody>
+      </p:sp>
+      <p:sp>
+        <p:nvSpPr>
+          <p:cNvPr id="71" name="TextBox 70"/>
           <p:cNvSpPr txBox="1"/>
           <p:nvPr/>
         </p:nvSpPr>
@@ -7976,7 +7857,7 @@
       </p:sp>
       <p:sp>
         <p:nvSpPr>
-          <p:cNvPr id="75" name="TextBox 74"/>
+          <p:cNvPr id="72" name="TextBox 71"/>
           <p:cNvSpPr txBox="1"/>
           <p:nvPr/>
         </p:nvSpPr>
@@ -8018,7 +7899,7 @@
       </p:sp>
       <p:sp>
         <p:nvSpPr>
-          <p:cNvPr id="76" name="TextBox 75"/>
+          <p:cNvPr id="73" name="TextBox 72"/>
           <p:cNvSpPr txBox="1"/>
           <p:nvPr/>
         </p:nvSpPr>
@@ -8060,7 +7941,7 @@
       </p:sp>
       <p:sp>
         <p:nvSpPr>
-          <p:cNvPr id="77" name="TextBox 76"/>
+          <p:cNvPr id="74" name="TextBox 73"/>
           <p:cNvSpPr txBox="1"/>
           <p:nvPr/>
         </p:nvSpPr>
@@ -8102,7 +7983,7 @@
       </p:sp>
       <p:graphicFrame>
         <p:nvGraphicFramePr>
-          <p:cNvPr id="78" name="Chart 77"/>
+          <p:cNvPr id="75" name="Chart 74"/>
           <p:cNvGraphicFramePr>
             <a:graphicFrameLocks noGrp="1"/>
           </p:cNvGraphicFramePr>
@@ -8120,7 +8001,7 @@
       </p:graphicFrame>
       <p:sp>
         <p:nvSpPr>
-          <p:cNvPr id="79" name="TextBox 78"/>
+          <p:cNvPr id="76" name="TextBox 75"/>
           <p:cNvSpPr txBox="1"/>
           <p:nvPr/>
         </p:nvSpPr>
@@ -8162,7 +8043,7 @@
       </p:sp>
       <p:sp>
         <p:nvSpPr>
-          <p:cNvPr id="80" name="TextBox 79"/>
+          <p:cNvPr id="77" name="TextBox 76"/>
           <p:cNvSpPr txBox="1"/>
           <p:nvPr/>
         </p:nvSpPr>
@@ -8204,7 +8085,7 @@
       </p:sp>
       <p:sp>
         <p:nvSpPr>
-          <p:cNvPr id="81" name="TextBox 80"/>
+          <p:cNvPr id="78" name="TextBox 77"/>
           <p:cNvSpPr txBox="1"/>
           <p:nvPr/>
         </p:nvSpPr>
@@ -8246,7 +8127,7 @@
       </p:sp>
       <p:sp>
         <p:nvSpPr>
-          <p:cNvPr id="82" name="TextBox 81"/>
+          <p:cNvPr id="79" name="TextBox 78"/>
           <p:cNvSpPr txBox="1"/>
           <p:nvPr/>
         </p:nvSpPr>
@@ -8288,7 +8169,7 @@
       </p:sp>
       <p:sp>
         <p:nvSpPr>
-          <p:cNvPr id="83" name="TextBox 82"/>
+          <p:cNvPr id="80" name="TextBox 79"/>
           <p:cNvSpPr txBox="1"/>
           <p:nvPr/>
         </p:nvSpPr>
@@ -8330,7 +8211,7 @@
       </p:sp>
       <p:graphicFrame>
         <p:nvGraphicFramePr>
-          <p:cNvPr id="84" name="Table 83"/>
+          <p:cNvPr id="81" name="Table 80"/>
           <p:cNvGraphicFramePr>
             <a:graphicFrameLocks noGrp="1"/>
           </p:cNvGraphicFramePr>
@@ -8832,7 +8713,7 @@
       </p:graphicFrame>
       <p:sp>
         <p:nvSpPr>
-          <p:cNvPr id="85" name="TextBox 84"/>
+          <p:cNvPr id="82" name="TextBox 81"/>
           <p:cNvSpPr txBox="1"/>
           <p:nvPr/>
         </p:nvSpPr>
@@ -8874,7 +8755,7 @@
       </p:sp>
       <p:sp>
         <p:nvSpPr>
-          <p:cNvPr id="86" name="TextBox 85"/>
+          <p:cNvPr id="83" name="TextBox 82"/>
           <p:cNvSpPr txBox="1"/>
           <p:nvPr/>
         </p:nvSpPr>
@@ -8909,7 +8790,7 @@
                 </a:solidFill>
                 <a:latin typeface="Arial"/>
               </a:rPr>
-              <a:t>MoF JGB curve at 31-Jul-26, weekly since 2000, n = 1,387. Stops tested on every entry at or above the 85th percentile, worst point over the next 26 weeks. Noise is the QT era, n = 121. Cashflow-level pricing on the annual JPY OIS schedule. Our path is a scenario: 2y +10bp, 10y +40bp.</a:t>
+              <a:t>MoF JGB curve at 31-Jul-26, weekly since 2000, n = 1,387. Stops tested on every entry at or above the 85th percentile, worst point over the next 26 weeks. Betas are the QT era, n = 122. Cashflow-level pricing on the annual JPY OIS schedule. Our path is a scenario: 2y +10bp, 10y +40bp.</a:t>
             </a:r>
           </a:p>
         </p:txBody>

</xml_diff>

<commit_message>
Test whether the 30-year beta holds, and state the crux
</commit_message>
<xml_diff>
--- a/JGB_2s10s_Steepener_Risk.pptx
+++ b/JGB_2s10s_Steepener_Risk.pptx
@@ -7283,7 +7283,7 @@
                 </a:solidFill>
                 <a:latin typeface="Arial"/>
               </a:rPr>
-              <a:t>Percentile since 2000</a:t>
+              <a:t>Back leg follows the 10y at</a:t>
             </a:r>
           </a:p>
         </p:txBody>
@@ -7325,7 +7325,7 @@
                 </a:solidFill>
                 <a:latin typeface="Arial"/>
               </a:rPr>
-              <a:t>93rd</a:t>
+              <a:t>1.00</a:t>
             </a:r>
           </a:p>
         </p:txBody>
@@ -7367,7 +7367,7 @@
                 </a:solidFill>
                 <a:latin typeface="Arial"/>
               </a:rPr>
-              <a:t>99th</a:t>
+              <a:t>0.75</a:t>
             </a:r>
           </a:p>
         </p:txBody>
@@ -7444,7 +7444,7 @@
                 </a:solidFill>
                 <a:latin typeface="Arial"/>
               </a:rPr>
-              <a:t>Notional per ¥1bn back leg</a:t>
+              <a:t>Percentile since 2000</a:t>
             </a:r>
           </a:p>
         </p:txBody>
@@ -7486,7 +7486,7 @@
                 </a:solidFill>
                 <a:latin typeface="Arial"/>
               </a:rPr>
-              <a:t>¥5.5bn</a:t>
+              <a:t>93rd</a:t>
             </a:r>
           </a:p>
         </p:txBody>
@@ -7528,7 +7528,7 @@
                 </a:solidFill>
                 <a:latin typeface="Arial"/>
               </a:rPr>
-              <a:t>¥10.3bn</a:t>
+              <a:t>99th</a:t>
             </a:r>
           </a:p>
         </p:txBody>
@@ -7605,7 +7605,7 @@
                 </a:solidFill>
                 <a:latin typeface="Arial"/>
               </a:rPr>
-              <a:t>Risk : reward, net of costs</a:t>
+              <a:t>Notional per ¥1bn back leg</a:t>
             </a:r>
           </a:p>
         </p:txBody>
@@ -7647,7 +7647,7 @@
                 </a:solidFill>
                 <a:latin typeface="Arial"/>
               </a:rPr>
-              <a:t>2.1 : 1</a:t>
+              <a:t>¥5.5bn</a:t>
             </a:r>
           </a:p>
         </p:txBody>
@@ -7689,7 +7689,7 @@
                 </a:solidFill>
                 <a:latin typeface="Arial"/>
               </a:rPr>
-              <a:t>1.1 : 1</a:t>
+              <a:t>¥10.3bn</a:t>
             </a:r>
           </a:p>
         </p:txBody>
@@ -8790,7 +8790,7 @@
                 </a:solidFill>
                 <a:latin typeface="Arial"/>
               </a:rPr>
-              <a:t>MoF JGB curve at 31-Jul-26, weekly since 2000, n = 1,387. Stops tested on every entry at or above the 85th percentile, worst point over the next 26 weeks. Betas are the QT era, n = 122. Cashflow-level pricing on the annual JPY OIS schedule. Our path is a scenario: 2y +10bp, 10y +40bp.</a:t>
+              <a:t>MoF JGB curve at 31-Jul-26, weekly since 2000, n = 1,387. Stops tested on every entry at or above the 85th percentile, worst point over the next 26 weeks. Betas are the QT era, n = 122; the 30y has not reached 1.00, where the two trades tie, since 2021. Cashflow-level pricing on the annual JPY OIS schedule. Our path is a scenario: 2y +10bp, 10y +40bp.</a:t>
             </a:r>
           </a:p>
         </p:txBody>

</xml_diff>

<commit_message>
Put the range panel back on exhibit 5, without the headroom argument
</commit_message>
<xml_diff>
--- a/JGB_2s10s_Steepener_Risk.pptx
+++ b/JGB_2s10s_Steepener_Risk.pptx
@@ -5820,7 +5820,7 @@
                 </a:solidFill>
                 <a:latin typeface="Arial"/>
               </a:rPr>
-              <a:t>Exhibit 5. The taper hits the 10-year. 2s10s keeps 5.1bp of every 10bp it sells off, 2s30s only 2.6bp</a:t>
+              <a:t>Exhibit 5. 2s30s sits at the 99th percentile of its own range since 2000. 2s10s is at the 93rd</a:t>
             </a:r>
           </a:p>
         </p:txBody>
@@ -5862,7 +5862,7 @@
                 </a:solidFill>
                 <a:latin typeface="Arial"/>
               </a:rPr>
-              <a:t>Pass-through of a 10bp 10-year-led sell-off, QT-era betas, bp</a:t>
+              <a:t>Slope vs its own range since 2000, bp</a:t>
             </a:r>
           </a:p>
         </p:txBody>
@@ -5875,8 +5875,8 @@
         </p:nvCxnSpPr>
         <p:spPr>
           <a:xfrm>
-            <a:off x="5065775" y="1773936"/>
-            <a:ext cx="0" cy="1353312"/>
+            <a:off x="5093207" y="1755648"/>
+            <a:ext cx="0" cy="1316736"/>
           </a:xfrm>
           <a:prstGeom prst="line">
             <a:avLst/>
@@ -5910,8 +5910,8 @@
         </p:nvCxnSpPr>
         <p:spPr>
           <a:xfrm>
-            <a:off x="5591555" y="1773936"/>
-            <a:ext cx="0" cy="1353312"/>
+            <a:off x="5806440" y="1755648"/>
+            <a:ext cx="0" cy="1316736"/>
           </a:xfrm>
           <a:prstGeom prst="line">
             <a:avLst/>
@@ -5945,8 +5945,8 @@
         </p:nvCxnSpPr>
         <p:spPr>
           <a:xfrm>
-            <a:off x="6117336" y="1773936"/>
-            <a:ext cx="0" cy="1353312"/>
+            <a:off x="6519672" y="1755648"/>
+            <a:ext cx="0" cy="1316736"/>
           </a:xfrm>
           <a:prstGeom prst="line">
             <a:avLst/>
@@ -5980,8 +5980,8 @@
         </p:nvCxnSpPr>
         <p:spPr>
           <a:xfrm>
-            <a:off x="6643115" y="1773936"/>
-            <a:ext cx="0" cy="1353312"/>
+            <a:off x="7232904" y="1755648"/>
+            <a:ext cx="0" cy="1316736"/>
           </a:xfrm>
           <a:prstGeom prst="line">
             <a:avLst/>
@@ -6007,23 +6007,653 @@
           </a:fontRef>
         </p:style>
       </p:cxnSp>
+      <p:sp>
+        <p:nvSpPr>
+          <p:cNvPr id="27" name="Rectangle 26"/>
+          <p:cNvSpPr/>
+          <p:nvPr/>
+        </p:nvSpPr>
+        <p:spPr>
+          <a:xfrm>
+            <a:off x="5118567" y="1897380"/>
+            <a:ext cx="1281440" cy="155448"/>
+          </a:xfrm>
+          <a:prstGeom prst="rect">
+            <a:avLst/>
+          </a:prstGeom>
+          <a:solidFill>
+            <a:srgbClr val="D7D8D6"/>
+          </a:solidFill>
+          <a:ln>
+            <a:noFill/>
+          </a:ln>
+          <a:effectLst/>
+        </p:spPr>
+        <p:style>
+          <a:lnRef idx="1">
+            <a:schemeClr val="accent1"/>
+          </a:lnRef>
+          <a:fillRef idx="3">
+            <a:schemeClr val="accent1"/>
+          </a:fillRef>
+          <a:effectRef idx="2">
+            <a:schemeClr val="accent1"/>
+          </a:effectRef>
+          <a:fontRef idx="minor">
+            <a:schemeClr val="lt1"/>
+          </a:fontRef>
+        </p:style>
+        <p:txBody>
+          <a:bodyPr rtlCol="0" anchor="ctr"/>
+          <a:lstStyle/>
+          <a:p/>
+        </p:txBody>
+      </p:sp>
+      <p:sp>
+        <p:nvSpPr>
+          <p:cNvPr id="28" name="Rectangle 27"/>
+          <p:cNvSpPr/>
+          <p:nvPr/>
+        </p:nvSpPr>
+        <p:spPr>
+          <a:xfrm>
+            <a:off x="5649772" y="1860804"/>
+            <a:ext cx="20116" cy="228600"/>
+          </a:xfrm>
+          <a:prstGeom prst="rect">
+            <a:avLst/>
+          </a:prstGeom>
+          <a:solidFill>
+            <a:srgbClr val="44546A"/>
+          </a:solidFill>
+          <a:ln>
+            <a:noFill/>
+          </a:ln>
+          <a:effectLst/>
+        </p:spPr>
+        <p:style>
+          <a:lnRef idx="1">
+            <a:schemeClr val="accent1"/>
+          </a:lnRef>
+          <a:fillRef idx="3">
+            <a:schemeClr val="accent1"/>
+          </a:fillRef>
+          <a:effectRef idx="2">
+            <a:schemeClr val="accent1"/>
+          </a:effectRef>
+          <a:fontRef idx="minor">
+            <a:schemeClr val="lt1"/>
+          </a:fontRef>
+        </p:style>
+        <p:txBody>
+          <a:bodyPr rtlCol="0" anchor="ctr"/>
+          <a:lstStyle/>
+          <a:p/>
+        </p:txBody>
+      </p:sp>
+      <p:sp>
+        <p:nvSpPr>
+          <p:cNvPr id="29" name="Rectangle 28"/>
+          <p:cNvSpPr/>
+          <p:nvPr/>
+        </p:nvSpPr>
+        <p:spPr>
+          <a:xfrm>
+            <a:off x="6093073" y="1833372"/>
+            <a:ext cx="51206" cy="283464"/>
+          </a:xfrm>
+          <a:prstGeom prst="rect">
+            <a:avLst/>
+          </a:prstGeom>
+          <a:solidFill>
+            <a:srgbClr val="DB0011"/>
+          </a:solidFill>
+          <a:ln>
+            <a:noFill/>
+          </a:ln>
+          <a:effectLst/>
+        </p:spPr>
+        <p:style>
+          <a:lnRef idx="1">
+            <a:schemeClr val="accent1"/>
+          </a:lnRef>
+          <a:fillRef idx="3">
+            <a:schemeClr val="accent1"/>
+          </a:fillRef>
+          <a:effectRef idx="2">
+            <a:schemeClr val="accent1"/>
+          </a:effectRef>
+          <a:fontRef idx="minor">
+            <a:schemeClr val="lt1"/>
+          </a:fontRef>
+        </p:style>
+        <p:txBody>
+          <a:bodyPr rtlCol="0" anchor="ctr"/>
+          <a:lstStyle/>
+          <a:p/>
+        </p:txBody>
+      </p:sp>
+      <p:sp>
+        <p:nvSpPr>
+          <p:cNvPr id="30" name="TextBox 29"/>
+          <p:cNvSpPr txBox="1"/>
+          <p:nvPr/>
+        </p:nvSpPr>
+        <p:spPr>
+          <a:xfrm>
+            <a:off x="4133087" y="1869948"/>
+            <a:ext cx="868680" cy="210312"/>
+          </a:xfrm>
+          <a:prstGeom prst="rect">
+            <a:avLst/>
+          </a:prstGeom>
+          <a:noFill/>
+        </p:spPr>
+        <p:txBody>
+          <a:bodyPr wrap="none" lIns="0" rIns="0" tIns="0" bIns="0" anchor="t">
+            <a:spAutoFit/>
+          </a:bodyPr>
+          <a:lstStyle/>
+          <a:p>
+            <a:pPr algn="l">
+              <a:lnSpc>
+                <a:spcPct val="100000"/>
+              </a:lnSpc>
+              <a:spcAft>
+                <a:spcPts val="0"/>
+              </a:spcAft>
+            </a:pPr>
+            <a:r>
+              <a:rPr sz="1000" b="1" i="0">
+                <a:solidFill>
+                  <a:srgbClr val="000000"/>
+                </a:solidFill>
+                <a:latin typeface="Arial"/>
+              </a:rPr>
+              <a:t>JGB 2s10s</a:t>
+            </a:r>
+          </a:p>
+        </p:txBody>
+      </p:sp>
+      <p:sp>
+        <p:nvSpPr>
+          <p:cNvPr id="31" name="TextBox 30"/>
+          <p:cNvSpPr txBox="1"/>
+          <p:nvPr/>
+        </p:nvSpPr>
+        <p:spPr>
+          <a:xfrm>
+            <a:off x="7232904" y="1869948"/>
+            <a:ext cx="923544" cy="210312"/>
+          </a:xfrm>
+          <a:prstGeom prst="rect">
+            <a:avLst/>
+          </a:prstGeom>
+          <a:noFill/>
+        </p:spPr>
+        <p:txBody>
+          <a:bodyPr wrap="none" lIns="0" rIns="0" tIns="0" bIns="0" anchor="t">
+            <a:spAutoFit/>
+          </a:bodyPr>
+          <a:lstStyle/>
+          <a:p>
+            <a:pPr algn="r">
+              <a:lnSpc>
+                <a:spcPct val="100000"/>
+              </a:lnSpc>
+              <a:spcAft>
+                <a:spcPts val="0"/>
+              </a:spcAft>
+            </a:pPr>
+            <a:r>
+              <a:rPr sz="1000" b="1" i="0">
+                <a:solidFill>
+                  <a:srgbClr val="DB0011"/>
+                </a:solidFill>
+                <a:latin typeface="Arial"/>
+              </a:rPr>
+              <a:t>129bp · 93rd</a:t>
+            </a:r>
+          </a:p>
+        </p:txBody>
+      </p:sp>
+      <p:sp>
+        <p:nvSpPr>
+          <p:cNvPr id="32" name="Rectangle 31"/>
+          <p:cNvSpPr/>
+          <p:nvPr/>
+        </p:nvSpPr>
+        <p:spPr>
+          <a:xfrm>
+            <a:off x="5345216" y="2336291"/>
+            <a:ext cx="966825" cy="155448"/>
+          </a:xfrm>
+          <a:prstGeom prst="rect">
+            <a:avLst/>
+          </a:prstGeom>
+          <a:solidFill>
+            <a:srgbClr val="D7D8D6"/>
+          </a:solidFill>
+          <a:ln>
+            <a:noFill/>
+          </a:ln>
+          <a:effectLst/>
+        </p:spPr>
+        <p:style>
+          <a:lnRef idx="1">
+            <a:schemeClr val="accent1"/>
+          </a:lnRef>
+          <a:fillRef idx="3">
+            <a:schemeClr val="accent1"/>
+          </a:fillRef>
+          <a:effectRef idx="2">
+            <a:schemeClr val="accent1"/>
+          </a:effectRef>
+          <a:fontRef idx="minor">
+            <a:schemeClr val="lt1"/>
+          </a:fontRef>
+        </p:style>
+        <p:txBody>
+          <a:bodyPr rtlCol="0" anchor="ctr"/>
+          <a:lstStyle/>
+          <a:p/>
+        </p:txBody>
+      </p:sp>
+      <p:sp>
+        <p:nvSpPr>
+          <p:cNvPr id="33" name="Rectangle 32"/>
+          <p:cNvSpPr/>
+          <p:nvPr/>
+        </p:nvSpPr>
+        <p:spPr>
+          <a:xfrm>
+            <a:off x="5767059" y="2299715"/>
+            <a:ext cx="20116" cy="228600"/>
+          </a:xfrm>
+          <a:prstGeom prst="rect">
+            <a:avLst/>
+          </a:prstGeom>
+          <a:solidFill>
+            <a:srgbClr val="44546A"/>
+          </a:solidFill>
+          <a:ln>
+            <a:noFill/>
+          </a:ln>
+          <a:effectLst/>
+        </p:spPr>
+        <p:style>
+          <a:lnRef idx="1">
+            <a:schemeClr val="accent1"/>
+          </a:lnRef>
+          <a:fillRef idx="3">
+            <a:schemeClr val="accent1"/>
+          </a:fillRef>
+          <a:effectRef idx="2">
+            <a:schemeClr val="accent1"/>
+          </a:effectRef>
+          <a:fontRef idx="minor">
+            <a:schemeClr val="lt1"/>
+          </a:fontRef>
+        </p:style>
+        <p:txBody>
+          <a:bodyPr rtlCol="0" anchor="ctr"/>
+          <a:lstStyle/>
+          <a:p/>
+        </p:txBody>
+      </p:sp>
+      <p:sp>
+        <p:nvSpPr>
+          <p:cNvPr id="34" name="Rectangle 33"/>
+          <p:cNvSpPr/>
+          <p:nvPr/>
+        </p:nvSpPr>
+        <p:spPr>
+          <a:xfrm>
+            <a:off x="6003523" y="2272284"/>
+            <a:ext cx="51206" cy="283464"/>
+          </a:xfrm>
+          <a:prstGeom prst="rect">
+            <a:avLst/>
+          </a:prstGeom>
+          <a:solidFill>
+            <a:srgbClr val="DB0011"/>
+          </a:solidFill>
+          <a:ln>
+            <a:noFill/>
+          </a:ln>
+          <a:effectLst/>
+        </p:spPr>
+        <p:style>
+          <a:lnRef idx="1">
+            <a:schemeClr val="accent1"/>
+          </a:lnRef>
+          <a:fillRef idx="3">
+            <a:schemeClr val="accent1"/>
+          </a:fillRef>
+          <a:effectRef idx="2">
+            <a:schemeClr val="accent1"/>
+          </a:effectRef>
+          <a:fontRef idx="minor">
+            <a:schemeClr val="lt1"/>
+          </a:fontRef>
+        </p:style>
+        <p:txBody>
+          <a:bodyPr rtlCol="0" anchor="ctr"/>
+          <a:lstStyle/>
+          <a:p/>
+        </p:txBody>
+      </p:sp>
+      <p:sp>
+        <p:nvSpPr>
+          <p:cNvPr id="35" name="TextBox 34"/>
+          <p:cNvSpPr txBox="1"/>
+          <p:nvPr/>
+        </p:nvSpPr>
+        <p:spPr>
+          <a:xfrm>
+            <a:off x="4133087" y="2308859"/>
+            <a:ext cx="868680" cy="210312"/>
+          </a:xfrm>
+          <a:prstGeom prst="rect">
+            <a:avLst/>
+          </a:prstGeom>
+          <a:noFill/>
+        </p:spPr>
+        <p:txBody>
+          <a:bodyPr wrap="none" lIns="0" rIns="0" tIns="0" bIns="0" anchor="t">
+            <a:spAutoFit/>
+          </a:bodyPr>
+          <a:lstStyle/>
+          <a:p>
+            <a:pPr algn="l">
+              <a:lnSpc>
+                <a:spcPct val="100000"/>
+              </a:lnSpc>
+              <a:spcAft>
+                <a:spcPts val="0"/>
+              </a:spcAft>
+            </a:pPr>
+            <a:r>
+              <a:rPr sz="1000" b="1" i="0">
+                <a:solidFill>
+                  <a:srgbClr val="000000"/>
+                </a:solidFill>
+                <a:latin typeface="Arial"/>
+              </a:rPr>
+              <a:t>JGB 10s30s</a:t>
+            </a:r>
+          </a:p>
+        </p:txBody>
+      </p:sp>
+      <p:sp>
+        <p:nvSpPr>
+          <p:cNvPr id="36" name="TextBox 35"/>
+          <p:cNvSpPr txBox="1"/>
+          <p:nvPr/>
+        </p:nvSpPr>
+        <p:spPr>
+          <a:xfrm>
+            <a:off x="7232904" y="2308859"/>
+            <a:ext cx="923544" cy="210312"/>
+          </a:xfrm>
+          <a:prstGeom prst="rect">
+            <a:avLst/>
+          </a:prstGeom>
+          <a:noFill/>
+        </p:spPr>
+        <p:txBody>
+          <a:bodyPr wrap="none" lIns="0" rIns="0" tIns="0" bIns="0" anchor="t">
+            <a:spAutoFit/>
+          </a:bodyPr>
+          <a:lstStyle/>
+          <a:p>
+            <a:pPr algn="r">
+              <a:lnSpc>
+                <a:spcPct val="100000"/>
+              </a:lnSpc>
+              <a:spcAft>
+                <a:spcPts val="0"/>
+              </a:spcAft>
+            </a:pPr>
+            <a:r>
+              <a:rPr sz="1000" b="1" i="0">
+                <a:solidFill>
+                  <a:srgbClr val="DB0011"/>
+                </a:solidFill>
+                <a:latin typeface="Arial"/>
+              </a:rPr>
+              <a:t>118bp · 94th</a:t>
+            </a:r>
+          </a:p>
+        </p:txBody>
+      </p:sp>
+      <p:sp>
+        <p:nvSpPr>
+          <p:cNvPr id="37" name="Rectangle 36"/>
+          <p:cNvSpPr/>
+          <p:nvPr/>
+        </p:nvSpPr>
+        <p:spPr>
+          <a:xfrm>
+            <a:off x="5427634" y="2775204"/>
+            <a:ext cx="1724436" cy="155448"/>
+          </a:xfrm>
+          <a:prstGeom prst="rect">
+            <a:avLst/>
+          </a:prstGeom>
+          <a:solidFill>
+            <a:srgbClr val="D7D8D6"/>
+          </a:solidFill>
+          <a:ln>
+            <a:noFill/>
+          </a:ln>
+          <a:effectLst/>
+        </p:spPr>
+        <p:style>
+          <a:lnRef idx="1">
+            <a:schemeClr val="accent1"/>
+          </a:lnRef>
+          <a:fillRef idx="3">
+            <a:schemeClr val="accent1"/>
+          </a:fillRef>
+          <a:effectRef idx="2">
+            <a:schemeClr val="accent1"/>
+          </a:effectRef>
+          <a:fontRef idx="minor">
+            <a:schemeClr val="lt1"/>
+          </a:fontRef>
+        </p:style>
+        <p:txBody>
+          <a:bodyPr rtlCol="0" anchor="ctr"/>
+          <a:lstStyle/>
+          <a:p/>
+        </p:txBody>
+      </p:sp>
+      <p:sp>
+        <p:nvSpPr>
+          <p:cNvPr id="38" name="Rectangle 37"/>
+          <p:cNvSpPr/>
+          <p:nvPr/>
+        </p:nvSpPr>
+        <p:spPr>
+          <a:xfrm>
+            <a:off x="6333683" y="2738628"/>
+            <a:ext cx="20116" cy="228600"/>
+          </a:xfrm>
+          <a:prstGeom prst="rect">
+            <a:avLst/>
+          </a:prstGeom>
+          <a:solidFill>
+            <a:srgbClr val="44546A"/>
+          </a:solidFill>
+          <a:ln>
+            <a:noFill/>
+          </a:ln>
+          <a:effectLst/>
+        </p:spPr>
+        <p:style>
+          <a:lnRef idx="1">
+            <a:schemeClr val="accent1"/>
+          </a:lnRef>
+          <a:fillRef idx="3">
+            <a:schemeClr val="accent1"/>
+          </a:fillRef>
+          <a:effectRef idx="2">
+            <a:schemeClr val="accent1"/>
+          </a:effectRef>
+          <a:fontRef idx="minor">
+            <a:schemeClr val="lt1"/>
+          </a:fontRef>
+        </p:style>
+        <p:txBody>
+          <a:bodyPr rtlCol="0" anchor="ctr"/>
+          <a:lstStyle/>
+          <a:p/>
+        </p:txBody>
+      </p:sp>
+      <p:sp>
+        <p:nvSpPr>
+          <p:cNvPr id="39" name="Rectangle 38"/>
+          <p:cNvSpPr/>
+          <p:nvPr/>
+        </p:nvSpPr>
+        <p:spPr>
+          <a:xfrm>
+            <a:off x="7028992" y="2711196"/>
+            <a:ext cx="51206" cy="283464"/>
+          </a:xfrm>
+          <a:prstGeom prst="rect">
+            <a:avLst/>
+          </a:prstGeom>
+          <a:solidFill>
+            <a:srgbClr val="DB0011"/>
+          </a:solidFill>
+          <a:ln>
+            <a:noFill/>
+          </a:ln>
+          <a:effectLst/>
+        </p:spPr>
+        <p:style>
+          <a:lnRef idx="1">
+            <a:schemeClr val="accent1"/>
+          </a:lnRef>
+          <a:fillRef idx="3">
+            <a:schemeClr val="accent1"/>
+          </a:fillRef>
+          <a:effectRef idx="2">
+            <a:schemeClr val="accent1"/>
+          </a:effectRef>
+          <a:fontRef idx="minor">
+            <a:schemeClr val="lt1"/>
+          </a:fontRef>
+        </p:style>
+        <p:txBody>
+          <a:bodyPr rtlCol="0" anchor="ctr"/>
+          <a:lstStyle/>
+          <a:p/>
+        </p:txBody>
+      </p:sp>
+      <p:sp>
+        <p:nvSpPr>
+          <p:cNvPr id="40" name="TextBox 39"/>
+          <p:cNvSpPr txBox="1"/>
+          <p:nvPr/>
+        </p:nvSpPr>
+        <p:spPr>
+          <a:xfrm>
+            <a:off x="4133087" y="2747772"/>
+            <a:ext cx="868680" cy="210312"/>
+          </a:xfrm>
+          <a:prstGeom prst="rect">
+            <a:avLst/>
+          </a:prstGeom>
+          <a:noFill/>
+        </p:spPr>
+        <p:txBody>
+          <a:bodyPr wrap="none" lIns="0" rIns="0" tIns="0" bIns="0" anchor="t">
+            <a:spAutoFit/>
+          </a:bodyPr>
+          <a:lstStyle/>
+          <a:p>
+            <a:pPr algn="l">
+              <a:lnSpc>
+                <a:spcPct val="100000"/>
+              </a:lnSpc>
+              <a:spcAft>
+                <a:spcPts val="0"/>
+              </a:spcAft>
+            </a:pPr>
+            <a:r>
+              <a:rPr sz="1000" b="1" i="0">
+                <a:solidFill>
+                  <a:srgbClr val="000000"/>
+                </a:solidFill>
+                <a:latin typeface="Arial"/>
+              </a:rPr>
+              <a:t>JGB 2s30s</a:t>
+            </a:r>
+          </a:p>
+        </p:txBody>
+      </p:sp>
+      <p:sp>
+        <p:nvSpPr>
+          <p:cNvPr id="41" name="TextBox 40"/>
+          <p:cNvSpPr txBox="1"/>
+          <p:nvPr/>
+        </p:nvSpPr>
+        <p:spPr>
+          <a:xfrm>
+            <a:off x="7232904" y="2747772"/>
+            <a:ext cx="923544" cy="210312"/>
+          </a:xfrm>
+          <a:prstGeom prst="rect">
+            <a:avLst/>
+          </a:prstGeom>
+          <a:noFill/>
+        </p:spPr>
+        <p:txBody>
+          <a:bodyPr wrap="none" lIns="0" rIns="0" tIns="0" bIns="0" anchor="t">
+            <a:spAutoFit/>
+          </a:bodyPr>
+          <a:lstStyle/>
+          <a:p>
+            <a:pPr algn="r">
+              <a:lnSpc>
+                <a:spcPct val="100000"/>
+              </a:lnSpc>
+              <a:spcAft>
+                <a:spcPts val="0"/>
+              </a:spcAft>
+            </a:pPr>
+            <a:r>
+              <a:rPr sz="1000" b="1" i="0">
+                <a:solidFill>
+                  <a:srgbClr val="DB0011"/>
+                </a:solidFill>
+                <a:latin typeface="Arial"/>
+              </a:rPr>
+              <a:t>248bp · 99th</a:t>
+            </a:r>
+          </a:p>
+        </p:txBody>
+      </p:sp>
       <p:cxnSp>
         <p:nvCxnSpPr>
-          <p:cNvPr id="27" name="Connector 26"/>
+          <p:cNvPr id="42" name="Connector 41"/>
           <p:cNvCxnSpPr/>
           <p:nvPr/>
         </p:nvCxnSpPr>
         <p:spPr>
           <a:xfrm>
-            <a:off x="7168896" y="1773936"/>
-            <a:ext cx="0" cy="1353312"/>
+            <a:off x="5093207" y="3072384"/>
+            <a:ext cx="2139697" cy="0"/>
           </a:xfrm>
           <a:prstGeom prst="line">
             <a:avLst/>
           </a:prstGeom>
-          <a:ln w="6350">
+          <a:ln w="9525">
             <a:solidFill>
-              <a:srgbClr val="D0CECE"/>
+              <a:srgbClr val="000000"/>
             </a:solidFill>
           </a:ln>
         </p:spPr>
@@ -6044,20 +6674,188 @@
       </p:cxnSp>
       <p:sp>
         <p:nvSpPr>
-          <p:cNvPr id="28" name="Rectangle 27"/>
+          <p:cNvPr id="43" name="TextBox 42"/>
+          <p:cNvSpPr txBox="1"/>
+          <p:nvPr/>
+        </p:nvSpPr>
+        <p:spPr>
+          <a:xfrm>
+            <a:off x="4773168" y="3108960"/>
+            <a:ext cx="640080" cy="182880"/>
+          </a:xfrm>
+          <a:prstGeom prst="rect">
+            <a:avLst/>
+          </a:prstGeom>
+          <a:noFill/>
+        </p:spPr>
+        <p:txBody>
+          <a:bodyPr wrap="none" lIns="0" rIns="0" tIns="0" bIns="0" anchor="t">
+            <a:spAutoFit/>
+          </a:bodyPr>
+          <a:lstStyle/>
+          <a:p>
+            <a:pPr algn="ctr">
+              <a:lnSpc>
+                <a:spcPct val="100000"/>
+              </a:lnSpc>
+              <a:spcAft>
+                <a:spcPts val="0"/>
+              </a:spcAft>
+            </a:pPr>
+            <a:r>
+              <a:rPr sz="850" b="0" i="0">
+                <a:solidFill>
+                  <a:srgbClr val="767576"/>
+                </a:solidFill>
+                <a:latin typeface="Arial"/>
+              </a:rPr>
+              <a:t>0</a:t>
+            </a:r>
+          </a:p>
+        </p:txBody>
+      </p:sp>
+      <p:sp>
+        <p:nvSpPr>
+          <p:cNvPr id="44" name="TextBox 43"/>
+          <p:cNvSpPr txBox="1"/>
+          <p:nvPr/>
+        </p:nvSpPr>
+        <p:spPr>
+          <a:xfrm>
+            <a:off x="5486400" y="3108960"/>
+            <a:ext cx="640080" cy="182880"/>
+          </a:xfrm>
+          <a:prstGeom prst="rect">
+            <a:avLst/>
+          </a:prstGeom>
+          <a:noFill/>
+        </p:spPr>
+        <p:txBody>
+          <a:bodyPr wrap="none" lIns="0" rIns="0" tIns="0" bIns="0" anchor="t">
+            <a:spAutoFit/>
+          </a:bodyPr>
+          <a:lstStyle/>
+          <a:p>
+            <a:pPr algn="ctr">
+              <a:lnSpc>
+                <a:spcPct val="100000"/>
+              </a:lnSpc>
+              <a:spcAft>
+                <a:spcPts val="0"/>
+              </a:spcAft>
+            </a:pPr>
+            <a:r>
+              <a:rPr sz="850" b="0" i="0">
+                <a:solidFill>
+                  <a:srgbClr val="767576"/>
+                </a:solidFill>
+                <a:latin typeface="Arial"/>
+              </a:rPr>
+              <a:t>+90</a:t>
+            </a:r>
+          </a:p>
+        </p:txBody>
+      </p:sp>
+      <p:sp>
+        <p:nvSpPr>
+          <p:cNvPr id="45" name="TextBox 44"/>
+          <p:cNvSpPr txBox="1"/>
+          <p:nvPr/>
+        </p:nvSpPr>
+        <p:spPr>
+          <a:xfrm>
+            <a:off x="6199632" y="3108960"/>
+            <a:ext cx="640080" cy="182880"/>
+          </a:xfrm>
+          <a:prstGeom prst="rect">
+            <a:avLst/>
+          </a:prstGeom>
+          <a:noFill/>
+        </p:spPr>
+        <p:txBody>
+          <a:bodyPr wrap="none" lIns="0" rIns="0" tIns="0" bIns="0" anchor="t">
+            <a:spAutoFit/>
+          </a:bodyPr>
+          <a:lstStyle/>
+          <a:p>
+            <a:pPr algn="ctr">
+              <a:lnSpc>
+                <a:spcPct val="100000"/>
+              </a:lnSpc>
+              <a:spcAft>
+                <a:spcPts val="0"/>
+              </a:spcAft>
+            </a:pPr>
+            <a:r>
+              <a:rPr sz="850" b="0" i="0">
+                <a:solidFill>
+                  <a:srgbClr val="767576"/>
+                </a:solidFill>
+                <a:latin typeface="Arial"/>
+              </a:rPr>
+              <a:t>+180</a:t>
+            </a:r>
+          </a:p>
+        </p:txBody>
+      </p:sp>
+      <p:sp>
+        <p:nvSpPr>
+          <p:cNvPr id="46" name="TextBox 45"/>
+          <p:cNvSpPr txBox="1"/>
+          <p:nvPr/>
+        </p:nvSpPr>
+        <p:spPr>
+          <a:xfrm>
+            <a:off x="6912864" y="3108960"/>
+            <a:ext cx="640080" cy="182880"/>
+          </a:xfrm>
+          <a:prstGeom prst="rect">
+            <a:avLst/>
+          </a:prstGeom>
+          <a:noFill/>
+        </p:spPr>
+        <p:txBody>
+          <a:bodyPr wrap="none" lIns="0" rIns="0" tIns="0" bIns="0" anchor="t">
+            <a:spAutoFit/>
+          </a:bodyPr>
+          <a:lstStyle/>
+          <a:p>
+            <a:pPr algn="ctr">
+              <a:lnSpc>
+                <a:spcPct val="100000"/>
+              </a:lnSpc>
+              <a:spcAft>
+                <a:spcPts val="0"/>
+              </a:spcAft>
+            </a:pPr>
+            <a:r>
+              <a:rPr sz="850" b="0" i="0">
+                <a:solidFill>
+                  <a:srgbClr val="767576"/>
+                </a:solidFill>
+                <a:latin typeface="Arial"/>
+              </a:rPr>
+              <a:t>+270</a:t>
+            </a:r>
+          </a:p>
+        </p:txBody>
+      </p:sp>
+      <p:sp>
+        <p:nvSpPr>
+          <p:cNvPr id="47" name="Rectangle 46"/>
           <p:cNvSpPr/>
           <p:nvPr/>
         </p:nvSpPr>
         <p:spPr>
           <a:xfrm>
-            <a:off x="5065775" y="2002536"/>
-            <a:ext cx="1911927" cy="219456"/>
+            <a:off x="4133087" y="3310128"/>
+            <a:ext cx="51206" cy="128016"/>
           </a:xfrm>
           <a:prstGeom prst="rect">
             <a:avLst/>
           </a:prstGeom>
           <a:solidFill>
-            <a:srgbClr val="F4B4BB"/>
+            <a:srgbClr val="DB0011"/>
           </a:solidFill>
           <a:ln>
             <a:noFill/>
@@ -6086,20 +6884,62 @@
       </p:sp>
       <p:sp>
         <p:nvSpPr>
-          <p:cNvPr id="29" name="Rectangle 28"/>
+          <p:cNvPr id="48" name="TextBox 47"/>
+          <p:cNvSpPr txBox="1"/>
+          <p:nvPr/>
+        </p:nvSpPr>
+        <p:spPr>
+          <a:xfrm>
+            <a:off x="4248302" y="3291840"/>
+            <a:ext cx="1174089" cy="182880"/>
+          </a:xfrm>
+          <a:prstGeom prst="rect">
+            <a:avLst/>
+          </a:prstGeom>
+          <a:noFill/>
+        </p:spPr>
+        <p:txBody>
+          <a:bodyPr wrap="none" lIns="0" rIns="0" tIns="0" bIns="0" anchor="t">
+            <a:spAutoFit/>
+          </a:bodyPr>
+          <a:lstStyle/>
+          <a:p>
+            <a:pPr algn="l">
+              <a:lnSpc>
+                <a:spcPct val="100000"/>
+              </a:lnSpc>
+              <a:spcAft>
+                <a:spcPts val="0"/>
+              </a:spcAft>
+            </a:pPr>
+            <a:r>
+              <a:rPr sz="850" b="0" i="0">
+                <a:solidFill>
+                  <a:srgbClr val="767576"/>
+                </a:solidFill>
+                <a:latin typeface="Arial"/>
+              </a:rPr>
+              <a:t>Today</a:t>
+            </a:r>
+          </a:p>
+        </p:txBody>
+      </p:sp>
+      <p:sp>
+        <p:nvSpPr>
+          <p:cNvPr id="49" name="Rectangle 48"/>
           <p:cNvSpPr/>
           <p:nvPr/>
         </p:nvSpPr>
         <p:spPr>
           <a:xfrm>
-            <a:off x="6002620" y="2002536"/>
-            <a:ext cx="975082" cy="219456"/>
+            <a:off x="5486400" y="3310128"/>
+            <a:ext cx="20116" cy="128016"/>
           </a:xfrm>
           <a:prstGeom prst="rect">
             <a:avLst/>
           </a:prstGeom>
           <a:solidFill>
-            <a:srgbClr val="DB0011"/>
+            <a:srgbClr val="44546A"/>
           </a:solidFill>
           <a:ln>
             <a:noFill/>
@@ -6128,20 +6968,62 @@
       </p:sp>
       <p:sp>
         <p:nvSpPr>
-          <p:cNvPr id="30" name="Rectangle 29"/>
+          <p:cNvPr id="50" name="TextBox 49"/>
+          <p:cNvSpPr txBox="1"/>
+          <p:nvPr/>
+        </p:nvSpPr>
+        <p:spPr>
+          <a:xfrm>
+            <a:off x="5570524" y="3291840"/>
+            <a:ext cx="1205179" cy="182880"/>
+          </a:xfrm>
+          <a:prstGeom prst="rect">
+            <a:avLst/>
+          </a:prstGeom>
+          <a:noFill/>
+        </p:spPr>
+        <p:txBody>
+          <a:bodyPr wrap="none" lIns="0" rIns="0" tIns="0" bIns="0" anchor="t">
+            <a:spAutoFit/>
+          </a:bodyPr>
+          <a:lstStyle/>
+          <a:p>
+            <a:pPr algn="l">
+              <a:lnSpc>
+                <a:spcPct val="100000"/>
+              </a:lnSpc>
+              <a:spcAft>
+                <a:spcPts val="0"/>
+              </a:spcAft>
+            </a:pPr>
+            <a:r>
+              <a:rPr sz="850" b="0" i="0">
+                <a:solidFill>
+                  <a:srgbClr val="767576"/>
+                </a:solidFill>
+                <a:latin typeface="Arial"/>
+              </a:rPr>
+              <a:t>Mean</a:t>
+            </a:r>
+          </a:p>
+        </p:txBody>
+      </p:sp>
+      <p:sp>
+        <p:nvSpPr>
+          <p:cNvPr id="51" name="Rectangle 50"/>
           <p:cNvSpPr/>
           <p:nvPr/>
         </p:nvSpPr>
         <p:spPr>
           <a:xfrm>
-            <a:off x="5065775" y="2002536"/>
-            <a:ext cx="936844" cy="219456"/>
+            <a:off x="6839712" y="3328416"/>
+            <a:ext cx="201168" cy="91440"/>
           </a:xfrm>
           <a:prstGeom prst="rect">
             <a:avLst/>
           </a:prstGeom>
           <a:solidFill>
-            <a:srgbClr val="6E747A"/>
+            <a:srgbClr val="D7D8D6"/>
           </a:solidFill>
           <a:ln>
             <a:noFill/>
@@ -6170,14 +7052,56 @@
       </p:sp>
       <p:sp>
         <p:nvSpPr>
-          <p:cNvPr id="31" name="TextBox 30"/>
+          <p:cNvPr id="52" name="TextBox 51"/>
           <p:cNvSpPr txBox="1"/>
           <p:nvPr/>
         </p:nvSpPr>
         <p:spPr>
           <a:xfrm>
-            <a:off x="6374199" y="2007107"/>
-            <a:ext cx="548640" cy="210312"/>
+            <a:off x="7104888" y="3291840"/>
+            <a:ext cx="1024128" cy="182880"/>
+          </a:xfrm>
+          <a:prstGeom prst="rect">
+            <a:avLst/>
+          </a:prstGeom>
+          <a:noFill/>
+        </p:spPr>
+        <p:txBody>
+          <a:bodyPr wrap="none" lIns="0" rIns="0" tIns="0" bIns="0" anchor="t">
+            <a:spAutoFit/>
+          </a:bodyPr>
+          <a:lstStyle/>
+          <a:p>
+            <a:pPr algn="l">
+              <a:lnSpc>
+                <a:spcPct val="100000"/>
+              </a:lnSpc>
+              <a:spcAft>
+                <a:spcPts val="0"/>
+              </a:spcAft>
+            </a:pPr>
+            <a:r>
+              <a:rPr sz="850" b="0" i="0">
+                <a:solidFill>
+                  <a:srgbClr val="767576"/>
+                </a:solidFill>
+                <a:latin typeface="Arial"/>
+              </a:rPr>
+              <a:t>Since 2000</a:t>
+            </a:r>
+          </a:p>
+        </p:txBody>
+      </p:sp>
+      <p:sp>
+        <p:nvSpPr>
+          <p:cNvPr id="53" name="TextBox 52"/>
+          <p:cNvSpPr txBox="1"/>
+          <p:nvPr/>
+        </p:nvSpPr>
+        <p:spPr>
+          <a:xfrm>
+            <a:off x="6236207" y="3584448"/>
+            <a:ext cx="914400" cy="164592"/>
           </a:xfrm>
           <a:prstGeom prst="rect">
             <a:avLst/>
@@ -6201,109 +7125,25 @@
             <a:r>
               <a:rPr sz="850" b="1" i="0">
                 <a:solidFill>
-                  <a:srgbClr val="FFFFFF"/>
-                </a:solidFill>
-                <a:latin typeface="Arial"/>
-              </a:rPr>
-              <a:t>+5.1</a:t>
-            </a:r>
-          </a:p>
-        </p:txBody>
-      </p:sp>
-      <p:sp>
-        <p:nvSpPr>
-          <p:cNvPr id="32" name="TextBox 31"/>
-          <p:cNvSpPr txBox="1"/>
-          <p:nvPr/>
-        </p:nvSpPr>
-        <p:spPr>
-          <a:xfrm>
-            <a:off x="7032567" y="2020824"/>
-            <a:ext cx="914400" cy="164592"/>
-          </a:xfrm>
-          <a:prstGeom prst="rect">
-            <a:avLst/>
-          </a:prstGeom>
-          <a:noFill/>
-        </p:spPr>
-        <p:txBody>
-          <a:bodyPr wrap="none" lIns="0" rIns="0" tIns="0" bIns="0" anchor="t">
-            <a:spAutoFit/>
-          </a:bodyPr>
-          <a:lstStyle/>
-          <a:p>
-            <a:pPr algn="l">
-              <a:lnSpc>
-                <a:spcPct val="100000"/>
-              </a:lnSpc>
-              <a:spcAft>
-                <a:spcPts val="0"/>
-              </a:spcAft>
-            </a:pPr>
-            <a:r>
-              <a:rPr sz="700" b="0" i="0">
-                <a:solidFill>
-                  <a:srgbClr val="767576"/>
-                </a:solidFill>
-                <a:latin typeface="Arial"/>
-              </a:rPr>
-              <a:t>10y +10.0</a:t>
-            </a:r>
-          </a:p>
-        </p:txBody>
-      </p:sp>
-      <p:sp>
-        <p:nvSpPr>
-          <p:cNvPr id="33" name="TextBox 32"/>
-          <p:cNvSpPr txBox="1"/>
-          <p:nvPr/>
-        </p:nvSpPr>
-        <p:spPr>
-          <a:xfrm>
-            <a:off x="4133087" y="2007107"/>
-            <a:ext cx="877824" cy="210312"/>
-          </a:xfrm>
-          <a:prstGeom prst="rect">
-            <a:avLst/>
-          </a:prstGeom>
-          <a:noFill/>
-        </p:spPr>
-        <p:txBody>
-          <a:bodyPr wrap="none" lIns="0" rIns="0" tIns="0" bIns="0" anchor="t">
-            <a:spAutoFit/>
-          </a:bodyPr>
-          <a:lstStyle/>
-          <a:p>
-            <a:pPr algn="l">
-              <a:lnSpc>
-                <a:spcPct val="100000"/>
-              </a:lnSpc>
-              <a:spcAft>
-                <a:spcPts val="0"/>
-              </a:spcAft>
-            </a:pPr>
-            <a:r>
-              <a:rPr sz="1000" b="1" i="0">
-                <a:solidFill>
                   <a:srgbClr val="DB0011"/>
                 </a:solidFill>
                 <a:latin typeface="Arial"/>
               </a:rPr>
-              <a:t>JGB 2s10s</a:t>
-            </a:r>
-          </a:p>
-        </p:txBody>
-      </p:sp>
-      <p:sp>
-        <p:nvSpPr>
-          <p:cNvPr id="34" name="TextBox 33"/>
+              <a:t>2s10s</a:t>
+            </a:r>
+          </a:p>
+        </p:txBody>
+      </p:sp>
+      <p:sp>
+        <p:nvSpPr>
+          <p:cNvPr id="54" name="TextBox 53"/>
           <p:cNvSpPr txBox="1"/>
           <p:nvPr/>
         </p:nvSpPr>
         <p:spPr>
           <a:xfrm>
-            <a:off x="7168896" y="1929384"/>
-            <a:ext cx="987552" cy="201168"/>
+            <a:off x="7150607" y="3584448"/>
+            <a:ext cx="914400" cy="164592"/>
           </a:xfrm>
           <a:prstGeom prst="rect">
             <a:avLst/>
@@ -6325,405 +7165,27 @@
               </a:spcAft>
             </a:pPr>
             <a:r>
-              <a:rPr sz="1050" b="1" i="0">
-                <a:solidFill>
-                  <a:srgbClr val="DB0011"/>
-                </a:solidFill>
-                <a:latin typeface="Arial"/>
-              </a:rPr>
-              <a:t>5.1bp</a:t>
-            </a:r>
-          </a:p>
-        </p:txBody>
-      </p:sp>
-      <p:sp>
-        <p:nvSpPr>
-          <p:cNvPr id="35" name="TextBox 34"/>
-          <p:cNvSpPr txBox="1"/>
-          <p:nvPr/>
-        </p:nvSpPr>
-        <p:spPr>
-          <a:xfrm>
-            <a:off x="7168896" y="2139696"/>
-            <a:ext cx="987552" cy="164592"/>
-          </a:xfrm>
-          <a:prstGeom prst="rect">
-            <a:avLst/>
-          </a:prstGeom>
-          <a:noFill/>
-        </p:spPr>
-        <p:txBody>
-          <a:bodyPr wrap="none" lIns="0" rIns="0" tIns="0" bIns="0" anchor="t">
-            <a:spAutoFit/>
-          </a:bodyPr>
-          <a:lstStyle/>
-          <a:p>
-            <a:pPr algn="r">
-              <a:lnSpc>
-                <a:spcPct val="100000"/>
-              </a:lnSpc>
-              <a:spcAft>
-                <a:spcPts val="0"/>
-              </a:spcAft>
-            </a:pPr>
-            <a:r>
-              <a:rPr sz="750" b="0" i="0">
-                <a:solidFill>
-                  <a:srgbClr val="767576"/>
-                </a:solidFill>
-                <a:latin typeface="Arial"/>
-              </a:rPr>
-              <a:t>kept per 10bp</a:t>
-            </a:r>
-          </a:p>
-        </p:txBody>
-      </p:sp>
-      <p:sp>
-        <p:nvSpPr>
-          <p:cNvPr id="36" name="Rectangle 35"/>
-          <p:cNvSpPr/>
-          <p:nvPr/>
-        </p:nvSpPr>
-        <p:spPr>
-          <a:xfrm>
-            <a:off x="5065775" y="2679191"/>
-            <a:ext cx="1433945" cy="219456"/>
-          </a:xfrm>
-          <a:prstGeom prst="rect">
-            <a:avLst/>
-          </a:prstGeom>
-          <a:solidFill>
-            <a:srgbClr val="D7D8D6"/>
-          </a:solidFill>
-          <a:ln>
-            <a:noFill/>
-          </a:ln>
-          <a:effectLst/>
-        </p:spPr>
-        <p:style>
-          <a:lnRef idx="1">
-            <a:schemeClr val="accent1"/>
-          </a:lnRef>
-          <a:fillRef idx="3">
-            <a:schemeClr val="accent1"/>
-          </a:fillRef>
-          <a:effectRef idx="2">
-            <a:schemeClr val="accent1"/>
-          </a:effectRef>
-          <a:fontRef idx="minor">
-            <a:schemeClr val="lt1"/>
-          </a:fontRef>
-        </p:style>
-        <p:txBody>
-          <a:bodyPr rtlCol="0" anchor="ctr"/>
-          <a:lstStyle/>
-          <a:p/>
-        </p:txBody>
-      </p:sp>
-      <p:sp>
-        <p:nvSpPr>
-          <p:cNvPr id="37" name="Rectangle 36"/>
-          <p:cNvSpPr/>
-          <p:nvPr/>
-        </p:nvSpPr>
-        <p:spPr>
-          <a:xfrm>
-            <a:off x="6002620" y="2679191"/>
-            <a:ext cx="497101" cy="219456"/>
-          </a:xfrm>
-          <a:prstGeom prst="rect">
-            <a:avLst/>
-          </a:prstGeom>
-          <a:solidFill>
-            <a:srgbClr val="44546A"/>
-          </a:solidFill>
-          <a:ln>
-            <a:noFill/>
-          </a:ln>
-          <a:effectLst/>
-        </p:spPr>
-        <p:style>
-          <a:lnRef idx="1">
-            <a:schemeClr val="accent1"/>
-          </a:lnRef>
-          <a:fillRef idx="3">
-            <a:schemeClr val="accent1"/>
-          </a:fillRef>
-          <a:effectRef idx="2">
-            <a:schemeClr val="accent1"/>
-          </a:effectRef>
-          <a:fontRef idx="minor">
-            <a:schemeClr val="lt1"/>
-          </a:fontRef>
-        </p:style>
-        <p:txBody>
-          <a:bodyPr rtlCol="0" anchor="ctr"/>
-          <a:lstStyle/>
-          <a:p/>
-        </p:txBody>
-      </p:sp>
-      <p:sp>
-        <p:nvSpPr>
-          <p:cNvPr id="38" name="Rectangle 37"/>
-          <p:cNvSpPr/>
-          <p:nvPr/>
-        </p:nvSpPr>
-        <p:spPr>
-          <a:xfrm>
-            <a:off x="5065775" y="2679191"/>
-            <a:ext cx="936844" cy="219456"/>
-          </a:xfrm>
-          <a:prstGeom prst="rect">
-            <a:avLst/>
-          </a:prstGeom>
-          <a:solidFill>
-            <a:srgbClr val="6E747A"/>
-          </a:solidFill>
-          <a:ln>
-            <a:noFill/>
-          </a:ln>
-          <a:effectLst/>
-        </p:spPr>
-        <p:style>
-          <a:lnRef idx="1">
-            <a:schemeClr val="accent1"/>
-          </a:lnRef>
-          <a:fillRef idx="3">
-            <a:schemeClr val="accent1"/>
-          </a:fillRef>
-          <a:effectRef idx="2">
-            <a:schemeClr val="accent1"/>
-          </a:effectRef>
-          <a:fontRef idx="minor">
-            <a:schemeClr val="lt1"/>
-          </a:fontRef>
-        </p:style>
-        <p:txBody>
-          <a:bodyPr rtlCol="0" anchor="ctr"/>
-          <a:lstStyle/>
-          <a:p/>
-        </p:txBody>
-      </p:sp>
-      <p:sp>
-        <p:nvSpPr>
-          <p:cNvPr id="39" name="TextBox 38"/>
-          <p:cNvSpPr txBox="1"/>
-          <p:nvPr/>
-        </p:nvSpPr>
-        <p:spPr>
-          <a:xfrm>
-            <a:off x="6554585" y="2683763"/>
-            <a:ext cx="502920" cy="210312"/>
-          </a:xfrm>
-          <a:prstGeom prst="rect">
-            <a:avLst/>
-          </a:prstGeom>
-          <a:noFill/>
-        </p:spPr>
-        <p:txBody>
-          <a:bodyPr wrap="none" lIns="0" rIns="0" tIns="0" bIns="0" anchor="t">
-            <a:spAutoFit/>
-          </a:bodyPr>
-          <a:lstStyle/>
-          <a:p>
-            <a:pPr algn="l">
-              <a:lnSpc>
-                <a:spcPct val="100000"/>
-              </a:lnSpc>
-              <a:spcAft>
-                <a:spcPts val="0"/>
-              </a:spcAft>
-            </a:pPr>
-            <a:r>
               <a:rPr sz="850" b="1" i="0">
                 <a:solidFill>
                   <a:srgbClr val="767576"/>
                 </a:solidFill>
                 <a:latin typeface="Arial"/>
               </a:rPr>
-              <a:t>+2.6</a:t>
-            </a:r>
-          </a:p>
-        </p:txBody>
-      </p:sp>
-      <p:sp>
-        <p:nvSpPr>
-          <p:cNvPr id="40" name="TextBox 39"/>
-          <p:cNvSpPr txBox="1"/>
-          <p:nvPr/>
-        </p:nvSpPr>
-        <p:spPr>
-          <a:xfrm>
-            <a:off x="6938633" y="2697479"/>
-            <a:ext cx="914400" cy="164592"/>
-          </a:xfrm>
-          <a:prstGeom prst="rect">
-            <a:avLst/>
-          </a:prstGeom>
-          <a:noFill/>
-        </p:spPr>
-        <p:txBody>
-          <a:bodyPr wrap="none" lIns="0" rIns="0" tIns="0" bIns="0" anchor="t">
-            <a:spAutoFit/>
-          </a:bodyPr>
-          <a:lstStyle/>
-          <a:p>
-            <a:pPr algn="l">
-              <a:lnSpc>
-                <a:spcPct val="100000"/>
-              </a:lnSpc>
-              <a:spcAft>
-                <a:spcPts val="0"/>
-              </a:spcAft>
-            </a:pPr>
-            <a:r>
-              <a:rPr sz="700" b="0" i="0">
-                <a:solidFill>
-                  <a:srgbClr val="767576"/>
-                </a:solidFill>
-                <a:latin typeface="Arial"/>
-              </a:rPr>
-              <a:t>30y +7.5</a:t>
-            </a:r>
-          </a:p>
-        </p:txBody>
-      </p:sp>
-      <p:sp>
-        <p:nvSpPr>
-          <p:cNvPr id="41" name="TextBox 40"/>
-          <p:cNvSpPr txBox="1"/>
-          <p:nvPr/>
-        </p:nvSpPr>
-        <p:spPr>
-          <a:xfrm>
-            <a:off x="4133087" y="2683763"/>
-            <a:ext cx="877824" cy="210312"/>
-          </a:xfrm>
-          <a:prstGeom prst="rect">
-            <a:avLst/>
-          </a:prstGeom>
-          <a:noFill/>
-        </p:spPr>
-        <p:txBody>
-          <a:bodyPr wrap="none" lIns="0" rIns="0" tIns="0" bIns="0" anchor="t">
-            <a:spAutoFit/>
-          </a:bodyPr>
-          <a:lstStyle/>
-          <a:p>
-            <a:pPr algn="l">
-              <a:lnSpc>
-                <a:spcPct val="100000"/>
-              </a:lnSpc>
-              <a:spcAft>
-                <a:spcPts val="0"/>
-              </a:spcAft>
-            </a:pPr>
-            <a:r>
-              <a:rPr sz="1000" b="1" i="0">
-                <a:solidFill>
-                  <a:srgbClr val="767576"/>
-                </a:solidFill>
-                <a:latin typeface="Arial"/>
-              </a:rPr>
-              <a:t>JGB 2s30s</a:t>
-            </a:r>
-          </a:p>
-        </p:txBody>
-      </p:sp>
-      <p:sp>
-        <p:nvSpPr>
-          <p:cNvPr id="42" name="TextBox 41"/>
-          <p:cNvSpPr txBox="1"/>
-          <p:nvPr/>
-        </p:nvSpPr>
-        <p:spPr>
-          <a:xfrm>
-            <a:off x="7168896" y="2606039"/>
-            <a:ext cx="987552" cy="201168"/>
-          </a:xfrm>
-          <a:prstGeom prst="rect">
-            <a:avLst/>
-          </a:prstGeom>
-          <a:noFill/>
-        </p:spPr>
-        <p:txBody>
-          <a:bodyPr wrap="none" lIns="0" rIns="0" tIns="0" bIns="0" anchor="t">
-            <a:spAutoFit/>
-          </a:bodyPr>
-          <a:lstStyle/>
-          <a:p>
-            <a:pPr algn="r">
-              <a:lnSpc>
-                <a:spcPct val="100000"/>
-              </a:lnSpc>
-              <a:spcAft>
-                <a:spcPts val="0"/>
-              </a:spcAft>
-            </a:pPr>
-            <a:r>
-              <a:rPr sz="1050" b="0" i="0">
-                <a:solidFill>
-                  <a:srgbClr val="767576"/>
-                </a:solidFill>
-                <a:latin typeface="Arial"/>
-              </a:rPr>
-              <a:t>2.6bp</a:t>
-            </a:r>
-          </a:p>
-        </p:txBody>
-      </p:sp>
-      <p:sp>
-        <p:nvSpPr>
-          <p:cNvPr id="43" name="TextBox 42"/>
-          <p:cNvSpPr txBox="1"/>
-          <p:nvPr/>
-        </p:nvSpPr>
-        <p:spPr>
-          <a:xfrm>
-            <a:off x="7168896" y="2816351"/>
-            <a:ext cx="987552" cy="164592"/>
-          </a:xfrm>
-          <a:prstGeom prst="rect">
-            <a:avLst/>
-          </a:prstGeom>
-          <a:noFill/>
-        </p:spPr>
-        <p:txBody>
-          <a:bodyPr wrap="none" lIns="0" rIns="0" tIns="0" bIns="0" anchor="t">
-            <a:spAutoFit/>
-          </a:bodyPr>
-          <a:lstStyle/>
-          <a:p>
-            <a:pPr algn="r">
-              <a:lnSpc>
-                <a:spcPct val="100000"/>
-              </a:lnSpc>
-              <a:spcAft>
-                <a:spcPts val="0"/>
-              </a:spcAft>
-            </a:pPr>
-            <a:r>
-              <a:rPr sz="750" b="0" i="0">
-                <a:solidFill>
-                  <a:srgbClr val="767576"/>
-                </a:solidFill>
-                <a:latin typeface="Arial"/>
-              </a:rPr>
-              <a:t>kept per 10bp</a:t>
+              <a:t>2s30s</a:t>
             </a:r>
           </a:p>
         </p:txBody>
       </p:sp>
       <p:cxnSp>
         <p:nvCxnSpPr>
-          <p:cNvPr id="44" name="Connector 43"/>
+          <p:cNvPr id="55" name="Connector 54"/>
           <p:cNvCxnSpPr/>
           <p:nvPr/>
         </p:nvCxnSpPr>
         <p:spPr>
           <a:xfrm>
-            <a:off x="5065775" y="3127248"/>
-            <a:ext cx="2103121" cy="0"/>
+            <a:off x="4133087" y="3767328"/>
+            <a:ext cx="3931921" cy="0"/>
           </a:xfrm>
           <a:prstGeom prst="line">
             <a:avLst/>
@@ -6751,266 +7213,14 @@
       </p:cxnSp>
       <p:sp>
         <p:nvSpPr>
-          <p:cNvPr id="45" name="TextBox 44"/>
+          <p:cNvPr id="56" name="TextBox 55"/>
           <p:cNvSpPr txBox="1"/>
           <p:nvPr/>
         </p:nvSpPr>
         <p:spPr>
           <a:xfrm>
-            <a:off x="4791455" y="3163824"/>
-            <a:ext cx="548640" cy="164592"/>
-          </a:xfrm>
-          <a:prstGeom prst="rect">
-            <a:avLst/>
-          </a:prstGeom>
-          <a:noFill/>
-        </p:spPr>
-        <p:txBody>
-          <a:bodyPr wrap="none" lIns="0" rIns="0" tIns="0" bIns="0" anchor="t">
-            <a:spAutoFit/>
-          </a:bodyPr>
-          <a:lstStyle/>
-          <a:p>
-            <a:pPr algn="ctr">
-              <a:lnSpc>
-                <a:spcPct val="100000"/>
-              </a:lnSpc>
-              <a:spcAft>
-                <a:spcPts val="0"/>
-              </a:spcAft>
-            </a:pPr>
-            <a:r>
-              <a:rPr sz="800" b="0" i="0">
-                <a:solidFill>
-                  <a:srgbClr val="767576"/>
-                </a:solidFill>
-                <a:latin typeface="Arial"/>
-              </a:rPr>
-              <a:t>0</a:t>
-            </a:r>
-          </a:p>
-        </p:txBody>
-      </p:sp>
-      <p:sp>
-        <p:nvSpPr>
-          <p:cNvPr id="46" name="TextBox 45"/>
-          <p:cNvSpPr txBox="1"/>
-          <p:nvPr/>
-        </p:nvSpPr>
-        <p:spPr>
-          <a:xfrm>
-            <a:off x="5317236" y="3163824"/>
-            <a:ext cx="548640" cy="164592"/>
-          </a:xfrm>
-          <a:prstGeom prst="rect">
-            <a:avLst/>
-          </a:prstGeom>
-          <a:noFill/>
-        </p:spPr>
-        <p:txBody>
-          <a:bodyPr wrap="none" lIns="0" rIns="0" tIns="0" bIns="0" anchor="t">
-            <a:spAutoFit/>
-          </a:bodyPr>
-          <a:lstStyle/>
-          <a:p>
-            <a:pPr algn="ctr">
-              <a:lnSpc>
-                <a:spcPct val="100000"/>
-              </a:lnSpc>
-              <a:spcAft>
-                <a:spcPts val="0"/>
-              </a:spcAft>
-            </a:pPr>
-            <a:r>
-              <a:rPr sz="800" b="0" i="0">
-                <a:solidFill>
-                  <a:srgbClr val="767576"/>
-                </a:solidFill>
-                <a:latin typeface="Arial"/>
-              </a:rPr>
-              <a:t>2.5</a:t>
-            </a:r>
-          </a:p>
-        </p:txBody>
-      </p:sp>
-      <p:sp>
-        <p:nvSpPr>
-          <p:cNvPr id="47" name="TextBox 46"/>
-          <p:cNvSpPr txBox="1"/>
-          <p:nvPr/>
-        </p:nvSpPr>
-        <p:spPr>
-          <a:xfrm>
-            <a:off x="5843016" y="3163824"/>
-            <a:ext cx="548640" cy="164592"/>
-          </a:xfrm>
-          <a:prstGeom prst="rect">
-            <a:avLst/>
-          </a:prstGeom>
-          <a:noFill/>
-        </p:spPr>
-        <p:txBody>
-          <a:bodyPr wrap="none" lIns="0" rIns="0" tIns="0" bIns="0" anchor="t">
-            <a:spAutoFit/>
-          </a:bodyPr>
-          <a:lstStyle/>
-          <a:p>
-            <a:pPr algn="ctr">
-              <a:lnSpc>
-                <a:spcPct val="100000"/>
-              </a:lnSpc>
-              <a:spcAft>
-                <a:spcPts val="0"/>
-              </a:spcAft>
-            </a:pPr>
-            <a:r>
-              <a:rPr sz="800" b="0" i="0">
-                <a:solidFill>
-                  <a:srgbClr val="767576"/>
-                </a:solidFill>
-                <a:latin typeface="Arial"/>
-              </a:rPr>
-              <a:t>5</a:t>
-            </a:r>
-          </a:p>
-        </p:txBody>
-      </p:sp>
-      <p:sp>
-        <p:nvSpPr>
-          <p:cNvPr id="48" name="TextBox 47"/>
-          <p:cNvSpPr txBox="1"/>
-          <p:nvPr/>
-        </p:nvSpPr>
-        <p:spPr>
-          <a:xfrm>
-            <a:off x="6368795" y="3163824"/>
-            <a:ext cx="548640" cy="164592"/>
-          </a:xfrm>
-          <a:prstGeom prst="rect">
-            <a:avLst/>
-          </a:prstGeom>
-          <a:noFill/>
-        </p:spPr>
-        <p:txBody>
-          <a:bodyPr wrap="none" lIns="0" rIns="0" tIns="0" bIns="0" anchor="t">
-            <a:spAutoFit/>
-          </a:bodyPr>
-          <a:lstStyle/>
-          <a:p>
-            <a:pPr algn="ctr">
-              <a:lnSpc>
-                <a:spcPct val="100000"/>
-              </a:lnSpc>
-              <a:spcAft>
-                <a:spcPts val="0"/>
-              </a:spcAft>
-            </a:pPr>
-            <a:r>
-              <a:rPr sz="800" b="0" i="0">
-                <a:solidFill>
-                  <a:srgbClr val="767576"/>
-                </a:solidFill>
-                <a:latin typeface="Arial"/>
-              </a:rPr>
-              <a:t>7.5</a:t>
-            </a:r>
-          </a:p>
-        </p:txBody>
-      </p:sp>
-      <p:sp>
-        <p:nvSpPr>
-          <p:cNvPr id="49" name="TextBox 48"/>
-          <p:cNvSpPr txBox="1"/>
-          <p:nvPr/>
-        </p:nvSpPr>
-        <p:spPr>
-          <a:xfrm>
-            <a:off x="6894576" y="3163824"/>
-            <a:ext cx="548640" cy="164592"/>
-          </a:xfrm>
-          <a:prstGeom prst="rect">
-            <a:avLst/>
-          </a:prstGeom>
-          <a:noFill/>
-        </p:spPr>
-        <p:txBody>
-          <a:bodyPr wrap="none" lIns="0" rIns="0" tIns="0" bIns="0" anchor="t">
-            <a:spAutoFit/>
-          </a:bodyPr>
-          <a:lstStyle/>
-          <a:p>
-            <a:pPr algn="ctr">
-              <a:lnSpc>
-                <a:spcPct val="100000"/>
-              </a:lnSpc>
-              <a:spcAft>
-                <a:spcPts val="0"/>
-              </a:spcAft>
-            </a:pPr>
-            <a:r>
-              <a:rPr sz="800" b="0" i="0">
-                <a:solidFill>
-                  <a:srgbClr val="767576"/>
-                </a:solidFill>
-                <a:latin typeface="Arial"/>
-              </a:rPr>
-              <a:t>10</a:t>
-            </a:r>
-          </a:p>
-        </p:txBody>
-      </p:sp>
-      <p:sp>
-        <p:nvSpPr>
-          <p:cNvPr id="50" name="Rectangle 49"/>
-          <p:cNvSpPr/>
-          <p:nvPr/>
-        </p:nvSpPr>
-        <p:spPr>
-          <a:xfrm>
-            <a:off x="4133087" y="3387851"/>
-            <a:ext cx="182880" cy="100584"/>
-          </a:xfrm>
-          <a:prstGeom prst="rect">
-            <a:avLst/>
-          </a:prstGeom>
-          <a:solidFill>
-            <a:srgbClr val="6E747A"/>
-          </a:solidFill>
-          <a:ln>
-            <a:noFill/>
-          </a:ln>
-          <a:effectLst/>
-        </p:spPr>
-        <p:style>
-          <a:lnRef idx="1">
-            <a:schemeClr val="accent1"/>
-          </a:lnRef>
-          <a:fillRef idx="3">
-            <a:schemeClr val="accent1"/>
-          </a:fillRef>
-          <a:effectRef idx="2">
-            <a:schemeClr val="accent1"/>
-          </a:effectRef>
-          <a:fontRef idx="minor">
-            <a:schemeClr val="lt1"/>
-          </a:fontRef>
-        </p:style>
-        <p:txBody>
-          <a:bodyPr rtlCol="0" anchor="ctr"/>
-          <a:lstStyle/>
-          <a:p/>
-        </p:txBody>
-      </p:sp>
-      <p:sp>
-        <p:nvSpPr>
-          <p:cNvPr id="51" name="TextBox 50"/>
-          <p:cNvSpPr txBox="1"/>
-          <p:nvPr/>
-        </p:nvSpPr>
-        <p:spPr>
-          <a:xfrm>
-            <a:off x="4370831" y="3346703"/>
-            <a:ext cx="2224552" cy="182880"/>
+            <a:off x="4133087" y="3822191"/>
+            <a:ext cx="2029967" cy="164592"/>
           </a:xfrm>
           <a:prstGeom prst="rect">
             <a:avLst/>
@@ -7034,108 +7244,24 @@
             <a:r>
               <a:rPr sz="800" b="0" i="0">
                 <a:solidFill>
-                  <a:srgbClr val="767576"/>
+                  <a:srgbClr val="000000"/>
                 </a:solidFill>
                 <a:latin typeface="Arial"/>
               </a:rPr>
-              <a:t>Given back as the 2y follows, 0.49</a:t>
-            </a:r>
-          </a:p>
-        </p:txBody>
-      </p:sp>
-      <p:sp>
-        <p:nvSpPr>
-          <p:cNvPr id="52" name="Rectangle 51"/>
-          <p:cNvSpPr/>
-          <p:nvPr/>
-        </p:nvSpPr>
-        <p:spPr>
-          <a:xfrm>
-            <a:off x="6650248" y="3364991"/>
-            <a:ext cx="23774" cy="146304"/>
-          </a:xfrm>
-          <a:prstGeom prst="rect">
-            <a:avLst/>
-          </a:prstGeom>
-          <a:solidFill>
-            <a:srgbClr val="DB0011"/>
-          </a:solidFill>
-          <a:ln>
-            <a:noFill/>
-          </a:ln>
-          <a:effectLst/>
-        </p:spPr>
-        <p:style>
-          <a:lnRef idx="1">
-            <a:schemeClr val="accent1"/>
-          </a:lnRef>
-          <a:fillRef idx="3">
-            <a:schemeClr val="accent1"/>
-          </a:fillRef>
-          <a:effectRef idx="2">
-            <a:schemeClr val="accent1"/>
-          </a:effectRef>
-          <a:fontRef idx="minor">
-            <a:schemeClr val="lt1"/>
-          </a:fontRef>
-        </p:style>
-        <p:txBody>
-          <a:bodyPr rtlCol="0" anchor="ctr"/>
-          <a:lstStyle/>
-          <a:p/>
-        </p:txBody>
-      </p:sp>
-      <p:sp>
-        <p:nvSpPr>
-          <p:cNvPr id="53" name="TextBox 52"/>
+              <a:t>Back leg follows the 10y at</a:t>
+            </a:r>
+          </a:p>
+        </p:txBody>
+      </p:sp>
+      <p:sp>
+        <p:nvSpPr>
+          <p:cNvPr id="57" name="TextBox 56"/>
           <p:cNvSpPr txBox="1"/>
           <p:nvPr/>
         </p:nvSpPr>
         <p:spPr>
           <a:xfrm>
-            <a:off x="6728886" y="3346703"/>
-            <a:ext cx="1409273" cy="182880"/>
-          </a:xfrm>
-          <a:prstGeom prst="rect">
-            <a:avLst/>
-          </a:prstGeom>
-          <a:noFill/>
-        </p:spPr>
-        <p:txBody>
-          <a:bodyPr wrap="none" lIns="0" rIns="0" tIns="0" bIns="0" anchor="t">
-            <a:spAutoFit/>
-          </a:bodyPr>
-          <a:lstStyle/>
-          <a:p>
-            <a:pPr algn="l">
-              <a:lnSpc>
-                <a:spcPct val="100000"/>
-              </a:lnSpc>
-              <a:spcAft>
-                <a:spcPts val="0"/>
-              </a:spcAft>
-            </a:pPr>
-            <a:r>
-              <a:rPr sz="800" b="0" i="0">
-                <a:solidFill>
-                  <a:srgbClr val="767576"/>
-                </a:solidFill>
-                <a:latin typeface="Arial"/>
-              </a:rPr>
-              <a:t>Kept</a:t>
-            </a:r>
-          </a:p>
-        </p:txBody>
-      </p:sp>
-      <p:sp>
-        <p:nvSpPr>
-          <p:cNvPr id="54" name="TextBox 53"/>
-          <p:cNvSpPr txBox="1"/>
-          <p:nvPr/>
-        </p:nvSpPr>
-        <p:spPr>
-          <a:xfrm>
-            <a:off x="6236207" y="3584448"/>
+            <a:off x="6236207" y="3822191"/>
             <a:ext cx="914400" cy="164592"/>
           </a:xfrm>
           <a:prstGeom prst="rect">
@@ -7164,20 +7290,20 @@
                 </a:solidFill>
                 <a:latin typeface="Arial"/>
               </a:rPr>
-              <a:t>2s10s</a:t>
-            </a:r>
-          </a:p>
-        </p:txBody>
-      </p:sp>
-      <p:sp>
-        <p:nvSpPr>
-          <p:cNvPr id="55" name="TextBox 54"/>
+              <a:t>1.00</a:t>
+            </a:r>
+          </a:p>
+        </p:txBody>
+      </p:sp>
+      <p:sp>
+        <p:nvSpPr>
+          <p:cNvPr id="58" name="TextBox 57"/>
           <p:cNvSpPr txBox="1"/>
           <p:nvPr/>
         </p:nvSpPr>
         <p:spPr>
           <a:xfrm>
-            <a:off x="7150607" y="3584448"/>
+            <a:off x="7150607" y="3822191"/>
             <a:ext cx="914400" cy="164592"/>
           </a:xfrm>
           <a:prstGeom prst="rect">
@@ -7200,34 +7326,34 @@
               </a:spcAft>
             </a:pPr>
             <a:r>
-              <a:rPr sz="850" b="1" i="0">
+              <a:rPr sz="850" b="0" i="0">
                 <a:solidFill>
                   <a:srgbClr val="767576"/>
                 </a:solidFill>
                 <a:latin typeface="Arial"/>
               </a:rPr>
-              <a:t>2s30s</a:t>
+              <a:t>0.75</a:t>
             </a:r>
           </a:p>
         </p:txBody>
       </p:sp>
       <p:cxnSp>
         <p:nvCxnSpPr>
-          <p:cNvPr id="56" name="Connector 55"/>
+          <p:cNvPr id="59" name="Connector 58"/>
           <p:cNvCxnSpPr/>
           <p:nvPr/>
         </p:nvCxnSpPr>
         <p:spPr>
           <a:xfrm>
-            <a:off x="4133087" y="3767328"/>
+            <a:off x="4133087" y="3968496"/>
             <a:ext cx="3931921" cy="0"/>
           </a:xfrm>
           <a:prstGeom prst="line">
             <a:avLst/>
           </a:prstGeom>
-          <a:ln w="9525">
+          <a:ln w="6350">
             <a:solidFill>
-              <a:srgbClr val="000000"/>
+              <a:srgbClr val="D0CECE"/>
             </a:solidFill>
           </a:ln>
         </p:spPr>
@@ -7248,13 +7374,13 @@
       </p:cxnSp>
       <p:sp>
         <p:nvSpPr>
-          <p:cNvPr id="57" name="TextBox 56"/>
+          <p:cNvPr id="60" name="TextBox 59"/>
           <p:cNvSpPr txBox="1"/>
           <p:nvPr/>
         </p:nvSpPr>
         <p:spPr>
           <a:xfrm>
-            <a:off x="4133087" y="3822191"/>
+            <a:off x="4133087" y="4005072"/>
             <a:ext cx="2029967" cy="164592"/>
           </a:xfrm>
           <a:prstGeom prst="rect">
@@ -7283,20 +7409,20 @@
                 </a:solidFill>
                 <a:latin typeface="Arial"/>
               </a:rPr>
-              <a:t>Back leg follows the 10y at</a:t>
-            </a:r>
-          </a:p>
-        </p:txBody>
-      </p:sp>
-      <p:sp>
-        <p:nvSpPr>
-          <p:cNvPr id="58" name="TextBox 57"/>
+              <a:t>Stopped out, comparable entries</a:t>
+            </a:r>
+          </a:p>
+        </p:txBody>
+      </p:sp>
+      <p:sp>
+        <p:nvSpPr>
+          <p:cNvPr id="61" name="TextBox 60"/>
           <p:cNvSpPr txBox="1"/>
           <p:nvPr/>
         </p:nvSpPr>
         <p:spPr>
           <a:xfrm>
-            <a:off x="6236207" y="3822191"/>
+            <a:off x="6236207" y="4005072"/>
             <a:ext cx="914400" cy="164592"/>
           </a:xfrm>
           <a:prstGeom prst="rect">
@@ -7325,20 +7451,20 @@
                 </a:solidFill>
                 <a:latin typeface="Arial"/>
               </a:rPr>
-              <a:t>1.00</a:t>
-            </a:r>
-          </a:p>
-        </p:txBody>
-      </p:sp>
-      <p:sp>
-        <p:nvSpPr>
-          <p:cNvPr id="59" name="TextBox 58"/>
+              <a:t>17%</a:t>
+            </a:r>
+          </a:p>
+        </p:txBody>
+      </p:sp>
+      <p:sp>
+        <p:nvSpPr>
+          <p:cNvPr id="62" name="TextBox 61"/>
           <p:cNvSpPr txBox="1"/>
           <p:nvPr/>
         </p:nvSpPr>
         <p:spPr>
           <a:xfrm>
-            <a:off x="7150607" y="3822191"/>
+            <a:off x="7150607" y="4005072"/>
             <a:ext cx="914400" cy="164592"/>
           </a:xfrm>
           <a:prstGeom prst="rect">
@@ -7367,20 +7493,20 @@
                 </a:solidFill>
                 <a:latin typeface="Arial"/>
               </a:rPr>
-              <a:t>0.75</a:t>
+              <a:t>57%</a:t>
             </a:r>
           </a:p>
         </p:txBody>
       </p:sp>
       <p:cxnSp>
         <p:nvCxnSpPr>
-          <p:cNvPr id="60" name="Connector 59"/>
+          <p:cNvPr id="63" name="Connector 62"/>
           <p:cNvCxnSpPr/>
           <p:nvPr/>
         </p:nvCxnSpPr>
         <p:spPr>
           <a:xfrm>
-            <a:off x="4133087" y="3968496"/>
+            <a:off x="4133087" y="4151376"/>
             <a:ext cx="3931921" cy="0"/>
           </a:xfrm>
           <a:prstGeom prst="line">
@@ -7409,13 +7535,13 @@
       </p:cxnSp>
       <p:sp>
         <p:nvSpPr>
-          <p:cNvPr id="61" name="TextBox 60"/>
+          <p:cNvPr id="64" name="TextBox 63"/>
           <p:cNvSpPr txBox="1"/>
           <p:nvPr/>
         </p:nvSpPr>
         <p:spPr>
           <a:xfrm>
-            <a:off x="4133087" y="4005072"/>
+            <a:off x="4133087" y="4187952"/>
             <a:ext cx="2029967" cy="164592"/>
           </a:xfrm>
           <a:prstGeom prst="rect">
@@ -7444,20 +7570,20 @@
                 </a:solidFill>
                 <a:latin typeface="Arial"/>
               </a:rPr>
-              <a:t>Percentile since 2000</a:t>
-            </a:r>
-          </a:p>
-        </p:txBody>
-      </p:sp>
-      <p:sp>
-        <p:nvSpPr>
-          <p:cNvPr id="62" name="TextBox 61"/>
+              <a:t>Notional per ¥1bn back leg</a:t>
+            </a:r>
+          </a:p>
+        </p:txBody>
+      </p:sp>
+      <p:sp>
+        <p:nvSpPr>
+          <p:cNvPr id="65" name="TextBox 64"/>
           <p:cNvSpPr txBox="1"/>
           <p:nvPr/>
         </p:nvSpPr>
         <p:spPr>
           <a:xfrm>
-            <a:off x="6236207" y="4005072"/>
+            <a:off x="6236207" y="4187952"/>
             <a:ext cx="914400" cy="164592"/>
           </a:xfrm>
           <a:prstGeom prst="rect">
@@ -7486,20 +7612,20 @@
                 </a:solidFill>
                 <a:latin typeface="Arial"/>
               </a:rPr>
-              <a:t>93rd</a:t>
-            </a:r>
-          </a:p>
-        </p:txBody>
-      </p:sp>
-      <p:sp>
-        <p:nvSpPr>
-          <p:cNvPr id="63" name="TextBox 62"/>
+              <a:t>¥5.5bn</a:t>
+            </a:r>
+          </a:p>
+        </p:txBody>
+      </p:sp>
+      <p:sp>
+        <p:nvSpPr>
+          <p:cNvPr id="66" name="TextBox 65"/>
           <p:cNvSpPr txBox="1"/>
           <p:nvPr/>
         </p:nvSpPr>
         <p:spPr>
           <a:xfrm>
-            <a:off x="7150607" y="4005072"/>
+            <a:off x="7150607" y="4187952"/>
             <a:ext cx="914400" cy="164592"/>
           </a:xfrm>
           <a:prstGeom prst="rect">
@@ -7528,20 +7654,20 @@
                 </a:solidFill>
                 <a:latin typeface="Arial"/>
               </a:rPr>
-              <a:t>99th</a:t>
+              <a:t>¥10.3bn</a:t>
             </a:r>
           </a:p>
         </p:txBody>
       </p:sp>
       <p:cxnSp>
         <p:nvCxnSpPr>
-          <p:cNvPr id="64" name="Connector 63"/>
+          <p:cNvPr id="67" name="Connector 66"/>
           <p:cNvCxnSpPr/>
           <p:nvPr/>
         </p:nvCxnSpPr>
         <p:spPr>
           <a:xfrm>
-            <a:off x="4133087" y="4151376"/>
+            <a:off x="4133087" y="4334256"/>
             <a:ext cx="3931921" cy="0"/>
           </a:xfrm>
           <a:prstGeom prst="line">
@@ -7570,168 +7696,7 @@
       </p:cxnSp>
       <p:sp>
         <p:nvSpPr>
-          <p:cNvPr id="65" name="TextBox 64"/>
-          <p:cNvSpPr txBox="1"/>
-          <p:nvPr/>
-        </p:nvSpPr>
-        <p:spPr>
-          <a:xfrm>
-            <a:off x="4133087" y="4187952"/>
-            <a:ext cx="2029967" cy="164592"/>
-          </a:xfrm>
-          <a:prstGeom prst="rect">
-            <a:avLst/>
-          </a:prstGeom>
-          <a:noFill/>
-        </p:spPr>
-        <p:txBody>
-          <a:bodyPr wrap="none" lIns="0" rIns="0" tIns="0" bIns="0" anchor="t">
-            <a:spAutoFit/>
-          </a:bodyPr>
-          <a:lstStyle/>
-          <a:p>
-            <a:pPr algn="l">
-              <a:lnSpc>
-                <a:spcPct val="100000"/>
-              </a:lnSpc>
-              <a:spcAft>
-                <a:spcPts val="0"/>
-              </a:spcAft>
-            </a:pPr>
-            <a:r>
-              <a:rPr sz="800" b="0" i="0">
-                <a:solidFill>
-                  <a:srgbClr val="000000"/>
-                </a:solidFill>
-                <a:latin typeface="Arial"/>
-              </a:rPr>
-              <a:t>Notional per ¥1bn back leg</a:t>
-            </a:r>
-          </a:p>
-        </p:txBody>
-      </p:sp>
-      <p:sp>
-        <p:nvSpPr>
-          <p:cNvPr id="66" name="TextBox 65"/>
-          <p:cNvSpPr txBox="1"/>
-          <p:nvPr/>
-        </p:nvSpPr>
-        <p:spPr>
-          <a:xfrm>
-            <a:off x="6236207" y="4187952"/>
-            <a:ext cx="914400" cy="164592"/>
-          </a:xfrm>
-          <a:prstGeom prst="rect">
-            <a:avLst/>
-          </a:prstGeom>
-          <a:noFill/>
-        </p:spPr>
-        <p:txBody>
-          <a:bodyPr wrap="none" lIns="0" rIns="0" tIns="0" bIns="0" anchor="t">
-            <a:spAutoFit/>
-          </a:bodyPr>
-          <a:lstStyle/>
-          <a:p>
-            <a:pPr algn="r">
-              <a:lnSpc>
-                <a:spcPct val="100000"/>
-              </a:lnSpc>
-              <a:spcAft>
-                <a:spcPts val="0"/>
-              </a:spcAft>
-            </a:pPr>
-            <a:r>
-              <a:rPr sz="850" b="1" i="0">
-                <a:solidFill>
-                  <a:srgbClr val="DB0011"/>
-                </a:solidFill>
-                <a:latin typeface="Arial"/>
-              </a:rPr>
-              <a:t>¥5.5bn</a:t>
-            </a:r>
-          </a:p>
-        </p:txBody>
-      </p:sp>
-      <p:sp>
-        <p:nvSpPr>
-          <p:cNvPr id="67" name="TextBox 66"/>
-          <p:cNvSpPr txBox="1"/>
-          <p:nvPr/>
-        </p:nvSpPr>
-        <p:spPr>
-          <a:xfrm>
-            <a:off x="7150607" y="4187952"/>
-            <a:ext cx="914400" cy="164592"/>
-          </a:xfrm>
-          <a:prstGeom prst="rect">
-            <a:avLst/>
-          </a:prstGeom>
-          <a:noFill/>
-        </p:spPr>
-        <p:txBody>
-          <a:bodyPr wrap="none" lIns="0" rIns="0" tIns="0" bIns="0" anchor="t">
-            <a:spAutoFit/>
-          </a:bodyPr>
-          <a:lstStyle/>
-          <a:p>
-            <a:pPr algn="r">
-              <a:lnSpc>
-                <a:spcPct val="100000"/>
-              </a:lnSpc>
-              <a:spcAft>
-                <a:spcPts val="0"/>
-              </a:spcAft>
-            </a:pPr>
-            <a:r>
-              <a:rPr sz="850" b="0" i="0">
-                <a:solidFill>
-                  <a:srgbClr val="767576"/>
-                </a:solidFill>
-                <a:latin typeface="Arial"/>
-              </a:rPr>
-              <a:t>¥10.3bn</a:t>
-            </a:r>
-          </a:p>
-        </p:txBody>
-      </p:sp>
-      <p:cxnSp>
-        <p:nvCxnSpPr>
-          <p:cNvPr id="68" name="Connector 67"/>
-          <p:cNvCxnSpPr/>
-          <p:nvPr/>
-        </p:nvCxnSpPr>
-        <p:spPr>
-          <a:xfrm>
-            <a:off x="4133087" y="4334256"/>
-            <a:ext cx="3931921" cy="0"/>
-          </a:xfrm>
-          <a:prstGeom prst="line">
-            <a:avLst/>
-          </a:prstGeom>
-          <a:ln w="6350">
-            <a:solidFill>
-              <a:srgbClr val="D0CECE"/>
-            </a:solidFill>
-          </a:ln>
-        </p:spPr>
-        <p:style>
-          <a:lnRef idx="2">
-            <a:schemeClr val="accent1"/>
-          </a:lnRef>
-          <a:fillRef idx="0">
-            <a:schemeClr val="accent1"/>
-          </a:fillRef>
-          <a:effectRef idx="1">
-            <a:schemeClr val="accent1"/>
-          </a:effectRef>
-          <a:fontRef idx="minor">
-            <a:schemeClr val="tx1"/>
-          </a:fontRef>
-        </p:style>
-      </p:cxnSp>
-      <p:sp>
-        <p:nvSpPr>
-          <p:cNvPr id="69" name="TextBox 68"/>
+          <p:cNvPr id="68" name="TextBox 67"/>
           <p:cNvSpPr txBox="1"/>
           <p:nvPr/>
         </p:nvSpPr>
@@ -7766,14 +7731,14 @@
                 </a:solidFill>
                 <a:latin typeface="Arial"/>
               </a:rPr>
-              <a:t>17% vs 57%</a:t>
-            </a:r>
-          </a:p>
-        </p:txBody>
-      </p:sp>
-      <p:sp>
-        <p:nvSpPr>
-          <p:cNvPr id="70" name="TextBox 69"/>
+              <a:t>5.1 vs 2.6bp</a:t>
+            </a:r>
+          </a:p>
+        </p:txBody>
+      </p:sp>
+      <p:sp>
+        <p:nvSpPr>
+          <p:cNvPr id="69" name="TextBox 68"/>
           <p:cNvSpPr txBox="1"/>
           <p:nvPr/>
         </p:nvSpPr>
@@ -7808,14 +7773,14 @@
                 </a:solidFill>
                 <a:latin typeface="Arial"/>
               </a:rPr>
-              <a:t>of comparable entries stopped out</a:t>
-            </a:r>
-          </a:p>
-        </p:txBody>
-      </p:sp>
-      <p:sp>
-        <p:nvSpPr>
-          <p:cNvPr id="71" name="TextBox 70"/>
+              <a:t>kept per 10bp the 10-year sells off</a:t>
+            </a:r>
+          </a:p>
+        </p:txBody>
+      </p:sp>
+      <p:sp>
+        <p:nvSpPr>
+          <p:cNvPr id="70" name="TextBox 69"/>
           <p:cNvSpPr txBox="1"/>
           <p:nvPr/>
         </p:nvSpPr>
@@ -7857,7 +7822,7 @@
       </p:sp>
       <p:sp>
         <p:nvSpPr>
-          <p:cNvPr id="72" name="TextBox 71"/>
+          <p:cNvPr id="71" name="TextBox 70"/>
           <p:cNvSpPr txBox="1"/>
           <p:nvPr/>
         </p:nvSpPr>
@@ -7899,7 +7864,7 @@
       </p:sp>
       <p:sp>
         <p:nvSpPr>
-          <p:cNvPr id="73" name="TextBox 72"/>
+          <p:cNvPr id="72" name="TextBox 71"/>
           <p:cNvSpPr txBox="1"/>
           <p:nvPr/>
         </p:nvSpPr>
@@ -7941,7 +7906,7 @@
       </p:sp>
       <p:sp>
         <p:nvSpPr>
-          <p:cNvPr id="74" name="TextBox 73"/>
+          <p:cNvPr id="73" name="TextBox 72"/>
           <p:cNvSpPr txBox="1"/>
           <p:nvPr/>
         </p:nvSpPr>
@@ -7983,7 +7948,7 @@
       </p:sp>
       <p:graphicFrame>
         <p:nvGraphicFramePr>
-          <p:cNvPr id="75" name="Chart 74"/>
+          <p:cNvPr id="74" name="Chart 73"/>
           <p:cNvGraphicFramePr>
             <a:graphicFrameLocks noGrp="1"/>
           </p:cNvGraphicFramePr>
@@ -8001,7 +7966,7 @@
       </p:graphicFrame>
       <p:sp>
         <p:nvSpPr>
-          <p:cNvPr id="76" name="TextBox 75"/>
+          <p:cNvPr id="75" name="TextBox 74"/>
           <p:cNvSpPr txBox="1"/>
           <p:nvPr/>
         </p:nvSpPr>
@@ -8043,7 +8008,7 @@
       </p:sp>
       <p:sp>
         <p:nvSpPr>
-          <p:cNvPr id="77" name="TextBox 76"/>
+          <p:cNvPr id="76" name="TextBox 75"/>
           <p:cNvSpPr txBox="1"/>
           <p:nvPr/>
         </p:nvSpPr>
@@ -8085,7 +8050,7 @@
       </p:sp>
       <p:sp>
         <p:nvSpPr>
-          <p:cNvPr id="78" name="TextBox 77"/>
+          <p:cNvPr id="77" name="TextBox 76"/>
           <p:cNvSpPr txBox="1"/>
           <p:nvPr/>
         </p:nvSpPr>
@@ -8127,7 +8092,7 @@
       </p:sp>
       <p:sp>
         <p:nvSpPr>
-          <p:cNvPr id="79" name="TextBox 78"/>
+          <p:cNvPr id="78" name="TextBox 77"/>
           <p:cNvSpPr txBox="1"/>
           <p:nvPr/>
         </p:nvSpPr>
@@ -8169,7 +8134,7 @@
       </p:sp>
       <p:sp>
         <p:nvSpPr>
-          <p:cNvPr id="80" name="TextBox 79"/>
+          <p:cNvPr id="79" name="TextBox 78"/>
           <p:cNvSpPr txBox="1"/>
           <p:nvPr/>
         </p:nvSpPr>
@@ -8211,7 +8176,7 @@
       </p:sp>
       <p:graphicFrame>
         <p:nvGraphicFramePr>
-          <p:cNvPr id="81" name="Table 80"/>
+          <p:cNvPr id="80" name="Table 79"/>
           <p:cNvGraphicFramePr>
             <a:graphicFrameLocks noGrp="1"/>
           </p:cNvGraphicFramePr>
@@ -8713,7 +8678,7 @@
       </p:graphicFrame>
       <p:sp>
         <p:nvSpPr>
-          <p:cNvPr id="82" name="TextBox 81"/>
+          <p:cNvPr id="81" name="TextBox 80"/>
           <p:cNvSpPr txBox="1"/>
           <p:nvPr/>
         </p:nvSpPr>
@@ -8755,7 +8720,7 @@
       </p:sp>
       <p:sp>
         <p:nvSpPr>
-          <p:cNvPr id="83" name="TextBox 82"/>
+          <p:cNvPr id="82" name="TextBox 81"/>
           <p:cNvSpPr txBox="1"/>
           <p:nvPr/>
         </p:nvSpPr>

</xml_diff>